<commit_message>
Support in Development and Docker environment connecting to Postgres database
</commit_message>
<xml_diff>
--- a/Documentations/SysArchitecture.pptx
+++ b/Documentations/SysArchitecture.pptx
@@ -266,7 +266,7 @@
           <a:p>
             <a:fld id="{8377380A-1819-462E-96FD-3D6CBD777CA0}" type="datetimeFigureOut">
               <a:rPr lang="en-IL" smtClean="0"/>
-              <a:t>09/08/2025</a:t>
+              <a:t>14/08/2025</a:t>
             </a:fld>
             <a:endParaRPr lang="en-IL"/>
           </a:p>
@@ -466,7 +466,7 @@
           <a:p>
             <a:fld id="{8377380A-1819-462E-96FD-3D6CBD777CA0}" type="datetimeFigureOut">
               <a:rPr lang="en-IL" smtClean="0"/>
-              <a:t>09/08/2025</a:t>
+              <a:t>14/08/2025</a:t>
             </a:fld>
             <a:endParaRPr lang="en-IL"/>
           </a:p>
@@ -676,7 +676,7 @@
           <a:p>
             <a:fld id="{8377380A-1819-462E-96FD-3D6CBD777CA0}" type="datetimeFigureOut">
               <a:rPr lang="en-IL" smtClean="0"/>
-              <a:t>09/08/2025</a:t>
+              <a:t>14/08/2025</a:t>
             </a:fld>
             <a:endParaRPr lang="en-IL"/>
           </a:p>
@@ -876,7 +876,7 @@
           <a:p>
             <a:fld id="{8377380A-1819-462E-96FD-3D6CBD777CA0}" type="datetimeFigureOut">
               <a:rPr lang="en-IL" smtClean="0"/>
-              <a:t>09/08/2025</a:t>
+              <a:t>14/08/2025</a:t>
             </a:fld>
             <a:endParaRPr lang="en-IL"/>
           </a:p>
@@ -1152,7 +1152,7 @@
           <a:p>
             <a:fld id="{8377380A-1819-462E-96FD-3D6CBD777CA0}" type="datetimeFigureOut">
               <a:rPr lang="en-IL" smtClean="0"/>
-              <a:t>09/08/2025</a:t>
+              <a:t>14/08/2025</a:t>
             </a:fld>
             <a:endParaRPr lang="en-IL"/>
           </a:p>
@@ -1420,7 +1420,7 @@
           <a:p>
             <a:fld id="{8377380A-1819-462E-96FD-3D6CBD777CA0}" type="datetimeFigureOut">
               <a:rPr lang="en-IL" smtClean="0"/>
-              <a:t>09/08/2025</a:t>
+              <a:t>14/08/2025</a:t>
             </a:fld>
             <a:endParaRPr lang="en-IL"/>
           </a:p>
@@ -1835,7 +1835,7 @@
           <a:p>
             <a:fld id="{8377380A-1819-462E-96FD-3D6CBD777CA0}" type="datetimeFigureOut">
               <a:rPr lang="en-IL" smtClean="0"/>
-              <a:t>09/08/2025</a:t>
+              <a:t>14/08/2025</a:t>
             </a:fld>
             <a:endParaRPr lang="en-IL"/>
           </a:p>
@@ -1977,7 +1977,7 @@
           <a:p>
             <a:fld id="{8377380A-1819-462E-96FD-3D6CBD777CA0}" type="datetimeFigureOut">
               <a:rPr lang="en-IL" smtClean="0"/>
-              <a:t>09/08/2025</a:t>
+              <a:t>14/08/2025</a:t>
             </a:fld>
             <a:endParaRPr lang="en-IL"/>
           </a:p>
@@ -2090,7 +2090,7 @@
           <a:p>
             <a:fld id="{8377380A-1819-462E-96FD-3D6CBD777CA0}" type="datetimeFigureOut">
               <a:rPr lang="en-IL" smtClean="0"/>
-              <a:t>09/08/2025</a:t>
+              <a:t>14/08/2025</a:t>
             </a:fld>
             <a:endParaRPr lang="en-IL"/>
           </a:p>
@@ -2403,7 +2403,7 @@
           <a:p>
             <a:fld id="{8377380A-1819-462E-96FD-3D6CBD777CA0}" type="datetimeFigureOut">
               <a:rPr lang="en-IL" smtClean="0"/>
-              <a:t>09/08/2025</a:t>
+              <a:t>14/08/2025</a:t>
             </a:fld>
             <a:endParaRPr lang="en-IL"/>
           </a:p>
@@ -2692,7 +2692,7 @@
           <a:p>
             <a:fld id="{8377380A-1819-462E-96FD-3D6CBD777CA0}" type="datetimeFigureOut">
               <a:rPr lang="en-IL" smtClean="0"/>
-              <a:t>09/08/2025</a:t>
+              <a:t>14/08/2025</a:t>
             </a:fld>
             <a:endParaRPr lang="en-IL"/>
           </a:p>
@@ -2935,7 +2935,7 @@
           <a:p>
             <a:fld id="{8377380A-1819-462E-96FD-3D6CBD777CA0}" type="datetimeFigureOut">
               <a:rPr lang="en-IL" smtClean="0"/>
-              <a:t>09/08/2025</a:t>
+              <a:t>14/08/2025</a:t>
             </a:fld>
             <a:endParaRPr lang="en-IL"/>
           </a:p>
@@ -11468,8 +11468,8 @@
         </p:nvGrpSpPr>
         <p:grpSpPr>
           <a:xfrm>
-            <a:off x="244438" y="566996"/>
-            <a:ext cx="2732855" cy="1693316"/>
+            <a:off x="950614" y="876860"/>
+            <a:ext cx="2031057" cy="1693316"/>
             <a:chOff x="2037028" y="1176951"/>
             <a:chExt cx="3108185" cy="2252047"/>
           </a:xfrm>
@@ -11707,376 +11707,6 @@
           </p:txBody>
         </p:sp>
       </p:grpSp>
-      <p:grpSp>
-        <p:nvGrpSpPr>
-          <p:cNvPr id="20" name="Group 19">
-            <a:extLst>
-              <a:ext uri="{FF2B5EF4-FFF2-40B4-BE49-F238E27FC236}">
-                <a16:creationId xmlns:a16="http://schemas.microsoft.com/office/drawing/2014/main" id="{BE573448-C636-3802-CA73-D3B35B47CE11}"/>
-              </a:ext>
-            </a:extLst>
-          </p:cNvPr>
-          <p:cNvGrpSpPr/>
-          <p:nvPr/>
-        </p:nvGrpSpPr>
-        <p:grpSpPr>
-          <a:xfrm>
-            <a:off x="4761816" y="911400"/>
-            <a:ext cx="2900756" cy="1518442"/>
-            <a:chOff x="2037029" y="1176950"/>
-            <a:chExt cx="2136619" cy="3911097"/>
-          </a:xfrm>
-        </p:grpSpPr>
-        <p:sp>
-          <p:nvSpPr>
-            <p:cNvPr id="21" name="Rectangle 20">
-              <a:extLst>
-                <a:ext uri="{FF2B5EF4-FFF2-40B4-BE49-F238E27FC236}">
-                  <a16:creationId xmlns:a16="http://schemas.microsoft.com/office/drawing/2014/main" id="{364D5F93-7406-7B24-3361-3D6D0AB0EDAD}"/>
-                </a:ext>
-              </a:extLst>
-            </p:cNvPr>
-            <p:cNvSpPr/>
-            <p:nvPr/>
-          </p:nvSpPr>
-          <p:spPr>
-            <a:xfrm>
-              <a:off x="2037030" y="1176950"/>
-              <a:ext cx="2136618" cy="743255"/>
-            </a:xfrm>
-            <a:prstGeom prst="rect">
-              <a:avLst/>
-            </a:prstGeom>
-          </p:spPr>
-          <p:style>
-            <a:lnRef idx="2">
-              <a:schemeClr val="accent4">
-                <a:shade val="15000"/>
-              </a:schemeClr>
-            </a:lnRef>
-            <a:fillRef idx="1">
-              <a:schemeClr val="accent4"/>
-            </a:fillRef>
-            <a:effectRef idx="0">
-              <a:schemeClr val="accent4"/>
-            </a:effectRef>
-            <a:fontRef idx="minor">
-              <a:schemeClr val="lt1"/>
-            </a:fontRef>
-          </p:style>
-          <p:txBody>
-            <a:bodyPr rtlCol="0" anchor="ctr"/>
-            <a:lstStyle/>
-            <a:p>
-              <a:pPr algn="ctr"/>
-              <a:r>
-                <a:rPr lang="en-US" sz="1200" dirty="0"/>
-                <a:t>Phone</a:t>
-              </a:r>
-              <a:endParaRPr lang="en-IL" sz="1200" dirty="0"/>
-            </a:p>
-          </p:txBody>
-        </p:sp>
-        <p:sp>
-          <p:nvSpPr>
-            <p:cNvPr id="22" name="Rectangle 21">
-              <a:extLst>
-                <a:ext uri="{FF2B5EF4-FFF2-40B4-BE49-F238E27FC236}">
-                  <a16:creationId xmlns:a16="http://schemas.microsoft.com/office/drawing/2014/main" id="{699912BD-6A1C-309E-5ECA-E69FDA719701}"/>
-                </a:ext>
-              </a:extLst>
-            </p:cNvPr>
-            <p:cNvSpPr/>
-            <p:nvPr/>
-          </p:nvSpPr>
-          <p:spPr>
-            <a:xfrm>
-              <a:off x="2037029" y="1920205"/>
-              <a:ext cx="2136618" cy="3167842"/>
-            </a:xfrm>
-            <a:prstGeom prst="rect">
-              <a:avLst/>
-            </a:prstGeom>
-            <a:noFill/>
-          </p:spPr>
-          <p:style>
-            <a:lnRef idx="2">
-              <a:schemeClr val="accent1">
-                <a:shade val="15000"/>
-              </a:schemeClr>
-            </a:lnRef>
-            <a:fillRef idx="1">
-              <a:schemeClr val="accent1"/>
-            </a:fillRef>
-            <a:effectRef idx="0">
-              <a:schemeClr val="accent1"/>
-            </a:effectRef>
-            <a:fontRef idx="minor">
-              <a:schemeClr val="lt1"/>
-            </a:fontRef>
-          </p:style>
-          <p:txBody>
-            <a:bodyPr rtlCol="0" anchor="t"/>
-            <a:lstStyle/>
-            <a:p>
-              <a:r>
-                <a:rPr lang="en-US" sz="1200" b="1" dirty="0" err="1">
-                  <a:solidFill>
-                    <a:schemeClr val="tx1"/>
-                  </a:solidFill>
-                </a:rPr>
-                <a:t>Phone_Id</a:t>
-              </a:r>
-              <a:r>
-                <a:rPr lang="en-US" sz="1200" dirty="0">
-                  <a:solidFill>
-                    <a:schemeClr val="tx1"/>
-                  </a:solidFill>
-                </a:rPr>
-                <a:t> : int</a:t>
-              </a:r>
-            </a:p>
-            <a:p>
-              <a:r>
-                <a:rPr lang="en-US" sz="1200" dirty="0" err="1">
-                  <a:solidFill>
-                    <a:schemeClr val="tx1"/>
-                  </a:solidFill>
-                </a:rPr>
-                <a:t>User_Id</a:t>
-              </a:r>
-              <a:r>
-                <a:rPr lang="en-US" sz="1200" dirty="0">
-                  <a:solidFill>
-                    <a:schemeClr val="tx1"/>
-                  </a:solidFill>
-                </a:rPr>
-                <a:t> (FK) : int</a:t>
-              </a:r>
-            </a:p>
-            <a:p>
-              <a:r>
-                <a:rPr lang="en-US" sz="1200" dirty="0" err="1">
-                  <a:solidFill>
-                    <a:schemeClr val="tx1"/>
-                  </a:solidFill>
-                </a:rPr>
-                <a:t>Phone_Type</a:t>
-              </a:r>
-              <a:r>
-                <a:rPr lang="en-US" sz="1200" dirty="0">
-                  <a:solidFill>
-                    <a:schemeClr val="tx1"/>
-                  </a:solidFill>
-                </a:rPr>
-                <a:t> : </a:t>
-              </a:r>
-              <a:r>
-                <a:rPr lang="en-US" sz="1200" dirty="0" err="1">
-                  <a:solidFill>
-                    <a:schemeClr val="tx1"/>
-                  </a:solidFill>
-                </a:rPr>
-                <a:t>enum</a:t>
-              </a:r>
-              <a:r>
-                <a:rPr lang="en-US" sz="1200" dirty="0">
-                  <a:solidFill>
-                    <a:schemeClr val="tx1"/>
-                  </a:solidFill>
-                </a:rPr>
-                <a:t>(Office, Mobile, Fax)</a:t>
-              </a:r>
-            </a:p>
-            <a:p>
-              <a:r>
-                <a:rPr lang="en-US" sz="1200" dirty="0" err="1">
-                  <a:solidFill>
-                    <a:schemeClr val="tx1"/>
-                  </a:solidFill>
-                </a:rPr>
-                <a:t>Phone_Number</a:t>
-              </a:r>
-              <a:r>
-                <a:rPr lang="en-US" sz="1200" dirty="0">
-                  <a:solidFill>
-                    <a:schemeClr val="tx1"/>
-                  </a:solidFill>
-                </a:rPr>
-                <a:t> : string</a:t>
-              </a:r>
-            </a:p>
-            <a:p>
-              <a:r>
-                <a:rPr lang="en-US" sz="1200" dirty="0" err="1">
-                  <a:solidFill>
-                    <a:schemeClr val="tx1"/>
-                  </a:solidFill>
-                </a:rPr>
-                <a:t>Country_Code</a:t>
-              </a:r>
-              <a:r>
-                <a:rPr lang="en-US" sz="1200" dirty="0">
-                  <a:solidFill>
-                    <a:schemeClr val="tx1"/>
-                  </a:solidFill>
-                </a:rPr>
-                <a:t> : string</a:t>
-              </a:r>
-            </a:p>
-            <a:p>
-              <a:r>
-                <a:rPr lang="en-US" sz="1200" dirty="0" err="1">
-                  <a:solidFill>
-                    <a:schemeClr val="tx1"/>
-                  </a:solidFill>
-                </a:rPr>
-                <a:t>Is_Primary</a:t>
-              </a:r>
-              <a:r>
-                <a:rPr lang="en-US" sz="1200" dirty="0">
-                  <a:solidFill>
-                    <a:schemeClr val="tx1"/>
-                  </a:solidFill>
-                </a:rPr>
-                <a:t> : bool</a:t>
-              </a:r>
-            </a:p>
-            <a:p>
-              <a:endParaRPr lang="en-US" sz="1200" dirty="0">
-                <a:solidFill>
-                  <a:schemeClr val="tx1"/>
-                </a:solidFill>
-              </a:endParaRPr>
-            </a:p>
-            <a:p>
-              <a:endParaRPr lang="en-IL" sz="1200" dirty="0"/>
-            </a:p>
-          </p:txBody>
-        </p:sp>
-      </p:grpSp>
-      <p:grpSp>
-        <p:nvGrpSpPr>
-          <p:cNvPr id="26" name="Group 25">
-            <a:extLst>
-              <a:ext uri="{FF2B5EF4-FFF2-40B4-BE49-F238E27FC236}">
-                <a16:creationId xmlns:a16="http://schemas.microsoft.com/office/drawing/2014/main" id="{2DE970F0-C183-25A1-6216-C454ED20313F}"/>
-              </a:ext>
-            </a:extLst>
-          </p:cNvPr>
-          <p:cNvGrpSpPr/>
-          <p:nvPr/>
-        </p:nvGrpSpPr>
-        <p:grpSpPr>
-          <a:xfrm>
-            <a:off x="2998319" y="1071698"/>
-            <a:ext cx="1943551" cy="344032"/>
-            <a:chOff x="4173647" y="2200743"/>
-            <a:chExt cx="2219785" cy="344032"/>
-          </a:xfrm>
-        </p:grpSpPr>
-        <p:sp>
-          <p:nvSpPr>
-            <p:cNvPr id="27" name="Rectangle 26">
-              <a:extLst>
-                <a:ext uri="{FF2B5EF4-FFF2-40B4-BE49-F238E27FC236}">
-                  <a16:creationId xmlns:a16="http://schemas.microsoft.com/office/drawing/2014/main" id="{84DBC245-4011-3661-9C7B-CFEBAE049002}"/>
-                </a:ext>
-              </a:extLst>
-            </p:cNvPr>
-            <p:cNvSpPr/>
-            <p:nvPr/>
-          </p:nvSpPr>
-          <p:spPr>
-            <a:xfrm>
-              <a:off x="5524299" y="2200743"/>
-              <a:ext cx="869133" cy="344032"/>
-            </a:xfrm>
-            <a:prstGeom prst="rect">
-              <a:avLst/>
-            </a:prstGeom>
-            <a:noFill/>
-            <a:ln>
-              <a:noFill/>
-            </a:ln>
-          </p:spPr>
-          <p:style>
-            <a:lnRef idx="2">
-              <a:schemeClr val="accent1">
-                <a:shade val="15000"/>
-              </a:schemeClr>
-            </a:lnRef>
-            <a:fillRef idx="1">
-              <a:schemeClr val="accent1"/>
-            </a:fillRef>
-            <a:effectRef idx="0">
-              <a:schemeClr val="accent1"/>
-            </a:effectRef>
-            <a:fontRef idx="minor">
-              <a:schemeClr val="lt1"/>
-            </a:fontRef>
-          </p:style>
-          <p:txBody>
-            <a:bodyPr rtlCol="0" anchor="ctr"/>
-            <a:lstStyle/>
-            <a:p>
-              <a:pPr algn="ctr"/>
-              <a:r>
-                <a:rPr lang="en-US" sz="1000" dirty="0">
-                  <a:solidFill>
-                    <a:schemeClr val="tx1"/>
-                  </a:solidFill>
-                </a:rPr>
-                <a:t>1:N</a:t>
-              </a:r>
-              <a:endParaRPr lang="en-IL" sz="1000" dirty="0">
-                <a:solidFill>
-                  <a:schemeClr val="tx1"/>
-                </a:solidFill>
-              </a:endParaRPr>
-            </a:p>
-          </p:txBody>
-        </p:sp>
-        <p:cxnSp>
-          <p:nvCxnSpPr>
-            <p:cNvPr id="28" name="Straight Arrow Connector 27">
-              <a:extLst>
-                <a:ext uri="{FF2B5EF4-FFF2-40B4-BE49-F238E27FC236}">
-                  <a16:creationId xmlns:a16="http://schemas.microsoft.com/office/drawing/2014/main" id="{73E6D519-B162-2DBE-088E-94D236CA79CE}"/>
-                </a:ext>
-              </a:extLst>
-            </p:cNvPr>
-            <p:cNvCxnSpPr/>
-            <p:nvPr/>
-          </p:nvCxnSpPr>
-          <p:spPr>
-            <a:xfrm>
-              <a:off x="4173647" y="2489707"/>
-              <a:ext cx="2008358" cy="0"/>
-            </a:xfrm>
-            <a:prstGeom prst="straightConnector1">
-              <a:avLst/>
-            </a:prstGeom>
-            <a:ln>
-              <a:tailEnd type="triangle"/>
-            </a:ln>
-          </p:spPr>
-          <p:style>
-            <a:lnRef idx="2">
-              <a:schemeClr val="accent1"/>
-            </a:lnRef>
-            <a:fillRef idx="0">
-              <a:schemeClr val="accent1"/>
-            </a:fillRef>
-            <a:effectRef idx="1">
-              <a:schemeClr val="accent1"/>
-            </a:effectRef>
-            <a:fontRef idx="minor">
-              <a:schemeClr val="tx1"/>
-            </a:fontRef>
-          </p:style>
-        </p:cxnSp>
-      </p:grpSp>
       <p:sp>
         <p:nvSpPr>
           <p:cNvPr id="35" name="Rectangle 34">
@@ -12147,8 +11777,8 @@
         </p:nvGrpSpPr>
         <p:grpSpPr>
           <a:xfrm>
-            <a:off x="4756752" y="2630391"/>
-            <a:ext cx="3822169" cy="1567554"/>
+            <a:off x="4040566" y="2645223"/>
+            <a:ext cx="2732853" cy="1567554"/>
             <a:chOff x="2029809" y="1176950"/>
             <a:chExt cx="2136619" cy="3410260"/>
           </a:xfrm>
@@ -12388,8 +12018,8 @@
         </p:nvSpPr>
         <p:spPr>
           <a:xfrm>
-            <a:off x="4180893" y="2977998"/>
-            <a:ext cx="712858" cy="280774"/>
+            <a:off x="3592420" y="3323922"/>
+            <a:ext cx="391107" cy="280774"/>
           </a:xfrm>
           <a:prstGeom prst="rect">
             <a:avLst/>
@@ -12447,17 +12077,19 @@
           </p:cNvPr>
           <p:cNvCxnSpPr>
             <a:cxnSpLocks/>
-            <a:stCxn id="3" idx="2"/>
+            <a:endCxn id="72" idx="1"/>
           </p:cNvCxnSpPr>
           <p:nvPr/>
         </p:nvCxnSpPr>
         <p:spPr>
-          <a:xfrm rot="16200000" flipH="1">
-            <a:off x="2684579" y="1186599"/>
-            <a:ext cx="998460" cy="3145886"/>
+          <a:xfrm>
+            <a:off x="2156266" y="2570176"/>
+            <a:ext cx="1884301" cy="1035271"/>
           </a:xfrm>
-          <a:prstGeom prst="bentConnector2">
-            <a:avLst/>
+          <a:prstGeom prst="bentConnector3">
+            <a:avLst>
+              <a:gd name="adj1" fmla="val 50000"/>
+            </a:avLst>
           </a:prstGeom>
           <a:ln>
             <a:tailEnd type="triangle"/>
@@ -12492,7 +12124,7 @@
         </p:nvGrpSpPr>
         <p:grpSpPr>
           <a:xfrm>
-            <a:off x="2297557" y="4650680"/>
+            <a:off x="3915010" y="1180507"/>
             <a:ext cx="2732855" cy="915347"/>
             <a:chOff x="2037028" y="1176951"/>
             <a:chExt cx="3108185" cy="2252047"/>
@@ -12703,130 +12335,9 @@
                 </a:solidFill>
               </a:endParaRPr>
             </a:p>
-            <a:p>
-              <a:endParaRPr lang="en-US" sz="1200" dirty="0">
-                <a:solidFill>
-                  <a:schemeClr val="tx1"/>
-                </a:solidFill>
-              </a:endParaRPr>
-            </a:p>
-            <a:p>
-              <a:endParaRPr lang="en-US" sz="1200" dirty="0">
-                <a:solidFill>
-                  <a:schemeClr val="tx1"/>
-                </a:solidFill>
-              </a:endParaRPr>
-            </a:p>
-            <a:p>
-              <a:endParaRPr lang="en-IL" sz="1200" dirty="0"/>
-            </a:p>
           </p:txBody>
         </p:sp>
       </p:grpSp>
-      <p:cxnSp>
-        <p:nvCxnSpPr>
-          <p:cNvPr id="24" name="Connector: Elbow 23">
-            <a:extLst>
-              <a:ext uri="{FF2B5EF4-FFF2-40B4-BE49-F238E27FC236}">
-                <a16:creationId xmlns:a16="http://schemas.microsoft.com/office/drawing/2014/main" id="{58A371E0-7D2B-9A05-02C8-25EAB0C14055}"/>
-              </a:ext>
-            </a:extLst>
-          </p:cNvPr>
-          <p:cNvCxnSpPr>
-            <a:cxnSpLocks/>
-            <a:endCxn id="17" idx="1"/>
-          </p:cNvCxnSpPr>
-          <p:nvPr/>
-        </p:nvCxnSpPr>
-        <p:spPr>
-          <a:xfrm rot="16200000" flipH="1">
-            <a:off x="16691" y="2983357"/>
-            <a:ext cx="3003914" cy="1557818"/>
-          </a:xfrm>
-          <a:prstGeom prst="bentConnector2">
-            <a:avLst/>
-          </a:prstGeom>
-          <a:ln>
-            <a:tailEnd type="triangle"/>
-          </a:ln>
-        </p:spPr>
-        <p:style>
-          <a:lnRef idx="2">
-            <a:schemeClr val="accent1"/>
-          </a:lnRef>
-          <a:fillRef idx="0">
-            <a:schemeClr val="accent1"/>
-          </a:fillRef>
-          <a:effectRef idx="1">
-            <a:schemeClr val="accent1"/>
-          </a:effectRef>
-          <a:fontRef idx="minor">
-            <a:schemeClr val="tx1"/>
-          </a:fontRef>
-        </p:style>
-      </p:cxnSp>
-      <p:sp>
-        <p:nvSpPr>
-          <p:cNvPr id="25" name="Rectangle 24">
-            <a:extLst>
-              <a:ext uri="{FF2B5EF4-FFF2-40B4-BE49-F238E27FC236}">
-                <a16:creationId xmlns:a16="http://schemas.microsoft.com/office/drawing/2014/main" id="{1049D720-5E23-9ECB-0085-9B8DB5FBEB86}"/>
-              </a:ext>
-            </a:extLst>
-          </p:cNvPr>
-          <p:cNvSpPr/>
-          <p:nvPr/>
-        </p:nvSpPr>
-        <p:spPr>
-          <a:xfrm>
-            <a:off x="1723880" y="5027461"/>
-            <a:ext cx="712858" cy="280774"/>
-          </a:xfrm>
-          <a:prstGeom prst="rect">
-            <a:avLst/>
-          </a:prstGeom>
-          <a:noFill/>
-          <a:ln>
-            <a:noFill/>
-          </a:ln>
-        </p:spPr>
-        <p:style>
-          <a:lnRef idx="2">
-            <a:schemeClr val="accent1">
-              <a:shade val="15000"/>
-            </a:schemeClr>
-          </a:lnRef>
-          <a:fillRef idx="1">
-            <a:schemeClr val="accent1"/>
-          </a:fillRef>
-          <a:effectRef idx="0">
-            <a:schemeClr val="accent1"/>
-          </a:effectRef>
-          <a:fontRef idx="minor">
-            <a:schemeClr val="lt1"/>
-          </a:fontRef>
-        </p:style>
-        <p:txBody>
-          <a:bodyPr rtlCol="0" anchor="ctr"/>
-          <a:lstStyle/>
-          <a:p>
-            <a:pPr algn="ctr"/>
-            <a:r>
-              <a:rPr lang="en-US" sz="1000" dirty="0">
-                <a:solidFill>
-                  <a:schemeClr val="tx1"/>
-                </a:solidFill>
-              </a:rPr>
-              <a:t>1:1</a:t>
-            </a:r>
-            <a:endParaRPr lang="en-IL" sz="1000" dirty="0">
-              <a:solidFill>
-                <a:schemeClr val="tx1"/>
-              </a:solidFill>
-            </a:endParaRPr>
-          </a:p>
-        </p:txBody>
-      </p:sp>
       <p:grpSp>
         <p:nvGrpSpPr>
           <p:cNvPr id="33" name="Group 32">
@@ -12841,8 +12352,8 @@
         </p:nvGrpSpPr>
         <p:grpSpPr>
           <a:xfrm>
-            <a:off x="7515116" y="4742692"/>
-            <a:ext cx="3642619" cy="1319062"/>
+            <a:off x="7676068" y="2821669"/>
+            <a:ext cx="3477808" cy="1319062"/>
             <a:chOff x="2037028" y="1176951"/>
             <a:chExt cx="3108185" cy="2030619"/>
           </a:xfrm>
@@ -13084,26 +12595,24 @@
       </p:grpSp>
       <p:cxnSp>
         <p:nvCxnSpPr>
-          <p:cNvPr id="38" name="Connector: Elbow 37">
-            <a:extLst>
-              <a:ext uri="{FF2B5EF4-FFF2-40B4-BE49-F238E27FC236}">
-                <a16:creationId xmlns:a16="http://schemas.microsoft.com/office/drawing/2014/main" id="{787A013B-B0C3-BB43-BBDC-D7D3CFA18BF8}"/>
+          <p:cNvPr id="5" name="Straight Arrow Connector 4">
+            <a:extLst>
+              <a:ext uri="{FF2B5EF4-FFF2-40B4-BE49-F238E27FC236}">
+                <a16:creationId xmlns:a16="http://schemas.microsoft.com/office/drawing/2014/main" id="{87A80F61-BCF6-C798-3F07-5C6AE73CB2F5}"/>
               </a:ext>
             </a:extLst>
           </p:cNvPr>
           <p:cNvCxnSpPr>
             <a:cxnSpLocks/>
-            <a:stCxn id="72" idx="2"/>
-            <a:endCxn id="36" idx="1"/>
           </p:cNvCxnSpPr>
           <p:nvPr/>
         </p:nvCxnSpPr>
         <p:spPr>
-          <a:xfrm rot="16200000" flipH="1">
-            <a:off x="6407314" y="4458469"/>
-            <a:ext cx="1368326" cy="847278"/>
+          <a:xfrm flipV="1">
+            <a:off x="2981670" y="1722787"/>
+            <a:ext cx="930377" cy="731"/>
           </a:xfrm>
-          <a:prstGeom prst="bentConnector2">
+          <a:prstGeom prst="straightConnector1">
             <a:avLst/>
           </a:prstGeom>
           <a:ln>
@@ -13127,10 +12636,10 @@
       </p:cxnSp>
       <p:sp>
         <p:nvSpPr>
-          <p:cNvPr id="39" name="Rectangle 38">
-            <a:extLst>
-              <a:ext uri="{FF2B5EF4-FFF2-40B4-BE49-F238E27FC236}">
-                <a16:creationId xmlns:a16="http://schemas.microsoft.com/office/drawing/2014/main" id="{FFC090D4-1F5A-6BD9-182C-B709FDCDE36D}"/>
+          <p:cNvPr id="8" name="Rectangle 7">
+            <a:extLst>
+              <a:ext uri="{FF2B5EF4-FFF2-40B4-BE49-F238E27FC236}">
+                <a16:creationId xmlns:a16="http://schemas.microsoft.com/office/drawing/2014/main" id="{1049D720-5E23-9ECB-0085-9B8DB5FBEB86}"/>
               </a:ext>
             </a:extLst>
           </p:cNvPr>
@@ -13139,8 +12648,8 @@
         </p:nvSpPr>
         <p:spPr>
           <a:xfrm>
-            <a:off x="6962000" y="5138765"/>
-            <a:ext cx="712858" cy="280774"/>
+            <a:off x="3447951" y="1442013"/>
+            <a:ext cx="458005" cy="280774"/>
           </a:xfrm>
           <a:prstGeom prst="rect">
             <a:avLst/>
@@ -13177,7 +12686,110 @@
                   <a:schemeClr val="tx1"/>
                 </a:solidFill>
               </a:rPr>
-              <a:t>1:1</a:t>
+              <a:t>1:N</a:t>
+            </a:r>
+            <a:endParaRPr lang="en-IL" sz="1000" dirty="0">
+              <a:solidFill>
+                <a:schemeClr val="tx1"/>
+              </a:solidFill>
+            </a:endParaRPr>
+          </a:p>
+        </p:txBody>
+      </p:sp>
+      <p:cxnSp>
+        <p:nvCxnSpPr>
+          <p:cNvPr id="10" name="Straight Arrow Connector 9">
+            <a:extLst>
+              <a:ext uri="{FF2B5EF4-FFF2-40B4-BE49-F238E27FC236}">
+                <a16:creationId xmlns:a16="http://schemas.microsoft.com/office/drawing/2014/main" id="{F0EC6AC8-2264-2579-F9A2-C0806CFDBCBF}"/>
+              </a:ext>
+            </a:extLst>
+          </p:cNvPr>
+          <p:cNvCxnSpPr>
+            <a:cxnSpLocks/>
+          </p:cNvCxnSpPr>
+          <p:nvPr/>
+        </p:nvCxnSpPr>
+        <p:spPr>
+          <a:xfrm flipV="1">
+            <a:off x="6746419" y="3559135"/>
+            <a:ext cx="930377" cy="731"/>
+          </a:xfrm>
+          <a:prstGeom prst="straightConnector1">
+            <a:avLst/>
+          </a:prstGeom>
+          <a:ln>
+            <a:tailEnd type="triangle"/>
+          </a:ln>
+        </p:spPr>
+        <p:style>
+          <a:lnRef idx="2">
+            <a:schemeClr val="accent1"/>
+          </a:lnRef>
+          <a:fillRef idx="0">
+            <a:schemeClr val="accent1"/>
+          </a:fillRef>
+          <a:effectRef idx="1">
+            <a:schemeClr val="accent1"/>
+          </a:effectRef>
+          <a:fontRef idx="minor">
+            <a:schemeClr val="tx1"/>
+          </a:fontRef>
+        </p:style>
+      </p:cxnSp>
+      <p:sp>
+        <p:nvSpPr>
+          <p:cNvPr id="11" name="Rectangle 10">
+            <a:extLst>
+              <a:ext uri="{FF2B5EF4-FFF2-40B4-BE49-F238E27FC236}">
+                <a16:creationId xmlns:a16="http://schemas.microsoft.com/office/drawing/2014/main" id="{D4435BEA-6437-E00D-577F-23D7D5718537}"/>
+              </a:ext>
+            </a:extLst>
+          </p:cNvPr>
+          <p:cNvSpPr/>
+          <p:nvPr/>
+        </p:nvSpPr>
+        <p:spPr>
+          <a:xfrm>
+            <a:off x="7230806" y="3278361"/>
+            <a:ext cx="458005" cy="280774"/>
+          </a:xfrm>
+          <a:prstGeom prst="rect">
+            <a:avLst/>
+          </a:prstGeom>
+          <a:noFill/>
+          <a:ln>
+            <a:noFill/>
+          </a:ln>
+        </p:spPr>
+        <p:style>
+          <a:lnRef idx="2">
+            <a:schemeClr val="accent1">
+              <a:shade val="15000"/>
+            </a:schemeClr>
+          </a:lnRef>
+          <a:fillRef idx="1">
+            <a:schemeClr val="accent1"/>
+          </a:fillRef>
+          <a:effectRef idx="0">
+            <a:schemeClr val="accent1"/>
+          </a:effectRef>
+          <a:fontRef idx="minor">
+            <a:schemeClr val="lt1"/>
+          </a:fontRef>
+        </p:style>
+        <p:txBody>
+          <a:bodyPr rtlCol="0" anchor="ctr"/>
+          <a:lstStyle/>
+          <a:p>
+            <a:pPr algn="ctr"/>
+            <a:r>
+              <a:rPr lang="en-US" sz="1000" dirty="0">
+                <a:solidFill>
+                  <a:schemeClr val="tx1"/>
+                </a:solidFill>
+              </a:rPr>
+              <a:t>1:N</a:t>
             </a:r>
             <a:endParaRPr lang="en-IL" sz="1000" dirty="0">
               <a:solidFill>

</xml_diff>

<commit_message>
commiting documents from GILE-N1
</commit_message>
<xml_diff>
--- a/Documentations/SysArchitecture.pptx
+++ b/Documentations/SysArchitecture.pptx
@@ -10,7 +10,8 @@
     <p:sldId id="261" r:id="rId4"/>
     <p:sldId id="262" r:id="rId5"/>
     <p:sldId id="264" r:id="rId6"/>
-    <p:sldId id="265" r:id="rId7"/>
+    <p:sldId id="267" r:id="rId7"/>
+    <p:sldId id="265" r:id="rId8"/>
   </p:sldIdLst>
   <p:sldSz cx="12192000" cy="6858000"/>
   <p:notesSz cx="6858000" cy="9144000"/>
@@ -12077,19 +12078,18 @@
           </p:cNvPr>
           <p:cNvCxnSpPr>
             <a:cxnSpLocks/>
+            <a:stCxn id="3" idx="2"/>
             <a:endCxn id="72" idx="1"/>
           </p:cNvCxnSpPr>
           <p:nvPr/>
         </p:nvCxnSpPr>
         <p:spPr>
-          <a:xfrm>
-            <a:off x="2156266" y="2570176"/>
-            <a:ext cx="1884301" cy="1035271"/>
+          <a:xfrm rot="16200000" flipH="1">
+            <a:off x="2485720" y="2050599"/>
+            <a:ext cx="1035271" cy="2074424"/>
           </a:xfrm>
-          <a:prstGeom prst="bentConnector3">
-            <a:avLst>
-              <a:gd name="adj1" fmla="val 50000"/>
-            </a:avLst>
+          <a:prstGeom prst="bentConnector2">
+            <a:avLst/>
           </a:prstGeom>
           <a:ln>
             <a:tailEnd type="triangle"/>
@@ -12813,6 +12813,36 @@
 </file>
 
 <file path=ppt/slides/slide6.xml><?xml version="1.0" encoding="utf-8"?>
+<p:sld xmlns:a="http://schemas.openxmlformats.org/drawingml/2006/main" xmlns:r="http://schemas.openxmlformats.org/officeDocument/2006/relationships" xmlns:p="http://schemas.openxmlformats.org/presentationml/2006/main">
+  <p:cSld>
+    <p:spTree>
+      <p:nvGrpSpPr>
+        <p:cNvPr id="1" name=""/>
+        <p:cNvGrpSpPr/>
+        <p:nvPr/>
+      </p:nvGrpSpPr>
+      <p:grpSpPr>
+        <a:xfrm>
+          <a:off x="0" y="0"/>
+          <a:ext cx="0" cy="0"/>
+          <a:chOff x="0" y="0"/>
+          <a:chExt cx="0" cy="0"/>
+        </a:xfrm>
+      </p:grpSpPr>
+    </p:spTree>
+    <p:extLst>
+      <p:ext uri="{BB962C8B-B14F-4D97-AF65-F5344CB8AC3E}">
+        <p14:creationId xmlns:p14="http://schemas.microsoft.com/office/powerpoint/2010/main" val="903800887"/>
+      </p:ext>
+    </p:extLst>
+  </p:cSld>
+  <p:clrMapOvr>
+    <a:masterClrMapping/>
+  </p:clrMapOvr>
+</p:sld>
+</file>
+
+<file path=ppt/slides/slide7.xml><?xml version="1.0" encoding="utf-8"?>
 <p:sld xmlns:a="http://schemas.openxmlformats.org/drawingml/2006/main" xmlns:r="http://schemas.openxmlformats.org/officeDocument/2006/relationships" xmlns:p="http://schemas.openxmlformats.org/presentationml/2006/main">
   <p:cSld>
     <p:spTree>

</xml_diff>

<commit_message>
Fixing Users and UserRoles
</commit_message>
<xml_diff>
--- a/Documentations/SysArchitecture.pptx
+++ b/Documentations/SysArchitecture.pptx
@@ -267,7 +267,7 @@
           <a:p>
             <a:fld id="{8377380A-1819-462E-96FD-3D6CBD777CA0}" type="datetimeFigureOut">
               <a:rPr lang="en-IL" smtClean="0"/>
-              <a:t>14/08/2025</a:t>
+              <a:t>15/08/2025</a:t>
             </a:fld>
             <a:endParaRPr lang="en-IL"/>
           </a:p>
@@ -467,7 +467,7 @@
           <a:p>
             <a:fld id="{8377380A-1819-462E-96FD-3D6CBD777CA0}" type="datetimeFigureOut">
               <a:rPr lang="en-IL" smtClean="0"/>
-              <a:t>14/08/2025</a:t>
+              <a:t>15/08/2025</a:t>
             </a:fld>
             <a:endParaRPr lang="en-IL"/>
           </a:p>
@@ -677,7 +677,7 @@
           <a:p>
             <a:fld id="{8377380A-1819-462E-96FD-3D6CBD777CA0}" type="datetimeFigureOut">
               <a:rPr lang="en-IL" smtClean="0"/>
-              <a:t>14/08/2025</a:t>
+              <a:t>15/08/2025</a:t>
             </a:fld>
             <a:endParaRPr lang="en-IL"/>
           </a:p>
@@ -877,7 +877,7 @@
           <a:p>
             <a:fld id="{8377380A-1819-462E-96FD-3D6CBD777CA0}" type="datetimeFigureOut">
               <a:rPr lang="en-IL" smtClean="0"/>
-              <a:t>14/08/2025</a:t>
+              <a:t>15/08/2025</a:t>
             </a:fld>
             <a:endParaRPr lang="en-IL"/>
           </a:p>
@@ -1153,7 +1153,7 @@
           <a:p>
             <a:fld id="{8377380A-1819-462E-96FD-3D6CBD777CA0}" type="datetimeFigureOut">
               <a:rPr lang="en-IL" smtClean="0"/>
-              <a:t>14/08/2025</a:t>
+              <a:t>15/08/2025</a:t>
             </a:fld>
             <a:endParaRPr lang="en-IL"/>
           </a:p>
@@ -1421,7 +1421,7 @@
           <a:p>
             <a:fld id="{8377380A-1819-462E-96FD-3D6CBD777CA0}" type="datetimeFigureOut">
               <a:rPr lang="en-IL" smtClean="0"/>
-              <a:t>14/08/2025</a:t>
+              <a:t>15/08/2025</a:t>
             </a:fld>
             <a:endParaRPr lang="en-IL"/>
           </a:p>
@@ -1836,7 +1836,7 @@
           <a:p>
             <a:fld id="{8377380A-1819-462E-96FD-3D6CBD777CA0}" type="datetimeFigureOut">
               <a:rPr lang="en-IL" smtClean="0"/>
-              <a:t>14/08/2025</a:t>
+              <a:t>15/08/2025</a:t>
             </a:fld>
             <a:endParaRPr lang="en-IL"/>
           </a:p>
@@ -1978,7 +1978,7 @@
           <a:p>
             <a:fld id="{8377380A-1819-462E-96FD-3D6CBD777CA0}" type="datetimeFigureOut">
               <a:rPr lang="en-IL" smtClean="0"/>
-              <a:t>14/08/2025</a:t>
+              <a:t>15/08/2025</a:t>
             </a:fld>
             <a:endParaRPr lang="en-IL"/>
           </a:p>
@@ -2091,7 +2091,7 @@
           <a:p>
             <a:fld id="{8377380A-1819-462E-96FD-3D6CBD777CA0}" type="datetimeFigureOut">
               <a:rPr lang="en-IL" smtClean="0"/>
-              <a:t>14/08/2025</a:t>
+              <a:t>15/08/2025</a:t>
             </a:fld>
             <a:endParaRPr lang="en-IL"/>
           </a:p>
@@ -2404,7 +2404,7 @@
           <a:p>
             <a:fld id="{8377380A-1819-462E-96FD-3D6CBD777CA0}" type="datetimeFigureOut">
               <a:rPr lang="en-IL" smtClean="0"/>
-              <a:t>14/08/2025</a:t>
+              <a:t>15/08/2025</a:t>
             </a:fld>
             <a:endParaRPr lang="en-IL"/>
           </a:p>
@@ -2693,7 +2693,7 @@
           <a:p>
             <a:fld id="{8377380A-1819-462E-96FD-3D6CBD777CA0}" type="datetimeFigureOut">
               <a:rPr lang="en-IL" smtClean="0"/>
-              <a:t>14/08/2025</a:t>
+              <a:t>15/08/2025</a:t>
             </a:fld>
             <a:endParaRPr lang="en-IL"/>
           </a:p>
@@ -2936,7 +2936,7 @@
           <a:p>
             <a:fld id="{8377380A-1819-462E-96FD-3D6CBD777CA0}" type="datetimeFigureOut">
               <a:rPr lang="en-IL" smtClean="0"/>
-              <a:t>14/08/2025</a:t>
+              <a:t>15/08/2025</a:t>
             </a:fld>
             <a:endParaRPr lang="en-IL"/>
           </a:p>
@@ -11470,7 +11470,7 @@
         <p:grpSpPr>
           <a:xfrm>
             <a:off x="950614" y="876860"/>
-            <a:ext cx="2031057" cy="1693316"/>
+            <a:ext cx="2031057" cy="1217532"/>
             <a:chOff x="2037028" y="1176951"/>
             <a:chExt cx="3108185" cy="2252047"/>
           </a:xfrm>
@@ -11589,7 +11589,23 @@
                     <a:schemeClr val="tx1"/>
                   </a:solidFill>
                 </a:rPr>
-                <a:t>: int</a:t>
+                <a:t>: </a:t>
+              </a:r>
+              <a:r>
+                <a:rPr lang="en-US" sz="1200" dirty="0" err="1">
+                  <a:solidFill>
+                    <a:schemeClr val="tx1"/>
+                  </a:solidFill>
+                </a:rPr>
+                <a:t>Guid</a:t>
+              </a:r>
+              <a:r>
+                <a:rPr lang="en-US" sz="1200" dirty="0">
+                  <a:solidFill>
+                    <a:schemeClr val="tx1"/>
+                  </a:solidFill>
+                </a:rPr>
+                <a:t> (PK)</a:t>
               </a:r>
             </a:p>
             <a:p>
@@ -11652,20 +11668,6 @@
                 </a:rPr>
                 <a:t> : datetime</a:t>
               </a:r>
-            </a:p>
-            <a:p>
-              <a:endParaRPr lang="en-US" sz="1200" dirty="0">
-                <a:solidFill>
-                  <a:schemeClr val="tx1"/>
-                </a:solidFill>
-              </a:endParaRPr>
-            </a:p>
-            <a:p>
-              <a:endParaRPr lang="en-US" sz="1200" dirty="0">
-                <a:solidFill>
-                  <a:schemeClr val="tx1"/>
-                </a:solidFill>
-              </a:endParaRPr>
             </a:p>
             <a:p>
               <a:endParaRPr lang="en-US" sz="1200" dirty="0">
@@ -11778,7 +11780,7 @@
         </p:nvGrpSpPr>
         <p:grpSpPr>
           <a:xfrm>
-            <a:off x="4040566" y="2645223"/>
+            <a:off x="3915009" y="2201940"/>
             <a:ext cx="2732853" cy="1567554"/>
             <a:chOff x="2029809" y="1176950"/>
             <a:chExt cx="2136619" cy="3410260"/>
@@ -12019,7 +12021,7 @@
         </p:nvSpPr>
         <p:spPr>
           <a:xfrm>
-            <a:off x="3592420" y="3323922"/>
+            <a:off x="3447923" y="2881391"/>
             <a:ext cx="391107" cy="280774"/>
           </a:xfrm>
           <a:prstGeom prst="rect">
@@ -12085,8 +12087,8 @@
         </p:nvCxnSpPr>
         <p:spPr>
           <a:xfrm rot="16200000" flipH="1">
-            <a:off x="2485720" y="2050599"/>
-            <a:ext cx="1035271" cy="2074424"/>
+            <a:off x="2406690" y="1653844"/>
+            <a:ext cx="1067772" cy="1948867"/>
           </a:xfrm>
           <a:prstGeom prst="bentConnector2">
             <a:avLst/>
@@ -12124,8 +12126,8 @@
         </p:nvGrpSpPr>
         <p:grpSpPr>
           <a:xfrm>
-            <a:off x="3915010" y="1180507"/>
-            <a:ext cx="2732855" cy="915347"/>
+            <a:off x="3915009" y="1180507"/>
+            <a:ext cx="3773801" cy="915347"/>
             <a:chOff x="2037028" y="1176951"/>
             <a:chExt cx="3108185" cy="2252047"/>
           </a:xfrm>
@@ -12244,17 +12246,15 @@
                     <a:schemeClr val="tx1"/>
                   </a:solidFill>
                 </a:rPr>
-                <a:t>: int</a:t>
-              </a:r>
-            </a:p>
-            <a:p>
+                <a:t>: </a:t>
+              </a:r>
               <a:r>
                 <a:rPr lang="en-US" sz="1200" dirty="0" err="1">
                   <a:solidFill>
                     <a:schemeClr val="tx1"/>
                   </a:solidFill>
                 </a:rPr>
-                <a:t>User_Id</a:t>
+                <a:t>Guid</a:t>
               </a:r>
               <a:r>
                 <a:rPr lang="en-US" sz="1200" dirty="0">
@@ -12262,17 +12262,25 @@
                     <a:schemeClr val="tx1"/>
                   </a:solidFill>
                 </a:rPr>
-                <a:t> (FK) : int</a:t>
-              </a:r>
-            </a:p>
-            <a:p>
+                <a:t> (PK)</a:t>
+              </a:r>
+            </a:p>
+            <a:p>
+              <a:r>
+                <a:rPr lang="en-US" sz="1200" dirty="0" err="1">
+                  <a:solidFill>
+                    <a:schemeClr val="tx1"/>
+                  </a:solidFill>
+                </a:rPr>
+                <a:t>RoleName</a:t>
+              </a:r>
               <a:r>
                 <a:rPr lang="en-US" sz="1200" dirty="0">
                   <a:solidFill>
                     <a:schemeClr val="tx1"/>
                   </a:solidFill>
                 </a:rPr>
-                <a:t>Role : </a:t>
+                <a:t> : </a:t>
               </a:r>
               <a:r>
                 <a:rPr lang="en-US" sz="1200" dirty="0" err="1">
@@ -12288,7 +12296,7 @@
                     <a:schemeClr val="tx1"/>
                   </a:solidFill>
                 </a:rPr>
-                <a:t> (Admin, </a:t>
+                <a:t> (User = 0, Admin = 1, </a:t>
               </a:r>
               <a:r>
                 <a:rPr lang="en-US" sz="1200" dirty="0" err="1">
@@ -12304,7 +12312,7 @@
                     <a:schemeClr val="tx1"/>
                   </a:solidFill>
                 </a:rPr>
-                <a:t>, User)</a:t>
+                <a:t> = 2)</a:t>
               </a:r>
             </a:p>
             <a:p>

</xml_diff>

<commit_message>
Documentation file and Root folder name update
</commit_message>
<xml_diff>
--- a/Documentations/SysArchitecture.pptx
+++ b/Documentations/SysArchitecture.pptx
@@ -10009,10 +10009,18 @@
           <a:p>
             <a:pPr algn="ctr"/>
             <a:r>
-              <a:rPr lang="en-US" dirty="0"/>
+              <a:rPr lang="en-US" dirty="0">
+                <a:solidFill>
+                  <a:schemeClr val="tx1"/>
+                </a:solidFill>
+              </a:rPr>
               <a:t>Customer Data Model</a:t>
             </a:r>
-            <a:endParaRPr lang="en-IL" dirty="0"/>
+            <a:endParaRPr lang="en-IL" dirty="0">
+              <a:solidFill>
+                <a:schemeClr val="tx1"/>
+              </a:solidFill>
+            </a:endParaRPr>
           </a:p>
         </p:txBody>
       </p:sp>
@@ -11759,10 +11767,18 @@
           <a:p>
             <a:pPr algn="ctr"/>
             <a:r>
-              <a:rPr lang="en-US" dirty="0"/>
+              <a:rPr lang="en-US" dirty="0">
+                <a:solidFill>
+                  <a:schemeClr val="tx1"/>
+                </a:solidFill>
+              </a:rPr>
               <a:t>User Data Model</a:t>
             </a:r>
-            <a:endParaRPr lang="en-IL" dirty="0"/>
+            <a:endParaRPr lang="en-IL" dirty="0">
+              <a:solidFill>
+                <a:schemeClr val="tx1"/>
+              </a:solidFill>
+            </a:endParaRPr>
           </a:p>
         </p:txBody>
       </p:sp>
@@ -12837,6 +12853,1497 @@
           <a:chExt cx="0" cy="0"/>
         </a:xfrm>
       </p:grpSpPr>
+      <p:sp>
+        <p:nvSpPr>
+          <p:cNvPr id="2" name="AutoShape 13">
+            <a:extLst>
+              <a:ext uri="{FF2B5EF4-FFF2-40B4-BE49-F238E27FC236}">
+                <a16:creationId xmlns:a16="http://schemas.microsoft.com/office/drawing/2014/main" id="{78FF15C6-2884-A197-AD86-D46D737FF0CB}"/>
+              </a:ext>
+            </a:extLst>
+          </p:cNvPr>
+          <p:cNvSpPr>
+            <a:spLocks noChangeArrowheads="1"/>
+          </p:cNvSpPr>
+          <p:nvPr/>
+        </p:nvSpPr>
+        <p:spPr bwMode="auto">
+          <a:xfrm>
+            <a:off x="74234" y="701263"/>
+            <a:ext cx="1315653" cy="295343"/>
+          </a:xfrm>
+          <a:prstGeom prst="roundRect">
+            <a:avLst>
+              <a:gd name="adj" fmla="val 16667"/>
+            </a:avLst>
+          </a:prstGeom>
+          <a:solidFill>
+            <a:schemeClr val="bg1"/>
+          </a:solidFill>
+          <a:ln w="12700">
+            <a:solidFill>
+              <a:srgbClr val="09101D"/>
+            </a:solidFill>
+            <a:miter lim="800000"/>
+            <a:headEnd/>
+            <a:tailEnd/>
+          </a:ln>
+        </p:spPr>
+        <p:txBody>
+          <a:bodyPr vert="horz" wrap="square" lIns="91440" tIns="45720" rIns="91440" bIns="45720" numCol="1" anchor="ctr" anchorCtr="0" compatLnSpc="1">
+            <a:prstTxWarp prst="textNoShape">
+              <a:avLst/>
+            </a:prstTxWarp>
+          </a:bodyPr>
+          <a:lstStyle/>
+          <a:p>
+            <a:pPr marL="0" marR="0" lvl="0" indent="0" algn="ctr" defTabSz="914400" rtl="0" eaLnBrk="0" fontAlgn="base" latinLnBrk="0" hangingPunct="0">
+              <a:lnSpc>
+                <a:spcPct val="100000"/>
+              </a:lnSpc>
+              <a:spcBef>
+                <a:spcPct val="0"/>
+              </a:spcBef>
+              <a:spcAft>
+                <a:spcPct val="0"/>
+              </a:spcAft>
+              <a:buClrTx/>
+              <a:buSzTx/>
+              <a:buFontTx/>
+              <a:buNone/>
+              <a:tabLst/>
+            </a:pPr>
+            <a:r>
+              <a:rPr kumimoji="0" lang="en-US" altLang="en-IL" b="0" i="0" u="none" strike="noStrike" cap="none" normalizeH="0" baseline="0" dirty="0">
+                <a:ln>
+                  <a:noFill/>
+                </a:ln>
+                <a:solidFill>
+                  <a:schemeClr val="tx1"/>
+                </a:solidFill>
+                <a:effectLst/>
+                <a:latin typeface="Calibri" panose="020F0502020204030204" pitchFamily="34" charset="0"/>
+                <a:ea typeface="Yu Gothic" panose="020B0400000000000000" pitchFamily="34" charset="-128"/>
+                <a:cs typeface="Arial" panose="020B0604020202020204" pitchFamily="34" charset="0"/>
+              </a:rPr>
+              <a:t>A2C (Root)</a:t>
+            </a:r>
+            <a:endParaRPr kumimoji="0" lang="en-IL" altLang="en-IL" sz="4000" b="0" i="0" u="none" strike="noStrike" cap="none" normalizeH="0" baseline="0" dirty="0">
+              <a:ln>
+                <a:noFill/>
+              </a:ln>
+              <a:solidFill>
+                <a:schemeClr val="tx1"/>
+              </a:solidFill>
+              <a:effectLst/>
+              <a:latin typeface="Arial" panose="020B0604020202020204" pitchFamily="34" charset="0"/>
+            </a:endParaRPr>
+          </a:p>
+        </p:txBody>
+      </p:sp>
+      <p:sp>
+        <p:nvSpPr>
+          <p:cNvPr id="3" name="Rectangle 2">
+            <a:extLst>
+              <a:ext uri="{FF2B5EF4-FFF2-40B4-BE49-F238E27FC236}">
+                <a16:creationId xmlns:a16="http://schemas.microsoft.com/office/drawing/2014/main" id="{B4C09A88-5F98-C840-2E68-5720BEC0681D}"/>
+              </a:ext>
+            </a:extLst>
+          </p:cNvPr>
+          <p:cNvSpPr/>
+          <p:nvPr/>
+        </p:nvSpPr>
+        <p:spPr>
+          <a:xfrm>
+            <a:off x="2478179" y="117618"/>
+            <a:ext cx="3385068" cy="466687"/>
+          </a:xfrm>
+          <a:prstGeom prst="rect">
+            <a:avLst/>
+          </a:prstGeom>
+          <a:solidFill>
+            <a:schemeClr val="accent2">
+              <a:lumMod val="40000"/>
+              <a:lumOff val="60000"/>
+            </a:schemeClr>
+          </a:solidFill>
+        </p:spPr>
+        <p:style>
+          <a:lnRef idx="2">
+            <a:schemeClr val="accent1">
+              <a:shade val="15000"/>
+            </a:schemeClr>
+          </a:lnRef>
+          <a:fillRef idx="1">
+            <a:schemeClr val="accent1"/>
+          </a:fillRef>
+          <a:effectRef idx="0">
+            <a:schemeClr val="accent1"/>
+          </a:effectRef>
+          <a:fontRef idx="minor">
+            <a:schemeClr val="lt1"/>
+          </a:fontRef>
+        </p:style>
+        <p:txBody>
+          <a:bodyPr rtlCol="0" anchor="ctr"/>
+          <a:lstStyle/>
+          <a:p>
+            <a:pPr algn="ctr"/>
+            <a:r>
+              <a:rPr lang="en-US" dirty="0">
+                <a:solidFill>
+                  <a:schemeClr val="tx1"/>
+                </a:solidFill>
+              </a:rPr>
+              <a:t>Folders Structure</a:t>
+            </a:r>
+            <a:endParaRPr lang="en-IL" dirty="0">
+              <a:solidFill>
+                <a:schemeClr val="tx1"/>
+              </a:solidFill>
+            </a:endParaRPr>
+          </a:p>
+        </p:txBody>
+      </p:sp>
+      <p:sp>
+        <p:nvSpPr>
+          <p:cNvPr id="4" name="AutoShape 13">
+            <a:extLst>
+              <a:ext uri="{FF2B5EF4-FFF2-40B4-BE49-F238E27FC236}">
+                <a16:creationId xmlns:a16="http://schemas.microsoft.com/office/drawing/2014/main" id="{417BBC80-527E-A9B3-A84D-141B4841DB55}"/>
+              </a:ext>
+            </a:extLst>
+          </p:cNvPr>
+          <p:cNvSpPr>
+            <a:spLocks noChangeArrowheads="1"/>
+          </p:cNvSpPr>
+          <p:nvPr/>
+        </p:nvSpPr>
+        <p:spPr bwMode="auto">
+          <a:xfrm>
+            <a:off x="1298448" y="1842973"/>
+            <a:ext cx="832104" cy="305112"/>
+          </a:xfrm>
+          <a:prstGeom prst="roundRect">
+            <a:avLst>
+              <a:gd name="adj" fmla="val 16667"/>
+            </a:avLst>
+          </a:prstGeom>
+          <a:solidFill>
+            <a:schemeClr val="bg1"/>
+          </a:solidFill>
+          <a:ln w="12700">
+            <a:solidFill>
+              <a:srgbClr val="09101D"/>
+            </a:solidFill>
+            <a:miter lim="800000"/>
+            <a:headEnd/>
+            <a:tailEnd/>
+          </a:ln>
+        </p:spPr>
+        <p:txBody>
+          <a:bodyPr vert="horz" wrap="square" lIns="91440" tIns="45720" rIns="91440" bIns="45720" numCol="1" anchor="ctr" anchorCtr="0" compatLnSpc="1">
+            <a:prstTxWarp prst="textNoShape">
+              <a:avLst/>
+            </a:prstTxWarp>
+          </a:bodyPr>
+          <a:lstStyle/>
+          <a:p>
+            <a:pPr marL="0" marR="0" lvl="0" indent="0" algn="ctr" defTabSz="914400" rtl="0" eaLnBrk="0" fontAlgn="base" latinLnBrk="0" hangingPunct="0">
+              <a:lnSpc>
+                <a:spcPct val="100000"/>
+              </a:lnSpc>
+              <a:spcBef>
+                <a:spcPct val="0"/>
+              </a:spcBef>
+              <a:spcAft>
+                <a:spcPct val="0"/>
+              </a:spcAft>
+              <a:buClrTx/>
+              <a:buSzTx/>
+              <a:buFontTx/>
+              <a:buNone/>
+              <a:tabLst/>
+            </a:pPr>
+            <a:r>
+              <a:rPr kumimoji="0" lang="en-US" altLang="en-IL" b="0" i="0" u="none" strike="noStrike" cap="none" normalizeH="0" baseline="0" dirty="0">
+                <a:ln>
+                  <a:noFill/>
+                </a:ln>
+                <a:solidFill>
+                  <a:schemeClr val="tx1"/>
+                </a:solidFill>
+                <a:effectLst/>
+                <a:latin typeface="Calibri" panose="020F0502020204030204" pitchFamily="34" charset="0"/>
+                <a:ea typeface="Yu Gothic" panose="020B0400000000000000" pitchFamily="34" charset="-128"/>
+                <a:cs typeface="Arial" panose="020B0604020202020204" pitchFamily="34" charset="0"/>
+              </a:rPr>
+              <a:t>Server</a:t>
+            </a:r>
+            <a:endParaRPr kumimoji="0" lang="en-IL" altLang="en-IL" sz="4000" b="0" i="0" u="none" strike="noStrike" cap="none" normalizeH="0" baseline="0" dirty="0">
+              <a:ln>
+                <a:noFill/>
+              </a:ln>
+              <a:solidFill>
+                <a:schemeClr val="tx1"/>
+              </a:solidFill>
+              <a:effectLst/>
+              <a:latin typeface="Arial" panose="020B0604020202020204" pitchFamily="34" charset="0"/>
+            </a:endParaRPr>
+          </a:p>
+        </p:txBody>
+      </p:sp>
+      <p:sp>
+        <p:nvSpPr>
+          <p:cNvPr id="6" name="AutoShape 13">
+            <a:extLst>
+              <a:ext uri="{FF2B5EF4-FFF2-40B4-BE49-F238E27FC236}">
+                <a16:creationId xmlns:a16="http://schemas.microsoft.com/office/drawing/2014/main" id="{EFA49FBE-0BEA-95E9-179B-C50C986B99F4}"/>
+              </a:ext>
+            </a:extLst>
+          </p:cNvPr>
+          <p:cNvSpPr>
+            <a:spLocks noChangeArrowheads="1"/>
+          </p:cNvSpPr>
+          <p:nvPr/>
+        </p:nvSpPr>
+        <p:spPr bwMode="auto">
+          <a:xfrm>
+            <a:off x="1280160" y="1100440"/>
+            <a:ext cx="761080" cy="305112"/>
+          </a:xfrm>
+          <a:prstGeom prst="roundRect">
+            <a:avLst>
+              <a:gd name="adj" fmla="val 16667"/>
+            </a:avLst>
+          </a:prstGeom>
+          <a:solidFill>
+            <a:schemeClr val="bg1"/>
+          </a:solidFill>
+          <a:ln w="12700">
+            <a:solidFill>
+              <a:srgbClr val="09101D"/>
+            </a:solidFill>
+            <a:miter lim="800000"/>
+            <a:headEnd/>
+            <a:tailEnd/>
+          </a:ln>
+        </p:spPr>
+        <p:txBody>
+          <a:bodyPr vert="horz" wrap="square" lIns="91440" tIns="45720" rIns="91440" bIns="45720" numCol="1" anchor="ctr" anchorCtr="0" compatLnSpc="1">
+            <a:prstTxWarp prst="textNoShape">
+              <a:avLst/>
+            </a:prstTxWarp>
+          </a:bodyPr>
+          <a:lstStyle/>
+          <a:p>
+            <a:pPr marL="0" marR="0" lvl="0" indent="0" algn="ctr" defTabSz="914400" rtl="0" eaLnBrk="0" fontAlgn="base" latinLnBrk="0" hangingPunct="0">
+              <a:lnSpc>
+                <a:spcPct val="100000"/>
+              </a:lnSpc>
+              <a:spcBef>
+                <a:spcPct val="0"/>
+              </a:spcBef>
+              <a:spcAft>
+                <a:spcPct val="0"/>
+              </a:spcAft>
+              <a:buClrTx/>
+              <a:buSzTx/>
+              <a:buFontTx/>
+              <a:buNone/>
+              <a:tabLst/>
+            </a:pPr>
+            <a:r>
+              <a:rPr kumimoji="0" lang="en-US" altLang="en-IL" b="0" i="0" u="none" strike="noStrike" cap="none" normalizeH="0" baseline="0" dirty="0">
+                <a:ln>
+                  <a:noFill/>
+                </a:ln>
+                <a:solidFill>
+                  <a:schemeClr val="tx1"/>
+                </a:solidFill>
+                <a:effectLst/>
+                <a:latin typeface="Calibri" panose="020F0502020204030204" pitchFamily="34" charset="0"/>
+                <a:ea typeface="Yu Gothic" panose="020B0400000000000000" pitchFamily="34" charset="-128"/>
+                <a:cs typeface="Arial" panose="020B0604020202020204" pitchFamily="34" charset="0"/>
+              </a:rPr>
+              <a:t>Client</a:t>
+            </a:r>
+            <a:endParaRPr kumimoji="0" lang="en-IL" altLang="en-IL" sz="4000" b="0" i="0" u="none" strike="noStrike" cap="none" normalizeH="0" baseline="0" dirty="0">
+              <a:ln>
+                <a:noFill/>
+              </a:ln>
+              <a:solidFill>
+                <a:schemeClr val="tx1"/>
+              </a:solidFill>
+              <a:effectLst/>
+              <a:latin typeface="Arial" panose="020B0604020202020204" pitchFamily="34" charset="0"/>
+            </a:endParaRPr>
+          </a:p>
+        </p:txBody>
+      </p:sp>
+      <p:sp>
+        <p:nvSpPr>
+          <p:cNvPr id="7" name="AutoShape 13">
+            <a:extLst>
+              <a:ext uri="{FF2B5EF4-FFF2-40B4-BE49-F238E27FC236}">
+                <a16:creationId xmlns:a16="http://schemas.microsoft.com/office/drawing/2014/main" id="{0A62B873-9219-6D42-FED9-1EFD25F683FB}"/>
+              </a:ext>
+            </a:extLst>
+          </p:cNvPr>
+          <p:cNvSpPr>
+            <a:spLocks noChangeArrowheads="1"/>
+          </p:cNvSpPr>
+          <p:nvPr/>
+        </p:nvSpPr>
+        <p:spPr bwMode="auto">
+          <a:xfrm>
+            <a:off x="1283208" y="5817564"/>
+            <a:ext cx="1675482" cy="359441"/>
+          </a:xfrm>
+          <a:prstGeom prst="roundRect">
+            <a:avLst>
+              <a:gd name="adj" fmla="val 16667"/>
+            </a:avLst>
+          </a:prstGeom>
+          <a:solidFill>
+            <a:schemeClr val="bg1"/>
+          </a:solidFill>
+          <a:ln w="12700">
+            <a:solidFill>
+              <a:srgbClr val="09101D"/>
+            </a:solidFill>
+            <a:miter lim="800000"/>
+            <a:headEnd/>
+            <a:tailEnd/>
+          </a:ln>
+        </p:spPr>
+        <p:txBody>
+          <a:bodyPr vert="horz" wrap="square" lIns="91440" tIns="45720" rIns="91440" bIns="45720" numCol="1" anchor="ctr" anchorCtr="0" compatLnSpc="1">
+            <a:prstTxWarp prst="textNoShape">
+              <a:avLst/>
+            </a:prstTxWarp>
+          </a:bodyPr>
+          <a:lstStyle/>
+          <a:p>
+            <a:pPr algn="ctr" eaLnBrk="0" fontAlgn="base" hangingPunct="0">
+              <a:spcBef>
+                <a:spcPct val="0"/>
+              </a:spcBef>
+              <a:spcAft>
+                <a:spcPct val="0"/>
+              </a:spcAft>
+            </a:pPr>
+            <a:r>
+              <a:rPr lang="en-US" altLang="en-IL" dirty="0">
+                <a:latin typeface="Calibri" panose="020F0502020204030204" pitchFamily="34" charset="0"/>
+                <a:ea typeface="Yu Gothic" panose="020B0400000000000000" pitchFamily="34" charset="-128"/>
+                <a:cs typeface="Arial" panose="020B0604020202020204" pitchFamily="34" charset="0"/>
+              </a:rPr>
+              <a:t>Documentation</a:t>
+            </a:r>
+            <a:endParaRPr lang="en-IL" altLang="en-IL" dirty="0">
+              <a:latin typeface="Calibri" panose="020F0502020204030204" pitchFamily="34" charset="0"/>
+              <a:ea typeface="Yu Gothic" panose="020B0400000000000000" pitchFamily="34" charset="-128"/>
+              <a:cs typeface="Arial" panose="020B0604020202020204" pitchFamily="34" charset="0"/>
+            </a:endParaRPr>
+          </a:p>
+        </p:txBody>
+      </p:sp>
+      <p:cxnSp>
+        <p:nvCxnSpPr>
+          <p:cNvPr id="9" name="Straight Connector 8">
+            <a:extLst>
+              <a:ext uri="{FF2B5EF4-FFF2-40B4-BE49-F238E27FC236}">
+                <a16:creationId xmlns:a16="http://schemas.microsoft.com/office/drawing/2014/main" id="{57E11C29-6CF2-2E2F-E747-35691FFFFBC2}"/>
+              </a:ext>
+            </a:extLst>
+          </p:cNvPr>
+          <p:cNvCxnSpPr>
+            <a:cxnSpLocks/>
+          </p:cNvCxnSpPr>
+          <p:nvPr/>
+        </p:nvCxnSpPr>
+        <p:spPr>
+          <a:xfrm flipH="1">
+            <a:off x="625882" y="996606"/>
+            <a:ext cx="8184" cy="4979119"/>
+          </a:xfrm>
+          <a:prstGeom prst="line">
+            <a:avLst/>
+          </a:prstGeom>
+        </p:spPr>
+        <p:style>
+          <a:lnRef idx="2">
+            <a:schemeClr val="accent1"/>
+          </a:lnRef>
+          <a:fillRef idx="0">
+            <a:schemeClr val="accent1"/>
+          </a:fillRef>
+          <a:effectRef idx="1">
+            <a:schemeClr val="accent1"/>
+          </a:effectRef>
+          <a:fontRef idx="minor">
+            <a:schemeClr val="tx1"/>
+          </a:fontRef>
+        </p:style>
+      </p:cxnSp>
+      <p:cxnSp>
+        <p:nvCxnSpPr>
+          <p:cNvPr id="10" name="Straight Connector 9">
+            <a:extLst>
+              <a:ext uri="{FF2B5EF4-FFF2-40B4-BE49-F238E27FC236}">
+                <a16:creationId xmlns:a16="http://schemas.microsoft.com/office/drawing/2014/main" id="{8E575987-DD26-185B-E83A-9C5F84B0A4A3}"/>
+              </a:ext>
+            </a:extLst>
+          </p:cNvPr>
+          <p:cNvCxnSpPr>
+            <a:cxnSpLocks/>
+          </p:cNvCxnSpPr>
+          <p:nvPr/>
+        </p:nvCxnSpPr>
+        <p:spPr>
+          <a:xfrm>
+            <a:off x="634066" y="1280160"/>
+            <a:ext cx="646094" cy="9768"/>
+          </a:xfrm>
+          <a:prstGeom prst="line">
+            <a:avLst/>
+          </a:prstGeom>
+        </p:spPr>
+        <p:style>
+          <a:lnRef idx="2">
+            <a:schemeClr val="accent1"/>
+          </a:lnRef>
+          <a:fillRef idx="0">
+            <a:schemeClr val="accent1"/>
+          </a:fillRef>
+          <a:effectRef idx="1">
+            <a:schemeClr val="accent1"/>
+          </a:effectRef>
+          <a:fontRef idx="minor">
+            <a:schemeClr val="tx1"/>
+          </a:fontRef>
+        </p:style>
+      </p:cxnSp>
+      <p:cxnSp>
+        <p:nvCxnSpPr>
+          <p:cNvPr id="20" name="Straight Connector 19">
+            <a:extLst>
+              <a:ext uri="{FF2B5EF4-FFF2-40B4-BE49-F238E27FC236}">
+                <a16:creationId xmlns:a16="http://schemas.microsoft.com/office/drawing/2014/main" id="{63BA3F4B-DFBF-9FDB-CC15-5D15E7301C4E}"/>
+              </a:ext>
+            </a:extLst>
+          </p:cNvPr>
+          <p:cNvCxnSpPr>
+            <a:cxnSpLocks/>
+          </p:cNvCxnSpPr>
+          <p:nvPr/>
+        </p:nvCxnSpPr>
+        <p:spPr>
+          <a:xfrm>
+            <a:off x="640162" y="2008632"/>
+            <a:ext cx="658286" cy="0"/>
+          </a:xfrm>
+          <a:prstGeom prst="line">
+            <a:avLst/>
+          </a:prstGeom>
+        </p:spPr>
+        <p:style>
+          <a:lnRef idx="2">
+            <a:schemeClr val="accent1"/>
+          </a:lnRef>
+          <a:fillRef idx="0">
+            <a:schemeClr val="accent1"/>
+          </a:fillRef>
+          <a:effectRef idx="1">
+            <a:schemeClr val="accent1"/>
+          </a:effectRef>
+          <a:fontRef idx="minor">
+            <a:schemeClr val="tx1"/>
+          </a:fontRef>
+        </p:style>
+      </p:cxnSp>
+      <p:cxnSp>
+        <p:nvCxnSpPr>
+          <p:cNvPr id="22" name="Straight Connector 21">
+            <a:extLst>
+              <a:ext uri="{FF2B5EF4-FFF2-40B4-BE49-F238E27FC236}">
+                <a16:creationId xmlns:a16="http://schemas.microsoft.com/office/drawing/2014/main" id="{83E70F1E-D267-7CAE-D953-D335D1601B47}"/>
+              </a:ext>
+            </a:extLst>
+          </p:cNvPr>
+          <p:cNvCxnSpPr>
+            <a:cxnSpLocks/>
+          </p:cNvCxnSpPr>
+          <p:nvPr/>
+        </p:nvCxnSpPr>
+        <p:spPr>
+          <a:xfrm>
+            <a:off x="624922" y="5975725"/>
+            <a:ext cx="658286" cy="0"/>
+          </a:xfrm>
+          <a:prstGeom prst="line">
+            <a:avLst/>
+          </a:prstGeom>
+        </p:spPr>
+        <p:style>
+          <a:lnRef idx="2">
+            <a:schemeClr val="accent1"/>
+          </a:lnRef>
+          <a:fillRef idx="0">
+            <a:schemeClr val="accent1"/>
+          </a:fillRef>
+          <a:effectRef idx="1">
+            <a:schemeClr val="accent1"/>
+          </a:effectRef>
+          <a:fontRef idx="minor">
+            <a:schemeClr val="tx1"/>
+          </a:fontRef>
+        </p:style>
+      </p:cxnSp>
+      <p:sp>
+        <p:nvSpPr>
+          <p:cNvPr id="24" name="AutoShape 13">
+            <a:extLst>
+              <a:ext uri="{FF2B5EF4-FFF2-40B4-BE49-F238E27FC236}">
+                <a16:creationId xmlns:a16="http://schemas.microsoft.com/office/drawing/2014/main" id="{7B32EEA7-56D5-EB16-EF79-1E4E9A955A3E}"/>
+              </a:ext>
+            </a:extLst>
+          </p:cNvPr>
+          <p:cNvSpPr>
+            <a:spLocks noChangeArrowheads="1"/>
+          </p:cNvSpPr>
+          <p:nvPr/>
+        </p:nvSpPr>
+        <p:spPr bwMode="auto">
+          <a:xfrm>
+            <a:off x="2235397" y="2419045"/>
+            <a:ext cx="1495356" cy="359440"/>
+          </a:xfrm>
+          <a:prstGeom prst="roundRect">
+            <a:avLst>
+              <a:gd name="adj" fmla="val 16667"/>
+            </a:avLst>
+          </a:prstGeom>
+          <a:solidFill>
+            <a:schemeClr val="bg1"/>
+          </a:solidFill>
+          <a:ln w="12700">
+            <a:solidFill>
+              <a:srgbClr val="09101D"/>
+            </a:solidFill>
+            <a:miter lim="800000"/>
+            <a:headEnd/>
+            <a:tailEnd/>
+          </a:ln>
+        </p:spPr>
+        <p:txBody>
+          <a:bodyPr vert="horz" wrap="square" lIns="91440" tIns="45720" rIns="91440" bIns="45720" numCol="1" anchor="ctr" anchorCtr="0" compatLnSpc="1">
+            <a:prstTxWarp prst="textNoShape">
+              <a:avLst/>
+            </a:prstTxWarp>
+          </a:bodyPr>
+          <a:lstStyle/>
+          <a:p>
+            <a:pPr lvl="0" algn="ctr" eaLnBrk="0" fontAlgn="base" hangingPunct="0">
+              <a:spcBef>
+                <a:spcPct val="0"/>
+              </a:spcBef>
+              <a:spcAft>
+                <a:spcPct val="0"/>
+              </a:spcAft>
+            </a:pPr>
+            <a:r>
+              <a:rPr lang="en-US" altLang="en-IL" dirty="0">
+                <a:latin typeface="Calibri" panose="020F0502020204030204" pitchFamily="34" charset="0"/>
+                <a:ea typeface="Yu Gothic" panose="020B0400000000000000" pitchFamily="34" charset="-128"/>
+                <a:cs typeface="Arial" panose="020B0604020202020204" pitchFamily="34" charset="0"/>
+              </a:rPr>
+              <a:t>A2C.CRM.Api</a:t>
+            </a:r>
+            <a:endParaRPr kumimoji="0" lang="en-IL" altLang="en-IL" sz="4000" b="0" i="0" u="none" strike="noStrike" cap="none" normalizeH="0" baseline="0" dirty="0">
+              <a:ln>
+                <a:noFill/>
+              </a:ln>
+              <a:solidFill>
+                <a:schemeClr val="tx1"/>
+              </a:solidFill>
+              <a:effectLst/>
+              <a:latin typeface="Arial" panose="020B0604020202020204" pitchFamily="34" charset="0"/>
+            </a:endParaRPr>
+          </a:p>
+        </p:txBody>
+      </p:sp>
+      <p:cxnSp>
+        <p:nvCxnSpPr>
+          <p:cNvPr id="26" name="Straight Connector 25">
+            <a:extLst>
+              <a:ext uri="{FF2B5EF4-FFF2-40B4-BE49-F238E27FC236}">
+                <a16:creationId xmlns:a16="http://schemas.microsoft.com/office/drawing/2014/main" id="{5890FA60-DB45-EE3E-82FB-D028DB10995B}"/>
+              </a:ext>
+            </a:extLst>
+          </p:cNvPr>
+          <p:cNvCxnSpPr>
+            <a:cxnSpLocks/>
+          </p:cNvCxnSpPr>
+          <p:nvPr/>
+        </p:nvCxnSpPr>
+        <p:spPr>
+          <a:xfrm>
+            <a:off x="1702914" y="2598764"/>
+            <a:ext cx="532482" cy="0"/>
+          </a:xfrm>
+          <a:prstGeom prst="line">
+            <a:avLst/>
+          </a:prstGeom>
+        </p:spPr>
+        <p:style>
+          <a:lnRef idx="2">
+            <a:schemeClr val="accent1"/>
+          </a:lnRef>
+          <a:fillRef idx="0">
+            <a:schemeClr val="accent1"/>
+          </a:fillRef>
+          <a:effectRef idx="1">
+            <a:schemeClr val="accent1"/>
+          </a:effectRef>
+          <a:fontRef idx="minor">
+            <a:schemeClr val="tx1"/>
+          </a:fontRef>
+        </p:style>
+      </p:cxnSp>
+      <p:cxnSp>
+        <p:nvCxnSpPr>
+          <p:cNvPr id="27" name="Straight Connector 26">
+            <a:extLst>
+              <a:ext uri="{FF2B5EF4-FFF2-40B4-BE49-F238E27FC236}">
+                <a16:creationId xmlns:a16="http://schemas.microsoft.com/office/drawing/2014/main" id="{61B0946D-8097-6B78-E2CF-708C835A14FB}"/>
+              </a:ext>
+            </a:extLst>
+          </p:cNvPr>
+          <p:cNvCxnSpPr>
+            <a:cxnSpLocks/>
+          </p:cNvCxnSpPr>
+          <p:nvPr/>
+        </p:nvCxnSpPr>
+        <p:spPr>
+          <a:xfrm>
+            <a:off x="1702914" y="2156693"/>
+            <a:ext cx="0" cy="442071"/>
+          </a:xfrm>
+          <a:prstGeom prst="line">
+            <a:avLst/>
+          </a:prstGeom>
+        </p:spPr>
+        <p:style>
+          <a:lnRef idx="2">
+            <a:schemeClr val="accent1"/>
+          </a:lnRef>
+          <a:fillRef idx="0">
+            <a:schemeClr val="accent1"/>
+          </a:fillRef>
+          <a:effectRef idx="1">
+            <a:schemeClr val="accent1"/>
+          </a:effectRef>
+          <a:fontRef idx="minor">
+            <a:schemeClr val="tx1"/>
+          </a:fontRef>
+        </p:style>
+      </p:cxnSp>
+      <p:cxnSp>
+        <p:nvCxnSpPr>
+          <p:cNvPr id="31" name="Straight Connector 30">
+            <a:extLst>
+              <a:ext uri="{FF2B5EF4-FFF2-40B4-BE49-F238E27FC236}">
+                <a16:creationId xmlns:a16="http://schemas.microsoft.com/office/drawing/2014/main" id="{B11EEA41-506E-A630-D972-503CEA2836BB}"/>
+              </a:ext>
+            </a:extLst>
+          </p:cNvPr>
+          <p:cNvCxnSpPr>
+            <a:cxnSpLocks/>
+          </p:cNvCxnSpPr>
+          <p:nvPr/>
+        </p:nvCxnSpPr>
+        <p:spPr>
+          <a:xfrm>
+            <a:off x="3005091" y="2778485"/>
+            <a:ext cx="0" cy="2370973"/>
+          </a:xfrm>
+          <a:prstGeom prst="line">
+            <a:avLst/>
+          </a:prstGeom>
+        </p:spPr>
+        <p:style>
+          <a:lnRef idx="2">
+            <a:schemeClr val="accent1"/>
+          </a:lnRef>
+          <a:fillRef idx="0">
+            <a:schemeClr val="accent1"/>
+          </a:fillRef>
+          <a:effectRef idx="1">
+            <a:schemeClr val="accent1"/>
+          </a:effectRef>
+          <a:fontRef idx="minor">
+            <a:schemeClr val="tx1"/>
+          </a:fontRef>
+        </p:style>
+      </p:cxnSp>
+      <p:sp>
+        <p:nvSpPr>
+          <p:cNvPr id="36" name="AutoShape 13">
+            <a:extLst>
+              <a:ext uri="{FF2B5EF4-FFF2-40B4-BE49-F238E27FC236}">
+                <a16:creationId xmlns:a16="http://schemas.microsoft.com/office/drawing/2014/main" id="{CCF9E2EC-1E7B-DB39-289C-77C8A1C62207}"/>
+              </a:ext>
+            </a:extLst>
+          </p:cNvPr>
+          <p:cNvSpPr>
+            <a:spLocks noChangeArrowheads="1"/>
+          </p:cNvSpPr>
+          <p:nvPr/>
+        </p:nvSpPr>
+        <p:spPr bwMode="auto">
+          <a:xfrm>
+            <a:off x="3931920" y="2875013"/>
+            <a:ext cx="1360853" cy="343674"/>
+          </a:xfrm>
+          <a:prstGeom prst="roundRect">
+            <a:avLst>
+              <a:gd name="adj" fmla="val 16667"/>
+            </a:avLst>
+          </a:prstGeom>
+          <a:solidFill>
+            <a:schemeClr val="bg1"/>
+          </a:solidFill>
+          <a:ln w="12700">
+            <a:solidFill>
+              <a:srgbClr val="09101D"/>
+            </a:solidFill>
+            <a:miter lim="800000"/>
+            <a:headEnd/>
+            <a:tailEnd/>
+          </a:ln>
+        </p:spPr>
+        <p:txBody>
+          <a:bodyPr vert="horz" wrap="square" lIns="91440" tIns="45720" rIns="91440" bIns="45720" numCol="1" anchor="ctr" anchorCtr="0" compatLnSpc="1">
+            <a:prstTxWarp prst="textNoShape">
+              <a:avLst/>
+            </a:prstTxWarp>
+          </a:bodyPr>
+          <a:lstStyle/>
+          <a:p>
+            <a:pPr marL="0" marR="0" lvl="0" indent="0" algn="ctr" defTabSz="914400" rtl="0" eaLnBrk="0" fontAlgn="base" latinLnBrk="0" hangingPunct="0">
+              <a:lnSpc>
+                <a:spcPct val="100000"/>
+              </a:lnSpc>
+              <a:spcBef>
+                <a:spcPct val="0"/>
+              </a:spcBef>
+              <a:spcAft>
+                <a:spcPct val="0"/>
+              </a:spcAft>
+              <a:buClrTx/>
+              <a:buSzTx/>
+              <a:buFontTx/>
+              <a:buNone/>
+              <a:tabLst/>
+            </a:pPr>
+            <a:r>
+              <a:rPr kumimoji="0" lang="en-US" altLang="en-IL" b="0" i="0" u="none" strike="noStrike" cap="none" normalizeH="0" baseline="0" dirty="0">
+                <a:ln>
+                  <a:noFill/>
+                </a:ln>
+                <a:solidFill>
+                  <a:schemeClr val="tx1"/>
+                </a:solidFill>
+                <a:effectLst/>
+                <a:latin typeface="Calibri" panose="020F0502020204030204" pitchFamily="34" charset="0"/>
+                <a:ea typeface="Yu Gothic" panose="020B0400000000000000" pitchFamily="34" charset="-128"/>
+                <a:cs typeface="Arial" panose="020B0604020202020204" pitchFamily="34" charset="0"/>
+              </a:rPr>
+              <a:t>Controllers</a:t>
+            </a:r>
+            <a:endParaRPr kumimoji="0" lang="en-IL" altLang="en-IL" sz="4000" b="0" i="0" u="none" strike="noStrike" cap="none" normalizeH="0" baseline="0" dirty="0">
+              <a:ln>
+                <a:noFill/>
+              </a:ln>
+              <a:solidFill>
+                <a:schemeClr val="tx1"/>
+              </a:solidFill>
+              <a:effectLst/>
+              <a:latin typeface="Arial" panose="020B0604020202020204" pitchFamily="34" charset="0"/>
+            </a:endParaRPr>
+          </a:p>
+        </p:txBody>
+      </p:sp>
+      <p:cxnSp>
+        <p:nvCxnSpPr>
+          <p:cNvPr id="37" name="Straight Connector 36">
+            <a:extLst>
+              <a:ext uri="{FF2B5EF4-FFF2-40B4-BE49-F238E27FC236}">
+                <a16:creationId xmlns:a16="http://schemas.microsoft.com/office/drawing/2014/main" id="{FA71ECA9-6020-2668-0F61-288DC1B9B85A}"/>
+              </a:ext>
+            </a:extLst>
+          </p:cNvPr>
+          <p:cNvCxnSpPr>
+            <a:cxnSpLocks/>
+          </p:cNvCxnSpPr>
+          <p:nvPr/>
+        </p:nvCxnSpPr>
+        <p:spPr>
+          <a:xfrm>
+            <a:off x="3005091" y="3052916"/>
+            <a:ext cx="926829" cy="0"/>
+          </a:xfrm>
+          <a:prstGeom prst="line">
+            <a:avLst/>
+          </a:prstGeom>
+        </p:spPr>
+        <p:style>
+          <a:lnRef idx="2">
+            <a:schemeClr val="accent1"/>
+          </a:lnRef>
+          <a:fillRef idx="0">
+            <a:schemeClr val="accent1"/>
+          </a:fillRef>
+          <a:effectRef idx="1">
+            <a:schemeClr val="accent1"/>
+          </a:effectRef>
+          <a:fontRef idx="minor">
+            <a:schemeClr val="tx1"/>
+          </a:fontRef>
+        </p:style>
+      </p:cxnSp>
+      <p:sp>
+        <p:nvSpPr>
+          <p:cNvPr id="39" name="AutoShape 13">
+            <a:extLst>
+              <a:ext uri="{FF2B5EF4-FFF2-40B4-BE49-F238E27FC236}">
+                <a16:creationId xmlns:a16="http://schemas.microsoft.com/office/drawing/2014/main" id="{8F8E0109-A987-3884-2AAF-A55E71AC3CAD}"/>
+              </a:ext>
+            </a:extLst>
+          </p:cNvPr>
+          <p:cNvSpPr>
+            <a:spLocks noChangeArrowheads="1"/>
+          </p:cNvSpPr>
+          <p:nvPr/>
+        </p:nvSpPr>
+        <p:spPr bwMode="auto">
+          <a:xfrm>
+            <a:off x="3931920" y="3293553"/>
+            <a:ext cx="1360853" cy="343674"/>
+          </a:xfrm>
+          <a:prstGeom prst="roundRect">
+            <a:avLst>
+              <a:gd name="adj" fmla="val 16667"/>
+            </a:avLst>
+          </a:prstGeom>
+          <a:solidFill>
+            <a:schemeClr val="bg1"/>
+          </a:solidFill>
+          <a:ln w="12700">
+            <a:solidFill>
+              <a:srgbClr val="09101D"/>
+            </a:solidFill>
+            <a:miter lim="800000"/>
+            <a:headEnd/>
+            <a:tailEnd/>
+          </a:ln>
+        </p:spPr>
+        <p:txBody>
+          <a:bodyPr vert="horz" wrap="square" lIns="91440" tIns="45720" rIns="91440" bIns="45720" numCol="1" anchor="ctr" anchorCtr="0" compatLnSpc="1">
+            <a:prstTxWarp prst="textNoShape">
+              <a:avLst/>
+            </a:prstTxWarp>
+          </a:bodyPr>
+          <a:lstStyle/>
+          <a:p>
+            <a:pPr marL="0" marR="0" lvl="0" indent="0" algn="ctr" defTabSz="914400" rtl="0" eaLnBrk="0" fontAlgn="base" latinLnBrk="0" hangingPunct="0">
+              <a:lnSpc>
+                <a:spcPct val="100000"/>
+              </a:lnSpc>
+              <a:spcBef>
+                <a:spcPct val="0"/>
+              </a:spcBef>
+              <a:spcAft>
+                <a:spcPct val="0"/>
+              </a:spcAft>
+              <a:buClrTx/>
+              <a:buSzTx/>
+              <a:buFontTx/>
+              <a:buNone/>
+              <a:tabLst/>
+            </a:pPr>
+            <a:r>
+              <a:rPr kumimoji="0" lang="en-US" altLang="en-IL" b="0" i="0" u="none" strike="noStrike" cap="none" normalizeH="0" baseline="0" dirty="0">
+                <a:ln>
+                  <a:noFill/>
+                </a:ln>
+                <a:solidFill>
+                  <a:schemeClr val="tx1"/>
+                </a:solidFill>
+                <a:effectLst/>
+                <a:latin typeface="Calibri" panose="020F0502020204030204" pitchFamily="34" charset="0"/>
+                <a:ea typeface="Yu Gothic" panose="020B0400000000000000" pitchFamily="34" charset="-128"/>
+                <a:cs typeface="Arial" panose="020B0604020202020204" pitchFamily="34" charset="0"/>
+              </a:rPr>
+              <a:t>Data</a:t>
+            </a:r>
+            <a:endParaRPr kumimoji="0" lang="en-IL" altLang="en-IL" sz="4000" b="0" i="0" u="none" strike="noStrike" cap="none" normalizeH="0" baseline="0" dirty="0">
+              <a:ln>
+                <a:noFill/>
+              </a:ln>
+              <a:solidFill>
+                <a:schemeClr val="tx1"/>
+              </a:solidFill>
+              <a:effectLst/>
+              <a:latin typeface="Arial" panose="020B0604020202020204" pitchFamily="34" charset="0"/>
+            </a:endParaRPr>
+          </a:p>
+        </p:txBody>
+      </p:sp>
+      <p:cxnSp>
+        <p:nvCxnSpPr>
+          <p:cNvPr id="40" name="Straight Connector 39">
+            <a:extLst>
+              <a:ext uri="{FF2B5EF4-FFF2-40B4-BE49-F238E27FC236}">
+                <a16:creationId xmlns:a16="http://schemas.microsoft.com/office/drawing/2014/main" id="{F73FF06F-D158-D932-7EE8-5D76C7893249}"/>
+              </a:ext>
+            </a:extLst>
+          </p:cNvPr>
+          <p:cNvCxnSpPr>
+            <a:cxnSpLocks/>
+          </p:cNvCxnSpPr>
+          <p:nvPr/>
+        </p:nvCxnSpPr>
+        <p:spPr>
+          <a:xfrm>
+            <a:off x="3005091" y="3471456"/>
+            <a:ext cx="926829" cy="0"/>
+          </a:xfrm>
+          <a:prstGeom prst="line">
+            <a:avLst/>
+          </a:prstGeom>
+        </p:spPr>
+        <p:style>
+          <a:lnRef idx="2">
+            <a:schemeClr val="accent1"/>
+          </a:lnRef>
+          <a:fillRef idx="0">
+            <a:schemeClr val="accent1"/>
+          </a:fillRef>
+          <a:effectRef idx="1">
+            <a:schemeClr val="accent1"/>
+          </a:effectRef>
+          <a:fontRef idx="minor">
+            <a:schemeClr val="tx1"/>
+          </a:fontRef>
+        </p:style>
+      </p:cxnSp>
+      <p:sp>
+        <p:nvSpPr>
+          <p:cNvPr id="41" name="AutoShape 13">
+            <a:extLst>
+              <a:ext uri="{FF2B5EF4-FFF2-40B4-BE49-F238E27FC236}">
+                <a16:creationId xmlns:a16="http://schemas.microsoft.com/office/drawing/2014/main" id="{2A734496-13E5-C552-4657-6D89DA0A227F}"/>
+              </a:ext>
+            </a:extLst>
+          </p:cNvPr>
+          <p:cNvSpPr>
+            <a:spLocks noChangeArrowheads="1"/>
+          </p:cNvSpPr>
+          <p:nvPr/>
+        </p:nvSpPr>
+        <p:spPr bwMode="auto">
+          <a:xfrm>
+            <a:off x="3931920" y="3712731"/>
+            <a:ext cx="1360853" cy="343674"/>
+          </a:xfrm>
+          <a:prstGeom prst="roundRect">
+            <a:avLst>
+              <a:gd name="adj" fmla="val 16667"/>
+            </a:avLst>
+          </a:prstGeom>
+          <a:solidFill>
+            <a:schemeClr val="bg1"/>
+          </a:solidFill>
+          <a:ln w="12700">
+            <a:solidFill>
+              <a:srgbClr val="09101D"/>
+            </a:solidFill>
+            <a:miter lim="800000"/>
+            <a:headEnd/>
+            <a:tailEnd/>
+          </a:ln>
+        </p:spPr>
+        <p:txBody>
+          <a:bodyPr vert="horz" wrap="square" lIns="91440" tIns="45720" rIns="91440" bIns="45720" numCol="1" anchor="ctr" anchorCtr="0" compatLnSpc="1">
+            <a:prstTxWarp prst="textNoShape">
+              <a:avLst/>
+            </a:prstTxWarp>
+          </a:bodyPr>
+          <a:lstStyle/>
+          <a:p>
+            <a:pPr marL="0" marR="0" lvl="0" indent="0" algn="ctr" defTabSz="914400" rtl="0" eaLnBrk="0" fontAlgn="base" latinLnBrk="0" hangingPunct="0">
+              <a:lnSpc>
+                <a:spcPct val="100000"/>
+              </a:lnSpc>
+              <a:spcBef>
+                <a:spcPct val="0"/>
+              </a:spcBef>
+              <a:spcAft>
+                <a:spcPct val="0"/>
+              </a:spcAft>
+              <a:buClrTx/>
+              <a:buSzTx/>
+              <a:buFontTx/>
+              <a:buNone/>
+              <a:tabLst/>
+            </a:pPr>
+            <a:r>
+              <a:rPr kumimoji="0" lang="en-US" altLang="en-IL" b="0" i="0" u="none" strike="noStrike" cap="none" normalizeH="0" baseline="0" dirty="0">
+                <a:ln>
+                  <a:noFill/>
+                </a:ln>
+                <a:solidFill>
+                  <a:schemeClr val="tx1"/>
+                </a:solidFill>
+                <a:effectLst/>
+                <a:latin typeface="Calibri" panose="020F0502020204030204" pitchFamily="34" charset="0"/>
+                <a:ea typeface="Yu Gothic" panose="020B0400000000000000" pitchFamily="34" charset="-128"/>
+                <a:cs typeface="Arial" panose="020B0604020202020204" pitchFamily="34" charset="0"/>
+              </a:rPr>
+              <a:t>DTOs</a:t>
+            </a:r>
+            <a:endParaRPr kumimoji="0" lang="en-IL" altLang="en-IL" sz="4000" b="0" i="0" u="none" strike="noStrike" cap="none" normalizeH="0" baseline="0" dirty="0">
+              <a:ln>
+                <a:noFill/>
+              </a:ln>
+              <a:solidFill>
+                <a:schemeClr val="tx1"/>
+              </a:solidFill>
+              <a:effectLst/>
+              <a:latin typeface="Arial" panose="020B0604020202020204" pitchFamily="34" charset="0"/>
+            </a:endParaRPr>
+          </a:p>
+        </p:txBody>
+      </p:sp>
+      <p:cxnSp>
+        <p:nvCxnSpPr>
+          <p:cNvPr id="42" name="Straight Connector 41">
+            <a:extLst>
+              <a:ext uri="{FF2B5EF4-FFF2-40B4-BE49-F238E27FC236}">
+                <a16:creationId xmlns:a16="http://schemas.microsoft.com/office/drawing/2014/main" id="{CC6E8A8C-157D-F611-36B4-A162546C1B01}"/>
+              </a:ext>
+            </a:extLst>
+          </p:cNvPr>
+          <p:cNvCxnSpPr>
+            <a:cxnSpLocks/>
+          </p:cNvCxnSpPr>
+          <p:nvPr/>
+        </p:nvCxnSpPr>
+        <p:spPr>
+          <a:xfrm>
+            <a:off x="3005091" y="3890634"/>
+            <a:ext cx="926829" cy="0"/>
+          </a:xfrm>
+          <a:prstGeom prst="line">
+            <a:avLst/>
+          </a:prstGeom>
+        </p:spPr>
+        <p:style>
+          <a:lnRef idx="2">
+            <a:schemeClr val="accent1"/>
+          </a:lnRef>
+          <a:fillRef idx="0">
+            <a:schemeClr val="accent1"/>
+          </a:fillRef>
+          <a:effectRef idx="1">
+            <a:schemeClr val="accent1"/>
+          </a:effectRef>
+          <a:fontRef idx="minor">
+            <a:schemeClr val="tx1"/>
+          </a:fontRef>
+        </p:style>
+      </p:cxnSp>
+      <p:sp>
+        <p:nvSpPr>
+          <p:cNvPr id="43" name="AutoShape 13">
+            <a:extLst>
+              <a:ext uri="{FF2B5EF4-FFF2-40B4-BE49-F238E27FC236}">
+                <a16:creationId xmlns:a16="http://schemas.microsoft.com/office/drawing/2014/main" id="{5933977B-1DB3-63B2-5784-1EEAD9086AF0}"/>
+              </a:ext>
+            </a:extLst>
+          </p:cNvPr>
+          <p:cNvSpPr>
+            <a:spLocks noChangeArrowheads="1"/>
+          </p:cNvSpPr>
+          <p:nvPr/>
+        </p:nvSpPr>
+        <p:spPr bwMode="auto">
+          <a:xfrm>
+            <a:off x="3947160" y="4133837"/>
+            <a:ext cx="1360853" cy="343674"/>
+          </a:xfrm>
+          <a:prstGeom prst="roundRect">
+            <a:avLst>
+              <a:gd name="adj" fmla="val 16667"/>
+            </a:avLst>
+          </a:prstGeom>
+          <a:solidFill>
+            <a:schemeClr val="bg1"/>
+          </a:solidFill>
+          <a:ln w="12700">
+            <a:solidFill>
+              <a:srgbClr val="09101D"/>
+            </a:solidFill>
+            <a:miter lim="800000"/>
+            <a:headEnd/>
+            <a:tailEnd/>
+          </a:ln>
+        </p:spPr>
+        <p:txBody>
+          <a:bodyPr vert="horz" wrap="square" lIns="91440" tIns="45720" rIns="91440" bIns="45720" numCol="1" anchor="ctr" anchorCtr="0" compatLnSpc="1">
+            <a:prstTxWarp prst="textNoShape">
+              <a:avLst/>
+            </a:prstTxWarp>
+          </a:bodyPr>
+          <a:lstStyle/>
+          <a:p>
+            <a:pPr marL="0" marR="0" lvl="0" indent="0" algn="ctr" defTabSz="914400" rtl="0" eaLnBrk="0" fontAlgn="base" latinLnBrk="0" hangingPunct="0">
+              <a:lnSpc>
+                <a:spcPct val="100000"/>
+              </a:lnSpc>
+              <a:spcBef>
+                <a:spcPct val="0"/>
+              </a:spcBef>
+              <a:spcAft>
+                <a:spcPct val="0"/>
+              </a:spcAft>
+              <a:buClrTx/>
+              <a:buSzTx/>
+              <a:buFontTx/>
+              <a:buNone/>
+              <a:tabLst/>
+            </a:pPr>
+            <a:r>
+              <a:rPr kumimoji="0" lang="en-US" altLang="en-IL" b="0" i="0" u="none" strike="noStrike" cap="none" normalizeH="0" baseline="0" dirty="0">
+                <a:ln>
+                  <a:noFill/>
+                </a:ln>
+                <a:solidFill>
+                  <a:schemeClr val="tx1"/>
+                </a:solidFill>
+                <a:effectLst/>
+                <a:latin typeface="Calibri" panose="020F0502020204030204" pitchFamily="34" charset="0"/>
+                <a:ea typeface="Yu Gothic" panose="020B0400000000000000" pitchFamily="34" charset="-128"/>
+                <a:cs typeface="Arial" panose="020B0604020202020204" pitchFamily="34" charset="0"/>
+              </a:rPr>
+              <a:t>Migrations</a:t>
+            </a:r>
+            <a:endParaRPr kumimoji="0" lang="en-IL" altLang="en-IL" sz="4000" b="0" i="0" u="none" strike="noStrike" cap="none" normalizeH="0" baseline="0" dirty="0">
+              <a:ln>
+                <a:noFill/>
+              </a:ln>
+              <a:solidFill>
+                <a:schemeClr val="tx1"/>
+              </a:solidFill>
+              <a:effectLst/>
+              <a:latin typeface="Arial" panose="020B0604020202020204" pitchFamily="34" charset="0"/>
+            </a:endParaRPr>
+          </a:p>
+        </p:txBody>
+      </p:sp>
+      <p:cxnSp>
+        <p:nvCxnSpPr>
+          <p:cNvPr id="44" name="Straight Connector 43">
+            <a:extLst>
+              <a:ext uri="{FF2B5EF4-FFF2-40B4-BE49-F238E27FC236}">
+                <a16:creationId xmlns:a16="http://schemas.microsoft.com/office/drawing/2014/main" id="{0981965D-7B11-335C-EF5A-F7521F817921}"/>
+              </a:ext>
+            </a:extLst>
+          </p:cNvPr>
+          <p:cNvCxnSpPr>
+            <a:cxnSpLocks/>
+          </p:cNvCxnSpPr>
+          <p:nvPr/>
+        </p:nvCxnSpPr>
+        <p:spPr>
+          <a:xfrm>
+            <a:off x="3020331" y="4311740"/>
+            <a:ext cx="926829" cy="0"/>
+          </a:xfrm>
+          <a:prstGeom prst="line">
+            <a:avLst/>
+          </a:prstGeom>
+        </p:spPr>
+        <p:style>
+          <a:lnRef idx="2">
+            <a:schemeClr val="accent1"/>
+          </a:lnRef>
+          <a:fillRef idx="0">
+            <a:schemeClr val="accent1"/>
+          </a:fillRef>
+          <a:effectRef idx="1">
+            <a:schemeClr val="accent1"/>
+          </a:effectRef>
+          <a:fontRef idx="minor">
+            <a:schemeClr val="tx1"/>
+          </a:fontRef>
+        </p:style>
+      </p:cxnSp>
+      <p:sp>
+        <p:nvSpPr>
+          <p:cNvPr id="45" name="AutoShape 13">
+            <a:extLst>
+              <a:ext uri="{FF2B5EF4-FFF2-40B4-BE49-F238E27FC236}">
+                <a16:creationId xmlns:a16="http://schemas.microsoft.com/office/drawing/2014/main" id="{E9F760B8-FB4B-4A4B-BABE-2BF40D33C5E5}"/>
+              </a:ext>
+            </a:extLst>
+          </p:cNvPr>
+          <p:cNvSpPr>
+            <a:spLocks noChangeArrowheads="1"/>
+          </p:cNvSpPr>
+          <p:nvPr/>
+        </p:nvSpPr>
+        <p:spPr bwMode="auto">
+          <a:xfrm>
+            <a:off x="3947160" y="4552377"/>
+            <a:ext cx="1360853" cy="343674"/>
+          </a:xfrm>
+          <a:prstGeom prst="roundRect">
+            <a:avLst>
+              <a:gd name="adj" fmla="val 16667"/>
+            </a:avLst>
+          </a:prstGeom>
+          <a:solidFill>
+            <a:schemeClr val="bg1"/>
+          </a:solidFill>
+          <a:ln w="12700">
+            <a:solidFill>
+              <a:srgbClr val="09101D"/>
+            </a:solidFill>
+            <a:miter lim="800000"/>
+            <a:headEnd/>
+            <a:tailEnd/>
+          </a:ln>
+        </p:spPr>
+        <p:txBody>
+          <a:bodyPr vert="horz" wrap="square" lIns="91440" tIns="45720" rIns="91440" bIns="45720" numCol="1" anchor="ctr" anchorCtr="0" compatLnSpc="1">
+            <a:prstTxWarp prst="textNoShape">
+              <a:avLst/>
+            </a:prstTxWarp>
+          </a:bodyPr>
+          <a:lstStyle/>
+          <a:p>
+            <a:pPr marL="0" marR="0" lvl="0" indent="0" algn="ctr" defTabSz="914400" rtl="0" eaLnBrk="0" fontAlgn="base" latinLnBrk="0" hangingPunct="0">
+              <a:lnSpc>
+                <a:spcPct val="100000"/>
+              </a:lnSpc>
+              <a:spcBef>
+                <a:spcPct val="0"/>
+              </a:spcBef>
+              <a:spcAft>
+                <a:spcPct val="0"/>
+              </a:spcAft>
+              <a:buClrTx/>
+              <a:buSzTx/>
+              <a:buFontTx/>
+              <a:buNone/>
+              <a:tabLst/>
+            </a:pPr>
+            <a:r>
+              <a:rPr kumimoji="0" lang="en-US" altLang="en-IL" b="0" i="0" u="none" strike="noStrike" cap="none" normalizeH="0" baseline="0" dirty="0">
+                <a:ln>
+                  <a:noFill/>
+                </a:ln>
+                <a:solidFill>
+                  <a:schemeClr val="tx1"/>
+                </a:solidFill>
+                <a:effectLst/>
+                <a:latin typeface="Calibri" panose="020F0502020204030204" pitchFamily="34" charset="0"/>
+                <a:ea typeface="Yu Gothic" panose="020B0400000000000000" pitchFamily="34" charset="-128"/>
+                <a:cs typeface="Arial" panose="020B0604020202020204" pitchFamily="34" charset="0"/>
+              </a:rPr>
+              <a:t>Models</a:t>
+            </a:r>
+            <a:endParaRPr kumimoji="0" lang="en-IL" altLang="en-IL" sz="4000" b="0" i="0" u="none" strike="noStrike" cap="none" normalizeH="0" baseline="0" dirty="0">
+              <a:ln>
+                <a:noFill/>
+              </a:ln>
+              <a:solidFill>
+                <a:schemeClr val="tx1"/>
+              </a:solidFill>
+              <a:effectLst/>
+              <a:latin typeface="Arial" panose="020B0604020202020204" pitchFamily="34" charset="0"/>
+            </a:endParaRPr>
+          </a:p>
+        </p:txBody>
+      </p:sp>
+      <p:sp>
+        <p:nvSpPr>
+          <p:cNvPr id="46" name="AutoShape 13">
+            <a:extLst>
+              <a:ext uri="{FF2B5EF4-FFF2-40B4-BE49-F238E27FC236}">
+                <a16:creationId xmlns:a16="http://schemas.microsoft.com/office/drawing/2014/main" id="{42836964-E83A-B3D7-BB20-15372CAA0FA3}"/>
+              </a:ext>
+            </a:extLst>
+          </p:cNvPr>
+          <p:cNvSpPr>
+            <a:spLocks noChangeArrowheads="1"/>
+          </p:cNvSpPr>
+          <p:nvPr/>
+        </p:nvSpPr>
+        <p:spPr bwMode="auto">
+          <a:xfrm>
+            <a:off x="3947160" y="4971555"/>
+            <a:ext cx="1360853" cy="343674"/>
+          </a:xfrm>
+          <a:prstGeom prst="roundRect">
+            <a:avLst>
+              <a:gd name="adj" fmla="val 16667"/>
+            </a:avLst>
+          </a:prstGeom>
+          <a:solidFill>
+            <a:schemeClr val="bg1"/>
+          </a:solidFill>
+          <a:ln w="12700">
+            <a:solidFill>
+              <a:srgbClr val="09101D"/>
+            </a:solidFill>
+            <a:miter lim="800000"/>
+            <a:headEnd/>
+            <a:tailEnd/>
+          </a:ln>
+        </p:spPr>
+        <p:txBody>
+          <a:bodyPr vert="horz" wrap="square" lIns="91440" tIns="45720" rIns="91440" bIns="45720" numCol="1" anchor="ctr" anchorCtr="0" compatLnSpc="1">
+            <a:prstTxWarp prst="textNoShape">
+              <a:avLst/>
+            </a:prstTxWarp>
+          </a:bodyPr>
+          <a:lstStyle/>
+          <a:p>
+            <a:pPr marL="0" marR="0" lvl="0" indent="0" algn="ctr" defTabSz="914400" rtl="0" eaLnBrk="0" fontAlgn="base" latinLnBrk="0" hangingPunct="0">
+              <a:lnSpc>
+                <a:spcPct val="100000"/>
+              </a:lnSpc>
+              <a:spcBef>
+                <a:spcPct val="0"/>
+              </a:spcBef>
+              <a:spcAft>
+                <a:spcPct val="0"/>
+              </a:spcAft>
+              <a:buClrTx/>
+              <a:buSzTx/>
+              <a:buFontTx/>
+              <a:buNone/>
+              <a:tabLst/>
+            </a:pPr>
+            <a:r>
+              <a:rPr kumimoji="0" lang="en-US" altLang="en-IL" b="0" i="0" u="none" strike="noStrike" cap="none" normalizeH="0" baseline="0" dirty="0">
+                <a:ln>
+                  <a:noFill/>
+                </a:ln>
+                <a:solidFill>
+                  <a:schemeClr val="tx1"/>
+                </a:solidFill>
+                <a:effectLst/>
+                <a:latin typeface="Calibri" panose="020F0502020204030204" pitchFamily="34" charset="0"/>
+                <a:ea typeface="Yu Gothic" panose="020B0400000000000000" pitchFamily="34" charset="-128"/>
+                <a:cs typeface="Arial" panose="020B0604020202020204" pitchFamily="34" charset="0"/>
+              </a:rPr>
+              <a:t>Properties</a:t>
+            </a:r>
+            <a:endParaRPr kumimoji="0" lang="en-IL" altLang="en-IL" sz="4000" b="0" i="0" u="none" strike="noStrike" cap="none" normalizeH="0" baseline="0" dirty="0">
+              <a:ln>
+                <a:noFill/>
+              </a:ln>
+              <a:solidFill>
+                <a:schemeClr val="tx1"/>
+              </a:solidFill>
+              <a:effectLst/>
+              <a:latin typeface="Arial" panose="020B0604020202020204" pitchFamily="34" charset="0"/>
+            </a:endParaRPr>
+          </a:p>
+        </p:txBody>
+      </p:sp>
+      <p:cxnSp>
+        <p:nvCxnSpPr>
+          <p:cNvPr id="47" name="Straight Connector 46">
+            <a:extLst>
+              <a:ext uri="{FF2B5EF4-FFF2-40B4-BE49-F238E27FC236}">
+                <a16:creationId xmlns:a16="http://schemas.microsoft.com/office/drawing/2014/main" id="{FB9F25E6-DF5D-3A72-F754-0F0447644D2F}"/>
+              </a:ext>
+            </a:extLst>
+          </p:cNvPr>
+          <p:cNvCxnSpPr>
+            <a:cxnSpLocks/>
+          </p:cNvCxnSpPr>
+          <p:nvPr/>
+        </p:nvCxnSpPr>
+        <p:spPr>
+          <a:xfrm>
+            <a:off x="3020331" y="5149458"/>
+            <a:ext cx="926829" cy="0"/>
+          </a:xfrm>
+          <a:prstGeom prst="line">
+            <a:avLst/>
+          </a:prstGeom>
+        </p:spPr>
+        <p:style>
+          <a:lnRef idx="2">
+            <a:schemeClr val="accent1"/>
+          </a:lnRef>
+          <a:fillRef idx="0">
+            <a:schemeClr val="accent1"/>
+          </a:fillRef>
+          <a:effectRef idx="1">
+            <a:schemeClr val="accent1"/>
+          </a:effectRef>
+          <a:fontRef idx="minor">
+            <a:schemeClr val="tx1"/>
+          </a:fontRef>
+        </p:style>
+      </p:cxnSp>
+      <p:cxnSp>
+        <p:nvCxnSpPr>
+          <p:cNvPr id="48" name="Straight Connector 47">
+            <a:extLst>
+              <a:ext uri="{FF2B5EF4-FFF2-40B4-BE49-F238E27FC236}">
+                <a16:creationId xmlns:a16="http://schemas.microsoft.com/office/drawing/2014/main" id="{10FF5E8C-87F0-8001-0491-F0E429B85F20}"/>
+              </a:ext>
+            </a:extLst>
+          </p:cNvPr>
+          <p:cNvCxnSpPr>
+            <a:cxnSpLocks/>
+          </p:cNvCxnSpPr>
+          <p:nvPr/>
+        </p:nvCxnSpPr>
+        <p:spPr>
+          <a:xfrm>
+            <a:off x="3020331" y="4719690"/>
+            <a:ext cx="926829" cy="0"/>
+          </a:xfrm>
+          <a:prstGeom prst="line">
+            <a:avLst/>
+          </a:prstGeom>
+        </p:spPr>
+        <p:style>
+          <a:lnRef idx="2">
+            <a:schemeClr val="accent1"/>
+          </a:lnRef>
+          <a:fillRef idx="0">
+            <a:schemeClr val="accent1"/>
+          </a:fillRef>
+          <a:effectRef idx="1">
+            <a:schemeClr val="accent1"/>
+          </a:effectRef>
+          <a:fontRef idx="minor">
+            <a:schemeClr val="tx1"/>
+          </a:fontRef>
+        </p:style>
+      </p:cxnSp>
     </p:spTree>
     <p:extLst>
       <p:ext uri="{BB962C8B-B14F-4D97-AF65-F5344CB8AC3E}">

</xml_diff>

<commit_message>
Initial commit - microservices structure
</commit_message>
<xml_diff>
--- a/Documentations/SysArchitecture.pptx
+++ b/Documentations/SysArchitecture.pptx
@@ -8,10 +8,12 @@
     <p:sldId id="256" r:id="rId2"/>
     <p:sldId id="266" r:id="rId3"/>
     <p:sldId id="261" r:id="rId4"/>
-    <p:sldId id="262" r:id="rId5"/>
-    <p:sldId id="264" r:id="rId6"/>
-    <p:sldId id="267" r:id="rId7"/>
-    <p:sldId id="265" r:id="rId8"/>
+    <p:sldId id="268" r:id="rId5"/>
+    <p:sldId id="269" r:id="rId6"/>
+    <p:sldId id="262" r:id="rId7"/>
+    <p:sldId id="264" r:id="rId8"/>
+    <p:sldId id="267" r:id="rId9"/>
+    <p:sldId id="265" r:id="rId10"/>
   </p:sldIdLst>
   <p:sldSz cx="12192000" cy="6858000"/>
   <p:notesSz cx="6858000" cy="9144000"/>
@@ -267,7 +269,7 @@
           <a:p>
             <a:fld id="{8377380A-1819-462E-96FD-3D6CBD777CA0}" type="datetimeFigureOut">
               <a:rPr lang="en-IL" smtClean="0"/>
-              <a:t>15/08/2025</a:t>
+              <a:t>16/08/2025</a:t>
             </a:fld>
             <a:endParaRPr lang="en-IL"/>
           </a:p>
@@ -467,7 +469,7 @@
           <a:p>
             <a:fld id="{8377380A-1819-462E-96FD-3D6CBD777CA0}" type="datetimeFigureOut">
               <a:rPr lang="en-IL" smtClean="0"/>
-              <a:t>15/08/2025</a:t>
+              <a:t>16/08/2025</a:t>
             </a:fld>
             <a:endParaRPr lang="en-IL"/>
           </a:p>
@@ -677,7 +679,7 @@
           <a:p>
             <a:fld id="{8377380A-1819-462E-96FD-3D6CBD777CA0}" type="datetimeFigureOut">
               <a:rPr lang="en-IL" smtClean="0"/>
-              <a:t>15/08/2025</a:t>
+              <a:t>16/08/2025</a:t>
             </a:fld>
             <a:endParaRPr lang="en-IL"/>
           </a:p>
@@ -877,7 +879,7 @@
           <a:p>
             <a:fld id="{8377380A-1819-462E-96FD-3D6CBD777CA0}" type="datetimeFigureOut">
               <a:rPr lang="en-IL" smtClean="0"/>
-              <a:t>15/08/2025</a:t>
+              <a:t>16/08/2025</a:t>
             </a:fld>
             <a:endParaRPr lang="en-IL"/>
           </a:p>
@@ -1153,7 +1155,7 @@
           <a:p>
             <a:fld id="{8377380A-1819-462E-96FD-3D6CBD777CA0}" type="datetimeFigureOut">
               <a:rPr lang="en-IL" smtClean="0"/>
-              <a:t>15/08/2025</a:t>
+              <a:t>16/08/2025</a:t>
             </a:fld>
             <a:endParaRPr lang="en-IL"/>
           </a:p>
@@ -1421,7 +1423,7 @@
           <a:p>
             <a:fld id="{8377380A-1819-462E-96FD-3D6CBD777CA0}" type="datetimeFigureOut">
               <a:rPr lang="en-IL" smtClean="0"/>
-              <a:t>15/08/2025</a:t>
+              <a:t>16/08/2025</a:t>
             </a:fld>
             <a:endParaRPr lang="en-IL"/>
           </a:p>
@@ -1836,7 +1838,7 @@
           <a:p>
             <a:fld id="{8377380A-1819-462E-96FD-3D6CBD777CA0}" type="datetimeFigureOut">
               <a:rPr lang="en-IL" smtClean="0"/>
-              <a:t>15/08/2025</a:t>
+              <a:t>16/08/2025</a:t>
             </a:fld>
             <a:endParaRPr lang="en-IL"/>
           </a:p>
@@ -1978,7 +1980,7 @@
           <a:p>
             <a:fld id="{8377380A-1819-462E-96FD-3D6CBD777CA0}" type="datetimeFigureOut">
               <a:rPr lang="en-IL" smtClean="0"/>
-              <a:t>15/08/2025</a:t>
+              <a:t>16/08/2025</a:t>
             </a:fld>
             <a:endParaRPr lang="en-IL"/>
           </a:p>
@@ -2091,7 +2093,7 @@
           <a:p>
             <a:fld id="{8377380A-1819-462E-96FD-3D6CBD777CA0}" type="datetimeFigureOut">
               <a:rPr lang="en-IL" smtClean="0"/>
-              <a:t>15/08/2025</a:t>
+              <a:t>16/08/2025</a:t>
             </a:fld>
             <a:endParaRPr lang="en-IL"/>
           </a:p>
@@ -2404,7 +2406,7 @@
           <a:p>
             <a:fld id="{8377380A-1819-462E-96FD-3D6CBD777CA0}" type="datetimeFigureOut">
               <a:rPr lang="en-IL" smtClean="0"/>
-              <a:t>15/08/2025</a:t>
+              <a:t>16/08/2025</a:t>
             </a:fld>
             <a:endParaRPr lang="en-IL"/>
           </a:p>
@@ -2693,7 +2695,7 @@
           <a:p>
             <a:fld id="{8377380A-1819-462E-96FD-3D6CBD777CA0}" type="datetimeFigureOut">
               <a:rPr lang="en-IL" smtClean="0"/>
-              <a:t>15/08/2025</a:t>
+              <a:t>16/08/2025</a:t>
             </a:fld>
             <a:endParaRPr lang="en-IL"/>
           </a:p>
@@ -2936,7 +2938,7 @@
           <a:p>
             <a:fld id="{8377380A-1819-462E-96FD-3D6CBD777CA0}" type="datetimeFigureOut">
               <a:rPr lang="en-IL" smtClean="0"/>
-              <a:t>15/08/2025</a:t>
+              <a:t>16/08/2025</a:t>
             </a:fld>
             <a:endParaRPr lang="en-IL"/>
           </a:p>
@@ -8585,6 +8587,1609 @@
           <a:chExt cx="0" cy="0"/>
         </a:xfrm>
       </p:grpSpPr>
+      <p:sp>
+        <p:nvSpPr>
+          <p:cNvPr id="3" name="Rectangle 2">
+            <a:extLst>
+              <a:ext uri="{FF2B5EF4-FFF2-40B4-BE49-F238E27FC236}">
+                <a16:creationId xmlns:a16="http://schemas.microsoft.com/office/drawing/2014/main" id="{436CD954-48C9-7D5D-A37B-8130EF956A53}"/>
+              </a:ext>
+            </a:extLst>
+          </p:cNvPr>
+          <p:cNvSpPr>
+            <a:spLocks noChangeArrowheads="1"/>
+          </p:cNvSpPr>
+          <p:nvPr/>
+        </p:nvSpPr>
+        <p:spPr bwMode="auto">
+          <a:xfrm>
+            <a:off x="2121408" y="797363"/>
+            <a:ext cx="5769864" cy="3180277"/>
+          </a:xfrm>
+          <a:prstGeom prst="rect">
+            <a:avLst/>
+          </a:prstGeom>
+          <a:solidFill>
+            <a:srgbClr val="FAFAFA"/>
+          </a:solidFill>
+          <a:ln>
+            <a:noFill/>
+          </a:ln>
+          <a:effectLst/>
+          <a:extLst>
+            <a:ext uri="{91240B29-F687-4F45-9708-019B960494DF}">
+              <a14:hiddenLine xmlns:a14="http://schemas.microsoft.com/office/drawing/2010/main" w="9525">
+                <a:solidFill>
+                  <a:schemeClr val="tx1"/>
+                </a:solidFill>
+                <a:miter lim="800000"/>
+                <a:headEnd/>
+                <a:tailEnd/>
+              </a14:hiddenLine>
+            </a:ext>
+            <a:ext uri="{AF507438-7753-43E0-B8FC-AC1667EBCBE1}">
+              <a14:hiddenEffects xmlns:a14="http://schemas.microsoft.com/office/drawing/2010/main">
+                <a:effectLst>
+                  <a:outerShdw dist="35921" dir="2700000" algn="ctr" rotWithShape="0">
+                    <a:schemeClr val="bg2"/>
+                  </a:outerShdw>
+                </a:effectLst>
+              </a14:hiddenEffects>
+            </a:ext>
+          </a:extLst>
+        </p:spPr>
+        <p:txBody>
+          <a:bodyPr vert="horz" wrap="square" lIns="0" tIns="107916" rIns="0" bIns="146004" numCol="1" anchor="ctr" anchorCtr="0" compatLnSpc="1">
+            <a:prstTxWarp prst="textNoShape">
+              <a:avLst/>
+            </a:prstTxWarp>
+            <a:spAutoFit/>
+          </a:bodyPr>
+          <a:lstStyle/>
+          <a:p>
+            <a:pPr marL="0" marR="0" lvl="0" indent="0" algn="l" defTabSz="914400" rtl="0" eaLnBrk="0" fontAlgn="base" latinLnBrk="0" hangingPunct="0">
+              <a:lnSpc>
+                <a:spcPct val="100000"/>
+              </a:lnSpc>
+              <a:spcBef>
+                <a:spcPct val="0"/>
+              </a:spcBef>
+              <a:spcAft>
+                <a:spcPct val="0"/>
+              </a:spcAft>
+              <a:buClrTx/>
+              <a:buSzTx/>
+              <a:buFontTx/>
+              <a:buNone/>
+              <a:tabLst/>
+            </a:pPr>
+            <a:r>
+              <a:rPr kumimoji="0" lang="en-IL" altLang="en-IL" sz="1000" b="0" i="0" u="none" strike="noStrike" cap="none" normalizeH="0" baseline="0" dirty="0">
+                <a:ln>
+                  <a:noFill/>
+                </a:ln>
+                <a:solidFill>
+                  <a:srgbClr val="424242"/>
+                </a:solidFill>
+                <a:effectLst/>
+                <a:latin typeface="Arial Unicode MS"/>
+                <a:ea typeface="source-code-pro"/>
+              </a:rPr>
+              <a:t>A2C/ </a:t>
+            </a:r>
+            <a:endParaRPr kumimoji="0" lang="en-US" altLang="en-IL" sz="1000" b="0" i="0" u="none" strike="noStrike" cap="none" normalizeH="0" baseline="0" dirty="0">
+              <a:ln>
+                <a:noFill/>
+              </a:ln>
+              <a:solidFill>
+                <a:srgbClr val="424242"/>
+              </a:solidFill>
+              <a:effectLst/>
+              <a:latin typeface="Arial Unicode MS"/>
+              <a:ea typeface="source-code-pro"/>
+            </a:endParaRPr>
+          </a:p>
+          <a:p>
+            <a:pPr marL="0" marR="0" lvl="0" indent="0" algn="l" defTabSz="914400" rtl="0" eaLnBrk="0" fontAlgn="base" latinLnBrk="0" hangingPunct="0">
+              <a:lnSpc>
+                <a:spcPct val="100000"/>
+              </a:lnSpc>
+              <a:spcBef>
+                <a:spcPct val="0"/>
+              </a:spcBef>
+              <a:spcAft>
+                <a:spcPct val="0"/>
+              </a:spcAft>
+              <a:buClrTx/>
+              <a:buSzTx/>
+              <a:buFontTx/>
+              <a:buNone/>
+              <a:tabLst/>
+            </a:pPr>
+            <a:r>
+              <a:rPr kumimoji="0" lang="en-IL" altLang="en-IL" sz="1000" b="0" i="0" u="none" strike="noStrike" cap="none" normalizeH="0" baseline="0" dirty="0">
+                <a:ln>
+                  <a:noFill/>
+                </a:ln>
+                <a:solidFill>
+                  <a:srgbClr val="424242"/>
+                </a:solidFill>
+                <a:effectLst/>
+                <a:latin typeface="Arial Unicode MS"/>
+                <a:ea typeface="source-code-pro"/>
+              </a:rPr>
+              <a:t>├── Client/</a:t>
+            </a:r>
+            <a:r>
+              <a:rPr kumimoji="0" lang="en-US" altLang="en-IL" sz="1000" b="0" i="0" u="none" strike="noStrike" cap="none" normalizeH="0" baseline="0" dirty="0">
+                <a:ln>
+                  <a:noFill/>
+                </a:ln>
+                <a:solidFill>
+                  <a:srgbClr val="424242"/>
+                </a:solidFill>
+                <a:effectLst/>
+                <a:latin typeface="Arial Unicode MS"/>
+                <a:ea typeface="source-code-pro"/>
+              </a:rPr>
+              <a:t>                       		</a:t>
+            </a:r>
+            <a:r>
+              <a:rPr kumimoji="0" lang="en-IL" altLang="en-IL" sz="1000" b="0" i="0" u="none" strike="noStrike" cap="none" normalizeH="0" baseline="0" dirty="0">
+                <a:ln>
+                  <a:noFill/>
+                </a:ln>
+                <a:solidFill>
+                  <a:srgbClr val="424242"/>
+                </a:solidFill>
+                <a:effectLst/>
+                <a:latin typeface="Arial Unicode MS"/>
+                <a:ea typeface="source-code-pro"/>
+              </a:rPr>
+              <a:t>← Frontend (React) </a:t>
+            </a:r>
+            <a:endParaRPr kumimoji="0" lang="en-US" altLang="en-IL" sz="1000" b="0" i="0" u="none" strike="noStrike" cap="none" normalizeH="0" baseline="0" dirty="0">
+              <a:ln>
+                <a:noFill/>
+              </a:ln>
+              <a:solidFill>
+                <a:srgbClr val="424242"/>
+              </a:solidFill>
+              <a:effectLst/>
+              <a:latin typeface="Arial Unicode MS"/>
+              <a:ea typeface="source-code-pro"/>
+            </a:endParaRPr>
+          </a:p>
+          <a:p>
+            <a:pPr marL="0" marR="0" lvl="0" indent="0" algn="l" defTabSz="914400" rtl="0" eaLnBrk="0" fontAlgn="base" latinLnBrk="0" hangingPunct="0">
+              <a:lnSpc>
+                <a:spcPct val="100000"/>
+              </a:lnSpc>
+              <a:spcBef>
+                <a:spcPct val="0"/>
+              </a:spcBef>
+              <a:spcAft>
+                <a:spcPct val="0"/>
+              </a:spcAft>
+              <a:buClrTx/>
+              <a:buSzTx/>
+              <a:buFontTx/>
+              <a:buNone/>
+              <a:tabLst/>
+            </a:pPr>
+            <a:r>
+              <a:rPr kumimoji="0" lang="en-IL" altLang="en-IL" sz="1000" b="0" i="0" u="none" strike="noStrike" cap="none" normalizeH="0" baseline="0" dirty="0">
+                <a:ln>
+                  <a:noFill/>
+                </a:ln>
+                <a:solidFill>
+                  <a:srgbClr val="424242"/>
+                </a:solidFill>
+                <a:effectLst/>
+                <a:latin typeface="Arial Unicode MS"/>
+                <a:ea typeface="source-code-pro"/>
+              </a:rPr>
+              <a:t>├── Server/</a:t>
+            </a:r>
+            <a:r>
+              <a:rPr kumimoji="0" lang="en-US" altLang="en-IL" sz="1000" b="0" i="0" u="none" strike="noStrike" cap="none" normalizeH="0" baseline="0" dirty="0">
+                <a:ln>
+                  <a:noFill/>
+                </a:ln>
+                <a:solidFill>
+                  <a:srgbClr val="424242"/>
+                </a:solidFill>
+                <a:effectLst/>
+                <a:latin typeface="Arial Unicode MS"/>
+                <a:ea typeface="source-code-pro"/>
+              </a:rPr>
+              <a:t>                      </a:t>
+            </a:r>
+            <a:r>
+              <a:rPr kumimoji="0" lang="en-IL" altLang="en-IL" sz="1000" b="0" i="0" u="none" strike="noStrike" cap="none" normalizeH="0" baseline="0" dirty="0">
+                <a:ln>
+                  <a:noFill/>
+                </a:ln>
+                <a:solidFill>
+                  <a:srgbClr val="424242"/>
+                </a:solidFill>
+                <a:effectLst/>
+                <a:latin typeface="Arial Unicode MS"/>
+                <a:ea typeface="source-code-pro"/>
+              </a:rPr>
+              <a:t> </a:t>
+            </a:r>
+            <a:r>
+              <a:rPr kumimoji="0" lang="en-US" altLang="en-IL" sz="1000" b="0" i="0" u="none" strike="noStrike" cap="none" normalizeH="0" baseline="0" dirty="0">
+                <a:ln>
+                  <a:noFill/>
+                </a:ln>
+                <a:solidFill>
+                  <a:srgbClr val="424242"/>
+                </a:solidFill>
+                <a:effectLst/>
+                <a:latin typeface="Arial Unicode MS"/>
+                <a:ea typeface="source-code-pro"/>
+              </a:rPr>
+              <a:t>		</a:t>
+            </a:r>
+            <a:r>
+              <a:rPr kumimoji="0" lang="en-IL" altLang="en-IL" sz="1000" b="0" i="0" u="none" strike="noStrike" cap="none" normalizeH="0" baseline="0" dirty="0">
+                <a:ln>
+                  <a:noFill/>
+                </a:ln>
+                <a:solidFill>
+                  <a:srgbClr val="424242"/>
+                </a:solidFill>
+                <a:effectLst/>
+                <a:latin typeface="Arial Unicode MS"/>
+                <a:ea typeface="source-code-pro"/>
+              </a:rPr>
+              <a:t>← Backend </a:t>
+            </a:r>
+            <a:endParaRPr kumimoji="0" lang="en-US" altLang="en-IL" sz="1000" b="0" i="0" u="none" strike="noStrike" cap="none" normalizeH="0" baseline="0" dirty="0">
+              <a:ln>
+                <a:noFill/>
+              </a:ln>
+              <a:solidFill>
+                <a:srgbClr val="424242"/>
+              </a:solidFill>
+              <a:effectLst/>
+              <a:latin typeface="Arial Unicode MS"/>
+              <a:ea typeface="source-code-pro"/>
+            </a:endParaRPr>
+          </a:p>
+          <a:p>
+            <a:pPr marL="0" marR="0" lvl="0" indent="0" algn="l" defTabSz="914400" rtl="0" eaLnBrk="0" fontAlgn="base" latinLnBrk="0" hangingPunct="0">
+              <a:lnSpc>
+                <a:spcPct val="100000"/>
+              </a:lnSpc>
+              <a:spcBef>
+                <a:spcPct val="0"/>
+              </a:spcBef>
+              <a:spcAft>
+                <a:spcPct val="0"/>
+              </a:spcAft>
+              <a:buClrTx/>
+              <a:buSzTx/>
+              <a:buFontTx/>
+              <a:buNone/>
+              <a:tabLst/>
+            </a:pPr>
+            <a:r>
+              <a:rPr kumimoji="0" lang="en-IL" altLang="en-IL" sz="1000" b="0" i="0" u="none" strike="noStrike" cap="none" normalizeH="0" baseline="0" dirty="0">
+                <a:ln>
+                  <a:noFill/>
+                </a:ln>
+                <a:solidFill>
+                  <a:srgbClr val="424242"/>
+                </a:solidFill>
+                <a:effectLst/>
+                <a:latin typeface="Arial Unicode MS"/>
+                <a:ea typeface="source-code-pro"/>
+              </a:rPr>
+              <a:t>│ ├── AuthService/ </a:t>
+            </a:r>
+            <a:r>
+              <a:rPr kumimoji="0" lang="en-US" altLang="en-IL" sz="1000" b="0" i="0" u="none" strike="noStrike" cap="none" normalizeH="0" baseline="0" dirty="0">
+                <a:ln>
+                  <a:noFill/>
+                </a:ln>
+                <a:solidFill>
+                  <a:srgbClr val="424242"/>
+                </a:solidFill>
+                <a:effectLst/>
+                <a:latin typeface="Arial Unicode MS"/>
+                <a:ea typeface="source-code-pro"/>
+              </a:rPr>
+              <a:t>		</a:t>
+            </a:r>
+            <a:r>
+              <a:rPr kumimoji="0" lang="en-IL" altLang="en-IL" sz="1000" b="0" i="0" u="none" strike="noStrike" cap="none" normalizeH="0" baseline="0" dirty="0">
+                <a:ln>
+                  <a:noFill/>
+                </a:ln>
+                <a:solidFill>
+                  <a:srgbClr val="424242"/>
+                </a:solidFill>
+                <a:effectLst/>
+                <a:latin typeface="Arial Unicode MS"/>
+                <a:ea typeface="source-code-pro"/>
+              </a:rPr>
+              <a:t>← </a:t>
+            </a:r>
+            <a:r>
+              <a:rPr kumimoji="0" lang="en-US" altLang="en-IL" sz="1000" b="0" i="0" u="none" strike="noStrike" cap="none" normalizeH="0" baseline="0" dirty="0">
+                <a:ln>
+                  <a:noFill/>
+                </a:ln>
+                <a:solidFill>
+                  <a:srgbClr val="424242"/>
+                </a:solidFill>
+                <a:effectLst/>
+                <a:latin typeface="Arial Unicode MS"/>
+                <a:ea typeface="source-code-pro"/>
+                <a:cs typeface="Arial" panose="020B0604020202020204" pitchFamily="34" charset="0"/>
+              </a:rPr>
+              <a:t>Log in Service</a:t>
+            </a:r>
+            <a:endParaRPr kumimoji="0" lang="en-US" altLang="en-IL" sz="1000" b="0" i="0" u="none" strike="noStrike" cap="none" normalizeH="0" baseline="0" dirty="0">
+              <a:ln>
+                <a:noFill/>
+              </a:ln>
+              <a:solidFill>
+                <a:srgbClr val="424242"/>
+              </a:solidFill>
+              <a:effectLst/>
+              <a:latin typeface="Arial Unicode MS"/>
+              <a:ea typeface="source-code-pro"/>
+            </a:endParaRPr>
+          </a:p>
+          <a:p>
+            <a:pPr marL="0" marR="0" lvl="0" indent="0" algn="l" defTabSz="914400" rtl="0" eaLnBrk="0" fontAlgn="base" latinLnBrk="0" hangingPunct="0">
+              <a:lnSpc>
+                <a:spcPct val="100000"/>
+              </a:lnSpc>
+              <a:spcBef>
+                <a:spcPct val="0"/>
+              </a:spcBef>
+              <a:spcAft>
+                <a:spcPct val="0"/>
+              </a:spcAft>
+              <a:buClrTx/>
+              <a:buSzTx/>
+              <a:buFontTx/>
+              <a:buNone/>
+              <a:tabLst/>
+            </a:pPr>
+            <a:r>
+              <a:rPr kumimoji="0" lang="en-IL" altLang="en-IL" sz="1000" b="0" i="0" u="none" strike="noStrike" cap="none" normalizeH="0" baseline="0" dirty="0">
+                <a:ln>
+                  <a:noFill/>
+                </a:ln>
+                <a:solidFill>
+                  <a:srgbClr val="424242"/>
+                </a:solidFill>
+                <a:effectLst/>
+                <a:latin typeface="Arial Unicode MS"/>
+                <a:ea typeface="source-code-pro"/>
+              </a:rPr>
+              <a:t>│ ├── CustomersService/ </a:t>
+            </a:r>
+            <a:r>
+              <a:rPr kumimoji="0" lang="en-US" altLang="en-IL" sz="1000" b="0" i="0" u="none" strike="noStrike" cap="none" normalizeH="0" baseline="0" dirty="0">
+                <a:ln>
+                  <a:noFill/>
+                </a:ln>
+                <a:solidFill>
+                  <a:srgbClr val="424242"/>
+                </a:solidFill>
+                <a:effectLst/>
+                <a:latin typeface="Arial Unicode MS"/>
+                <a:ea typeface="source-code-pro"/>
+              </a:rPr>
+              <a:t>		</a:t>
+            </a:r>
+            <a:r>
+              <a:rPr kumimoji="0" lang="en-IL" altLang="en-IL" sz="1000" b="0" i="0" u="none" strike="noStrike" cap="none" normalizeH="0" baseline="0" dirty="0">
+                <a:ln>
+                  <a:noFill/>
+                </a:ln>
+                <a:solidFill>
+                  <a:srgbClr val="424242"/>
+                </a:solidFill>
+                <a:effectLst/>
+                <a:latin typeface="Arial Unicode MS"/>
+                <a:ea typeface="source-code-pro"/>
+              </a:rPr>
+              <a:t>← </a:t>
+            </a:r>
+            <a:r>
+              <a:rPr kumimoji="0" lang="en-US" altLang="en-IL" sz="1000" b="0" i="0" u="none" strike="noStrike" cap="none" normalizeH="0" baseline="0" dirty="0">
+                <a:ln>
+                  <a:noFill/>
+                </a:ln>
+                <a:solidFill>
+                  <a:srgbClr val="424242"/>
+                </a:solidFill>
+                <a:effectLst/>
+                <a:latin typeface="Arial Unicode MS"/>
+                <a:ea typeface="source-code-pro"/>
+                <a:cs typeface="Arial" panose="020B0604020202020204" pitchFamily="34" charset="0"/>
+              </a:rPr>
+              <a:t>Customers service</a:t>
+            </a:r>
+            <a:endParaRPr kumimoji="0" lang="en-US" altLang="en-IL" sz="1000" b="0" i="0" u="none" strike="noStrike" cap="none" normalizeH="0" baseline="0" dirty="0">
+              <a:ln>
+                <a:noFill/>
+              </a:ln>
+              <a:solidFill>
+                <a:srgbClr val="424242"/>
+              </a:solidFill>
+              <a:effectLst/>
+              <a:latin typeface="Arial Unicode MS"/>
+              <a:ea typeface="source-code-pro"/>
+            </a:endParaRPr>
+          </a:p>
+          <a:p>
+            <a:pPr marL="0" marR="0" lvl="0" indent="0" algn="l" defTabSz="914400" rtl="0" eaLnBrk="0" fontAlgn="base" latinLnBrk="0" hangingPunct="0">
+              <a:lnSpc>
+                <a:spcPct val="100000"/>
+              </a:lnSpc>
+              <a:spcBef>
+                <a:spcPct val="0"/>
+              </a:spcBef>
+              <a:spcAft>
+                <a:spcPct val="0"/>
+              </a:spcAft>
+              <a:buClrTx/>
+              <a:buSzTx/>
+              <a:buFontTx/>
+              <a:buNone/>
+              <a:tabLst/>
+            </a:pPr>
+            <a:r>
+              <a:rPr kumimoji="0" lang="en-IL" altLang="en-IL" sz="1000" b="0" i="0" u="none" strike="noStrike" cap="none" normalizeH="0" baseline="0" dirty="0">
+                <a:ln>
+                  <a:noFill/>
+                </a:ln>
+                <a:solidFill>
+                  <a:srgbClr val="424242"/>
+                </a:solidFill>
+                <a:effectLst/>
+                <a:latin typeface="Arial Unicode MS"/>
+                <a:ea typeface="source-code-pro"/>
+              </a:rPr>
+              <a:t>│ ├── OrdersService/ </a:t>
+            </a:r>
+            <a:r>
+              <a:rPr kumimoji="0" lang="en-US" altLang="en-IL" sz="1000" b="0" i="0" u="none" strike="noStrike" cap="none" normalizeH="0" baseline="0" dirty="0">
+                <a:ln>
+                  <a:noFill/>
+                </a:ln>
+                <a:solidFill>
+                  <a:srgbClr val="424242"/>
+                </a:solidFill>
+                <a:effectLst/>
+                <a:latin typeface="Arial Unicode MS"/>
+                <a:ea typeface="source-code-pro"/>
+              </a:rPr>
+              <a:t>		</a:t>
+            </a:r>
+            <a:r>
+              <a:rPr kumimoji="0" lang="en-IL" altLang="en-IL" sz="1000" b="0" i="0" u="none" strike="noStrike" cap="none" normalizeH="0" baseline="0" dirty="0">
+                <a:ln>
+                  <a:noFill/>
+                </a:ln>
+                <a:solidFill>
+                  <a:srgbClr val="424242"/>
+                </a:solidFill>
+                <a:effectLst/>
+                <a:latin typeface="Arial Unicode MS"/>
+                <a:ea typeface="source-code-pro"/>
+              </a:rPr>
+              <a:t>← </a:t>
+            </a:r>
+            <a:r>
+              <a:rPr kumimoji="0" lang="en-US" altLang="en-IL" sz="1000" b="0" i="0" u="none" strike="noStrike" cap="none" normalizeH="0" baseline="0" dirty="0">
+                <a:ln>
+                  <a:noFill/>
+                </a:ln>
+                <a:solidFill>
+                  <a:srgbClr val="424242"/>
+                </a:solidFill>
+                <a:effectLst/>
+                <a:latin typeface="Arial Unicode MS"/>
+                <a:ea typeface="source-code-pro"/>
+                <a:cs typeface="Arial" panose="020B0604020202020204" pitchFamily="34" charset="0"/>
+              </a:rPr>
+              <a:t>Orders Service</a:t>
+            </a:r>
+            <a:endParaRPr kumimoji="0" lang="en-US" altLang="en-IL" sz="1000" b="0" i="0" u="none" strike="noStrike" cap="none" normalizeH="0" baseline="0" dirty="0">
+              <a:ln>
+                <a:noFill/>
+              </a:ln>
+              <a:solidFill>
+                <a:srgbClr val="424242"/>
+              </a:solidFill>
+              <a:effectLst/>
+              <a:latin typeface="Arial Unicode MS"/>
+              <a:ea typeface="source-code-pro"/>
+            </a:endParaRPr>
+          </a:p>
+          <a:p>
+            <a:pPr marL="0" marR="0" lvl="0" indent="0" algn="l" defTabSz="914400" rtl="0" eaLnBrk="0" fontAlgn="base" latinLnBrk="0" hangingPunct="0">
+              <a:lnSpc>
+                <a:spcPct val="100000"/>
+              </a:lnSpc>
+              <a:spcBef>
+                <a:spcPct val="0"/>
+              </a:spcBef>
+              <a:spcAft>
+                <a:spcPct val="0"/>
+              </a:spcAft>
+              <a:buClrTx/>
+              <a:buSzTx/>
+              <a:buFontTx/>
+              <a:buNone/>
+              <a:tabLst/>
+            </a:pPr>
+            <a:r>
+              <a:rPr kumimoji="0" lang="en-IL" altLang="en-IL" sz="1000" b="0" i="0" u="none" strike="noStrike" cap="none" normalizeH="0" baseline="0" dirty="0">
+                <a:ln>
+                  <a:noFill/>
+                </a:ln>
+                <a:solidFill>
+                  <a:srgbClr val="424242"/>
+                </a:solidFill>
+                <a:effectLst/>
+                <a:latin typeface="Arial Unicode MS"/>
+                <a:ea typeface="source-code-pro"/>
+              </a:rPr>
+              <a:t>│ ├── LoggingService/ </a:t>
+            </a:r>
+            <a:r>
+              <a:rPr kumimoji="0" lang="en-US" altLang="en-IL" sz="1000" b="0" i="0" u="none" strike="noStrike" cap="none" normalizeH="0" baseline="0" dirty="0">
+                <a:ln>
+                  <a:noFill/>
+                </a:ln>
+                <a:solidFill>
+                  <a:srgbClr val="424242"/>
+                </a:solidFill>
+                <a:effectLst/>
+                <a:latin typeface="Arial Unicode MS"/>
+                <a:ea typeface="source-code-pro"/>
+              </a:rPr>
+              <a:t>		</a:t>
+            </a:r>
+            <a:r>
+              <a:rPr kumimoji="0" lang="en-IL" altLang="en-IL" sz="1000" b="0" i="0" u="none" strike="noStrike" cap="none" normalizeH="0" baseline="0" dirty="0">
+                <a:ln>
+                  <a:noFill/>
+                </a:ln>
+                <a:solidFill>
+                  <a:srgbClr val="424242"/>
+                </a:solidFill>
+                <a:effectLst/>
+                <a:latin typeface="Arial Unicode MS"/>
+                <a:ea typeface="source-code-pro"/>
+              </a:rPr>
+              <a:t>← </a:t>
+            </a:r>
+            <a:r>
+              <a:rPr kumimoji="0" lang="en-US" altLang="en-IL" sz="1000" b="0" i="0" u="none" strike="noStrike" cap="none" normalizeH="0" baseline="0" dirty="0">
+                <a:ln>
+                  <a:noFill/>
+                </a:ln>
+                <a:solidFill>
+                  <a:srgbClr val="424242"/>
+                </a:solidFill>
+                <a:effectLst/>
+                <a:latin typeface="Arial Unicode MS"/>
+                <a:ea typeface="source-code-pro"/>
+                <a:cs typeface="Arial" panose="020B0604020202020204" pitchFamily="34" charset="0"/>
+              </a:rPr>
+              <a:t>Logs service</a:t>
+            </a:r>
+            <a:endParaRPr kumimoji="0" lang="en-US" altLang="en-IL" sz="1000" b="0" i="0" u="none" strike="noStrike" cap="none" normalizeH="0" baseline="0" dirty="0">
+              <a:ln>
+                <a:noFill/>
+              </a:ln>
+              <a:solidFill>
+                <a:srgbClr val="424242"/>
+              </a:solidFill>
+              <a:effectLst/>
+              <a:latin typeface="Arial Unicode MS"/>
+              <a:ea typeface="source-code-pro"/>
+            </a:endParaRPr>
+          </a:p>
+          <a:p>
+            <a:pPr marL="0" marR="0" lvl="0" indent="0" algn="l" defTabSz="914400" rtl="0" eaLnBrk="0" fontAlgn="base" latinLnBrk="0" hangingPunct="0">
+              <a:lnSpc>
+                <a:spcPct val="100000"/>
+              </a:lnSpc>
+              <a:spcBef>
+                <a:spcPct val="0"/>
+              </a:spcBef>
+              <a:spcAft>
+                <a:spcPct val="0"/>
+              </a:spcAft>
+              <a:buClrTx/>
+              <a:buSzTx/>
+              <a:buFontTx/>
+              <a:buNone/>
+              <a:tabLst/>
+            </a:pPr>
+            <a:r>
+              <a:rPr kumimoji="0" lang="en-IL" altLang="en-IL" sz="1000" b="0" i="0" u="none" strike="noStrike" cap="none" normalizeH="0" baseline="0" dirty="0">
+                <a:ln>
+                  <a:noFill/>
+                </a:ln>
+                <a:solidFill>
+                  <a:srgbClr val="424242"/>
+                </a:solidFill>
+                <a:effectLst/>
+                <a:latin typeface="Arial Unicode MS"/>
+                <a:ea typeface="source-code-pro"/>
+              </a:rPr>
+              <a:t>│ ├── NotificationsWorker/ </a:t>
+            </a:r>
+            <a:r>
+              <a:rPr kumimoji="0" lang="en-US" altLang="en-IL" sz="1000" b="0" i="0" u="none" strike="noStrike" cap="none" normalizeH="0" baseline="0" dirty="0">
+                <a:ln>
+                  <a:noFill/>
+                </a:ln>
+                <a:solidFill>
+                  <a:srgbClr val="424242"/>
+                </a:solidFill>
+                <a:effectLst/>
+                <a:latin typeface="Arial Unicode MS"/>
+                <a:ea typeface="source-code-pro"/>
+              </a:rPr>
+              <a:t>		</a:t>
+            </a:r>
+            <a:r>
+              <a:rPr kumimoji="0" lang="en-IL" altLang="en-IL" sz="1000" b="0" i="0" u="none" strike="noStrike" cap="none" normalizeH="0" baseline="0" dirty="0">
+                <a:ln>
+                  <a:noFill/>
+                </a:ln>
+                <a:solidFill>
+                  <a:srgbClr val="424242"/>
+                </a:solidFill>
+                <a:effectLst/>
+                <a:latin typeface="Arial Unicode MS"/>
+                <a:ea typeface="source-code-pro"/>
+              </a:rPr>
+              <a:t>← </a:t>
+            </a:r>
+            <a:r>
+              <a:rPr lang="en-US" altLang="en-IL" sz="1000" dirty="0">
+                <a:solidFill>
+                  <a:srgbClr val="424242"/>
+                </a:solidFill>
+                <a:latin typeface="Arial Unicode MS"/>
+                <a:ea typeface="source-code-pro"/>
+              </a:rPr>
+              <a:t>Notifications w</a:t>
+            </a:r>
+            <a:r>
+              <a:rPr lang="en-US" altLang="en-IL" sz="1000" dirty="0">
+                <a:solidFill>
+                  <a:srgbClr val="424242"/>
+                </a:solidFill>
+                <a:latin typeface="Arial Unicode MS"/>
+                <a:ea typeface="source-code-pro"/>
+                <a:cs typeface="Arial" panose="020B0604020202020204" pitchFamily="34" charset="0"/>
+              </a:rPr>
+              <a:t>orker service </a:t>
+            </a:r>
+            <a:endParaRPr kumimoji="0" lang="en-US" altLang="en-IL" sz="1000" b="0" i="0" u="none" strike="noStrike" cap="none" normalizeH="0" baseline="0" dirty="0">
+              <a:ln>
+                <a:noFill/>
+              </a:ln>
+              <a:solidFill>
+                <a:srgbClr val="424242"/>
+              </a:solidFill>
+              <a:effectLst/>
+              <a:latin typeface="Arial Unicode MS"/>
+              <a:ea typeface="source-code-pro"/>
+            </a:endParaRPr>
+          </a:p>
+          <a:p>
+            <a:pPr marL="0" marR="0" lvl="0" indent="0" algn="l" defTabSz="914400" rtl="0" eaLnBrk="0" fontAlgn="base" latinLnBrk="0" hangingPunct="0">
+              <a:lnSpc>
+                <a:spcPct val="100000"/>
+              </a:lnSpc>
+              <a:spcBef>
+                <a:spcPct val="0"/>
+              </a:spcBef>
+              <a:spcAft>
+                <a:spcPct val="0"/>
+              </a:spcAft>
+              <a:buClrTx/>
+              <a:buSzTx/>
+              <a:buFontTx/>
+              <a:buNone/>
+              <a:tabLst/>
+            </a:pPr>
+            <a:r>
+              <a:rPr kumimoji="0" lang="en-IL" altLang="en-IL" sz="1000" b="0" i="0" u="none" strike="noStrike" cap="none" normalizeH="0" baseline="0" dirty="0">
+                <a:ln>
+                  <a:noFill/>
+                </a:ln>
+                <a:solidFill>
+                  <a:srgbClr val="424242"/>
+                </a:solidFill>
+                <a:effectLst/>
+                <a:latin typeface="Arial Unicode MS"/>
+                <a:ea typeface="source-code-pro"/>
+              </a:rPr>
+              <a:t>│ ├── PublisherService/ </a:t>
+            </a:r>
+            <a:r>
+              <a:rPr kumimoji="0" lang="en-US" altLang="en-IL" sz="1000" b="0" i="0" u="none" strike="noStrike" cap="none" normalizeH="0" baseline="0" dirty="0">
+                <a:ln>
+                  <a:noFill/>
+                </a:ln>
+                <a:solidFill>
+                  <a:srgbClr val="424242"/>
+                </a:solidFill>
+                <a:effectLst/>
+                <a:latin typeface="Arial Unicode MS"/>
+                <a:ea typeface="source-code-pro"/>
+              </a:rPr>
+              <a:t>		</a:t>
+            </a:r>
+            <a:r>
+              <a:rPr kumimoji="0" lang="en-IL" altLang="en-IL" sz="1000" b="0" i="0" u="none" strike="noStrike" cap="none" normalizeH="0" baseline="0" dirty="0">
+                <a:ln>
+                  <a:noFill/>
+                </a:ln>
+                <a:solidFill>
+                  <a:srgbClr val="424242"/>
+                </a:solidFill>
+                <a:effectLst/>
+                <a:latin typeface="Arial Unicode MS"/>
+                <a:ea typeface="source-code-pro"/>
+              </a:rPr>
+              <a:t>← </a:t>
+            </a:r>
+            <a:r>
+              <a:rPr kumimoji="0" lang="en-US" altLang="en-IL" sz="1000" b="0" i="0" u="none" strike="noStrike" cap="none" normalizeH="0" baseline="0" dirty="0">
+                <a:ln>
+                  <a:noFill/>
+                </a:ln>
+                <a:solidFill>
+                  <a:srgbClr val="424242"/>
+                </a:solidFill>
+                <a:effectLst/>
+                <a:latin typeface="Arial Unicode MS"/>
+                <a:ea typeface="source-code-pro"/>
+                <a:cs typeface="Arial" panose="020B0604020202020204" pitchFamily="34" charset="0"/>
+              </a:rPr>
+              <a:t>Data </a:t>
+            </a:r>
+            <a:r>
+              <a:rPr lang="en-US" altLang="en-IL" sz="1000" dirty="0">
+                <a:solidFill>
+                  <a:srgbClr val="424242"/>
+                </a:solidFill>
+                <a:latin typeface="Arial Unicode MS"/>
+                <a:ea typeface="source-code-pro"/>
+                <a:cs typeface="Arial" panose="020B0604020202020204" pitchFamily="34" charset="0"/>
+              </a:rPr>
+              <a:t>publishing service</a:t>
+            </a:r>
+            <a:endParaRPr kumimoji="0" lang="en-US" altLang="en-IL" sz="1000" b="0" i="0" u="none" strike="noStrike" cap="none" normalizeH="0" baseline="0" dirty="0">
+              <a:ln>
+                <a:noFill/>
+              </a:ln>
+              <a:solidFill>
+                <a:srgbClr val="424242"/>
+              </a:solidFill>
+              <a:effectLst/>
+              <a:latin typeface="Arial Unicode MS"/>
+              <a:ea typeface="source-code-pro"/>
+            </a:endParaRPr>
+          </a:p>
+          <a:p>
+            <a:pPr marL="0" marR="0" lvl="0" indent="0" algn="l" defTabSz="914400" rtl="0" eaLnBrk="0" fontAlgn="base" latinLnBrk="0" hangingPunct="0">
+              <a:lnSpc>
+                <a:spcPct val="100000"/>
+              </a:lnSpc>
+              <a:spcBef>
+                <a:spcPct val="0"/>
+              </a:spcBef>
+              <a:spcAft>
+                <a:spcPct val="0"/>
+              </a:spcAft>
+              <a:buClrTx/>
+              <a:buSzTx/>
+              <a:buFontTx/>
+              <a:buNone/>
+              <a:tabLst/>
+            </a:pPr>
+            <a:r>
+              <a:rPr kumimoji="0" lang="en-IL" altLang="en-IL" sz="1000" b="0" i="0" u="none" strike="noStrike" cap="none" normalizeH="0" baseline="0" dirty="0">
+                <a:ln>
+                  <a:noFill/>
+                </a:ln>
+                <a:solidFill>
+                  <a:srgbClr val="424242"/>
+                </a:solidFill>
+                <a:effectLst/>
+                <a:latin typeface="Arial Unicode MS"/>
+                <a:ea typeface="source-code-pro"/>
+              </a:rPr>
+              <a:t>│ └── Gateway/ </a:t>
+            </a:r>
+            <a:r>
+              <a:rPr kumimoji="0" lang="en-US" altLang="en-IL" sz="1000" b="0" i="0" u="none" strike="noStrike" cap="none" normalizeH="0" baseline="0" dirty="0">
+                <a:ln>
+                  <a:noFill/>
+                </a:ln>
+                <a:solidFill>
+                  <a:srgbClr val="424242"/>
+                </a:solidFill>
+                <a:effectLst/>
+                <a:latin typeface="Arial Unicode MS"/>
+                <a:ea typeface="source-code-pro"/>
+              </a:rPr>
+              <a:t>		</a:t>
+            </a:r>
+            <a:r>
+              <a:rPr kumimoji="0" lang="en-IL" altLang="en-IL" sz="1000" b="0" i="0" u="none" strike="noStrike" cap="none" normalizeH="0" baseline="0" dirty="0">
+                <a:ln>
+                  <a:noFill/>
+                </a:ln>
+                <a:solidFill>
+                  <a:srgbClr val="424242"/>
+                </a:solidFill>
+                <a:effectLst/>
+                <a:latin typeface="Arial Unicode MS"/>
+                <a:ea typeface="source-code-pro"/>
+              </a:rPr>
+              <a:t>← API Gateway </a:t>
+            </a:r>
+            <a:endParaRPr kumimoji="0" lang="en-US" altLang="en-IL" sz="1000" b="0" i="0" u="none" strike="noStrike" cap="none" normalizeH="0" baseline="0" dirty="0">
+              <a:ln>
+                <a:noFill/>
+              </a:ln>
+              <a:solidFill>
+                <a:srgbClr val="424242"/>
+              </a:solidFill>
+              <a:effectLst/>
+              <a:latin typeface="Arial Unicode MS"/>
+              <a:ea typeface="source-code-pro"/>
+            </a:endParaRPr>
+          </a:p>
+          <a:p>
+            <a:pPr marL="0" marR="0" lvl="0" indent="0" algn="l" defTabSz="914400" rtl="0" eaLnBrk="0" fontAlgn="base" latinLnBrk="0" hangingPunct="0">
+              <a:lnSpc>
+                <a:spcPct val="100000"/>
+              </a:lnSpc>
+              <a:spcBef>
+                <a:spcPct val="0"/>
+              </a:spcBef>
+              <a:spcAft>
+                <a:spcPct val="0"/>
+              </a:spcAft>
+              <a:buClrTx/>
+              <a:buSzTx/>
+              <a:buFontTx/>
+              <a:buNone/>
+              <a:tabLst/>
+            </a:pPr>
+            <a:r>
+              <a:rPr kumimoji="0" lang="en-IL" altLang="en-IL" sz="1000" b="0" i="0" u="none" strike="noStrike" cap="none" normalizeH="0" baseline="0" dirty="0">
+                <a:ln>
+                  <a:noFill/>
+                </a:ln>
+                <a:solidFill>
+                  <a:srgbClr val="424242"/>
+                </a:solidFill>
+                <a:effectLst/>
+                <a:latin typeface="Arial Unicode MS"/>
+                <a:ea typeface="source-code-pro"/>
+              </a:rPr>
+              <a:t>├── Shared/ </a:t>
+            </a:r>
+            <a:r>
+              <a:rPr kumimoji="0" lang="en-US" altLang="en-IL" sz="1000" b="0" i="0" u="none" strike="noStrike" cap="none" normalizeH="0" baseline="0" dirty="0">
+                <a:ln>
+                  <a:noFill/>
+                </a:ln>
+                <a:solidFill>
+                  <a:srgbClr val="424242"/>
+                </a:solidFill>
+                <a:effectLst/>
+                <a:latin typeface="Arial Unicode MS"/>
+                <a:ea typeface="source-code-pro"/>
+              </a:rPr>
+              <a:t>			</a:t>
+            </a:r>
+            <a:r>
+              <a:rPr kumimoji="0" lang="en-IL" altLang="en-IL" sz="1000" b="0" i="0" u="none" strike="noStrike" cap="none" normalizeH="0" baseline="0" dirty="0">
+                <a:ln>
+                  <a:noFill/>
+                </a:ln>
+                <a:solidFill>
+                  <a:srgbClr val="424242"/>
+                </a:solidFill>
+                <a:effectLst/>
+                <a:latin typeface="Arial Unicode MS"/>
+                <a:ea typeface="source-code-pro"/>
+              </a:rPr>
+              <a:t>← </a:t>
+            </a:r>
+            <a:r>
+              <a:rPr kumimoji="0" lang="en-US" altLang="en-IL" sz="1000" b="0" i="0" u="none" strike="noStrike" cap="none" normalizeH="0" baseline="0" dirty="0">
+                <a:ln>
+                  <a:noFill/>
+                </a:ln>
+                <a:solidFill>
+                  <a:srgbClr val="424242"/>
+                </a:solidFill>
+                <a:effectLst/>
+                <a:latin typeface="Arial Unicode MS"/>
+                <a:ea typeface="source-code-pro"/>
+                <a:cs typeface="Arial" panose="020B0604020202020204" pitchFamily="34" charset="0"/>
+              </a:rPr>
+              <a:t>Shared code </a:t>
+            </a:r>
+            <a:r>
+              <a:rPr kumimoji="0" lang="en-IL" altLang="en-IL" sz="1000" b="0" i="0" u="none" strike="noStrike" cap="none" normalizeH="0" baseline="0" dirty="0">
+                <a:ln>
+                  <a:noFill/>
+                </a:ln>
+                <a:solidFill>
+                  <a:srgbClr val="424242"/>
+                </a:solidFill>
+                <a:effectLst/>
+                <a:latin typeface="Arial Unicode MS"/>
+                <a:ea typeface="source-code-pro"/>
+              </a:rPr>
+              <a:t>(DTOs, Utils </a:t>
+            </a:r>
+            <a:r>
+              <a:rPr kumimoji="0" lang="en-US" altLang="en-IL" sz="1000" b="0" i="0" u="none" strike="noStrike" cap="none" normalizeH="0" baseline="0" dirty="0">
+                <a:ln>
+                  <a:noFill/>
+                </a:ln>
+                <a:solidFill>
+                  <a:srgbClr val="424242"/>
+                </a:solidFill>
+                <a:effectLst/>
+                <a:latin typeface="Arial Unicode MS"/>
+                <a:ea typeface="source-code-pro"/>
+                <a:cs typeface="Arial" panose="020B0604020202020204" pitchFamily="34" charset="0"/>
+              </a:rPr>
+              <a:t>etc.</a:t>
+            </a:r>
+            <a:r>
+              <a:rPr kumimoji="0" lang="en-IL" altLang="en-IL" sz="1000" b="0" i="0" u="none" strike="noStrike" cap="none" normalizeH="0" baseline="0" dirty="0">
+                <a:ln>
+                  <a:noFill/>
+                </a:ln>
+                <a:solidFill>
+                  <a:srgbClr val="424242"/>
+                </a:solidFill>
+                <a:effectLst/>
+                <a:latin typeface="Arial Unicode MS"/>
+                <a:ea typeface="source-code-pro"/>
+              </a:rPr>
+              <a:t>) </a:t>
+            </a:r>
+            <a:endParaRPr kumimoji="0" lang="en-US" altLang="en-IL" sz="1000" b="0" i="0" u="none" strike="noStrike" cap="none" normalizeH="0" baseline="0" dirty="0">
+              <a:ln>
+                <a:noFill/>
+              </a:ln>
+              <a:solidFill>
+                <a:srgbClr val="424242"/>
+              </a:solidFill>
+              <a:effectLst/>
+              <a:latin typeface="Arial Unicode MS"/>
+              <a:ea typeface="source-code-pro"/>
+            </a:endParaRPr>
+          </a:p>
+          <a:p>
+            <a:pPr marL="0" marR="0" lvl="0" indent="0" algn="l" defTabSz="914400" rtl="0" eaLnBrk="0" fontAlgn="base" latinLnBrk="0" hangingPunct="0">
+              <a:lnSpc>
+                <a:spcPct val="100000"/>
+              </a:lnSpc>
+              <a:spcBef>
+                <a:spcPct val="0"/>
+              </a:spcBef>
+              <a:spcAft>
+                <a:spcPct val="0"/>
+              </a:spcAft>
+              <a:buClrTx/>
+              <a:buSzTx/>
+              <a:buFontTx/>
+              <a:buNone/>
+              <a:tabLst/>
+            </a:pPr>
+            <a:r>
+              <a:rPr kumimoji="0" lang="en-IL" altLang="en-IL" sz="1000" b="0" i="0" u="none" strike="noStrike" cap="none" normalizeH="0" baseline="0" dirty="0">
+                <a:ln>
+                  <a:noFill/>
+                </a:ln>
+                <a:solidFill>
+                  <a:srgbClr val="424242"/>
+                </a:solidFill>
+                <a:effectLst/>
+                <a:latin typeface="Arial Unicode MS"/>
+                <a:ea typeface="source-code-pro"/>
+              </a:rPr>
+              <a:t>├── Tests/ </a:t>
+            </a:r>
+            <a:endParaRPr kumimoji="0" lang="en-US" altLang="en-IL" sz="1000" b="0" i="0" u="none" strike="noStrike" cap="none" normalizeH="0" baseline="0" dirty="0">
+              <a:ln>
+                <a:noFill/>
+              </a:ln>
+              <a:solidFill>
+                <a:srgbClr val="424242"/>
+              </a:solidFill>
+              <a:effectLst/>
+              <a:latin typeface="Arial Unicode MS"/>
+              <a:ea typeface="source-code-pro"/>
+            </a:endParaRPr>
+          </a:p>
+          <a:p>
+            <a:pPr marL="0" marR="0" lvl="0" indent="0" algn="l" defTabSz="914400" rtl="0" eaLnBrk="0" fontAlgn="base" latinLnBrk="0" hangingPunct="0">
+              <a:lnSpc>
+                <a:spcPct val="100000"/>
+              </a:lnSpc>
+              <a:spcBef>
+                <a:spcPct val="0"/>
+              </a:spcBef>
+              <a:spcAft>
+                <a:spcPct val="0"/>
+              </a:spcAft>
+              <a:buClrTx/>
+              <a:buSzTx/>
+              <a:buFontTx/>
+              <a:buNone/>
+              <a:tabLst/>
+            </a:pPr>
+            <a:r>
+              <a:rPr kumimoji="0" lang="en-IL" altLang="en-IL" sz="1000" b="0" i="0" u="none" strike="noStrike" cap="none" normalizeH="0" baseline="0" dirty="0">
+                <a:ln>
+                  <a:noFill/>
+                </a:ln>
+                <a:solidFill>
+                  <a:srgbClr val="424242"/>
+                </a:solidFill>
+                <a:effectLst/>
+                <a:latin typeface="Arial Unicode MS"/>
+                <a:ea typeface="source-code-pro"/>
+              </a:rPr>
+              <a:t>│ ├── AuthService.Tests/ </a:t>
+            </a:r>
+            <a:endParaRPr kumimoji="0" lang="en-US" altLang="en-IL" sz="1000" b="0" i="0" u="none" strike="noStrike" cap="none" normalizeH="0" baseline="0" dirty="0">
+              <a:ln>
+                <a:noFill/>
+              </a:ln>
+              <a:solidFill>
+                <a:srgbClr val="424242"/>
+              </a:solidFill>
+              <a:effectLst/>
+              <a:latin typeface="Arial Unicode MS"/>
+              <a:ea typeface="source-code-pro"/>
+            </a:endParaRPr>
+          </a:p>
+          <a:p>
+            <a:pPr marL="0" marR="0" lvl="0" indent="0" algn="l" defTabSz="914400" rtl="0" eaLnBrk="0" fontAlgn="base" latinLnBrk="0" hangingPunct="0">
+              <a:lnSpc>
+                <a:spcPct val="100000"/>
+              </a:lnSpc>
+              <a:spcBef>
+                <a:spcPct val="0"/>
+              </a:spcBef>
+              <a:spcAft>
+                <a:spcPct val="0"/>
+              </a:spcAft>
+              <a:buClrTx/>
+              <a:buSzTx/>
+              <a:buFontTx/>
+              <a:buNone/>
+              <a:tabLst/>
+            </a:pPr>
+            <a:r>
+              <a:rPr kumimoji="0" lang="en-IL" altLang="en-IL" sz="1000" b="0" i="0" u="none" strike="noStrike" cap="none" normalizeH="0" baseline="0" dirty="0">
+                <a:ln>
+                  <a:noFill/>
+                </a:ln>
+                <a:solidFill>
+                  <a:srgbClr val="424242"/>
+                </a:solidFill>
+                <a:effectLst/>
+                <a:latin typeface="Arial Unicode MS"/>
+                <a:ea typeface="source-code-pro"/>
+              </a:rPr>
+              <a:t>│ ├── CustomersService.Tests/ </a:t>
+            </a:r>
+            <a:endParaRPr kumimoji="0" lang="en-US" altLang="en-IL" sz="1000" b="0" i="0" u="none" strike="noStrike" cap="none" normalizeH="0" baseline="0" dirty="0">
+              <a:ln>
+                <a:noFill/>
+              </a:ln>
+              <a:solidFill>
+                <a:srgbClr val="424242"/>
+              </a:solidFill>
+              <a:effectLst/>
+              <a:latin typeface="Arial Unicode MS"/>
+              <a:ea typeface="source-code-pro"/>
+            </a:endParaRPr>
+          </a:p>
+          <a:p>
+            <a:pPr marL="0" marR="0" lvl="0" indent="0" algn="l" defTabSz="914400" rtl="0" eaLnBrk="0" fontAlgn="base" latinLnBrk="0" hangingPunct="0">
+              <a:lnSpc>
+                <a:spcPct val="100000"/>
+              </a:lnSpc>
+              <a:spcBef>
+                <a:spcPct val="0"/>
+              </a:spcBef>
+              <a:spcAft>
+                <a:spcPct val="0"/>
+              </a:spcAft>
+              <a:buClrTx/>
+              <a:buSzTx/>
+              <a:buFontTx/>
+              <a:buNone/>
+              <a:tabLst/>
+            </a:pPr>
+            <a:r>
+              <a:rPr kumimoji="0" lang="en-IL" altLang="en-IL" sz="1000" b="0" i="0" u="none" strike="noStrike" cap="none" normalizeH="0" baseline="0" dirty="0">
+                <a:ln>
+                  <a:noFill/>
+                </a:ln>
+                <a:solidFill>
+                  <a:srgbClr val="424242"/>
+                </a:solidFill>
+                <a:effectLst/>
+                <a:latin typeface="Arial Unicode MS"/>
+                <a:ea typeface="source-code-pro"/>
+              </a:rPr>
+              <a:t>│ └── ... </a:t>
+            </a:r>
+            <a:endParaRPr kumimoji="0" lang="en-US" altLang="en-IL" sz="1000" b="0" i="0" u="none" strike="noStrike" cap="none" normalizeH="0" baseline="0" dirty="0">
+              <a:ln>
+                <a:noFill/>
+              </a:ln>
+              <a:solidFill>
+                <a:srgbClr val="424242"/>
+              </a:solidFill>
+              <a:effectLst/>
+              <a:latin typeface="Arial Unicode MS"/>
+              <a:ea typeface="source-code-pro"/>
+            </a:endParaRPr>
+          </a:p>
+          <a:p>
+            <a:pPr marL="0" marR="0" lvl="0" indent="0" algn="l" defTabSz="914400" rtl="0" eaLnBrk="0" fontAlgn="base" latinLnBrk="0" hangingPunct="0">
+              <a:lnSpc>
+                <a:spcPct val="100000"/>
+              </a:lnSpc>
+              <a:spcBef>
+                <a:spcPct val="0"/>
+              </a:spcBef>
+              <a:spcAft>
+                <a:spcPct val="0"/>
+              </a:spcAft>
+              <a:buClrTx/>
+              <a:buSzTx/>
+              <a:buFontTx/>
+              <a:buNone/>
+              <a:tabLst/>
+            </a:pPr>
+            <a:r>
+              <a:rPr kumimoji="0" lang="en-IL" altLang="en-IL" sz="1000" b="0" i="0" u="none" strike="noStrike" cap="none" normalizeH="0" baseline="0" dirty="0">
+                <a:ln>
+                  <a:noFill/>
+                </a:ln>
+                <a:solidFill>
+                  <a:srgbClr val="424242"/>
+                </a:solidFill>
+                <a:effectLst/>
+                <a:latin typeface="Arial Unicode MS"/>
+                <a:ea typeface="source-code-pro"/>
+              </a:rPr>
+              <a:t>├── Documentation/ </a:t>
+            </a:r>
+            <a:r>
+              <a:rPr kumimoji="0" lang="en-US" altLang="en-IL" sz="1000" b="0" i="0" u="none" strike="noStrike" cap="none" normalizeH="0" baseline="0" dirty="0">
+                <a:ln>
+                  <a:noFill/>
+                </a:ln>
+                <a:solidFill>
+                  <a:srgbClr val="424242"/>
+                </a:solidFill>
+                <a:effectLst/>
+                <a:latin typeface="Arial Unicode MS"/>
+                <a:ea typeface="source-code-pro"/>
+              </a:rPr>
+              <a:t>		</a:t>
+            </a:r>
+            <a:r>
+              <a:rPr kumimoji="0" lang="en-IL" altLang="en-IL" sz="1000" b="0" i="0" u="none" strike="noStrike" cap="none" normalizeH="0" baseline="0" dirty="0">
+                <a:ln>
+                  <a:noFill/>
+                </a:ln>
+                <a:solidFill>
+                  <a:srgbClr val="424242"/>
+                </a:solidFill>
+                <a:effectLst/>
+                <a:latin typeface="Arial Unicode MS"/>
+                <a:ea typeface="source-code-pro"/>
+              </a:rPr>
+              <a:t>← SRS, SDD </a:t>
+            </a:r>
+            <a:r>
+              <a:rPr kumimoji="0" lang="en-US" altLang="en-IL" sz="1000" b="0" i="0" u="none" strike="noStrike" cap="none" normalizeH="0" baseline="0" dirty="0">
+                <a:ln>
+                  <a:noFill/>
+                </a:ln>
+                <a:solidFill>
+                  <a:srgbClr val="424242"/>
+                </a:solidFill>
+                <a:effectLst/>
+                <a:latin typeface="Arial Unicode MS"/>
+                <a:ea typeface="source-code-pro"/>
+                <a:cs typeface="Arial" panose="020B0604020202020204" pitchFamily="34" charset="0"/>
+              </a:rPr>
+              <a:t>documents etc.</a:t>
+            </a:r>
+            <a:r>
+              <a:rPr kumimoji="0" lang="en-IL" altLang="en-IL" sz="1000" b="0" i="0" u="none" strike="noStrike" cap="none" normalizeH="0" baseline="0" dirty="0">
+                <a:ln>
+                  <a:noFill/>
+                </a:ln>
+                <a:solidFill>
+                  <a:srgbClr val="424242"/>
+                </a:solidFill>
+                <a:effectLst/>
+                <a:latin typeface="Arial Unicode MS"/>
+                <a:ea typeface="source-code-pro"/>
+              </a:rPr>
+              <a:t> </a:t>
+            </a:r>
+            <a:endParaRPr kumimoji="0" lang="en-US" altLang="en-IL" sz="1000" b="0" i="0" u="none" strike="noStrike" cap="none" normalizeH="0" baseline="0" dirty="0">
+              <a:ln>
+                <a:noFill/>
+              </a:ln>
+              <a:solidFill>
+                <a:srgbClr val="424242"/>
+              </a:solidFill>
+              <a:effectLst/>
+              <a:latin typeface="Arial Unicode MS"/>
+              <a:ea typeface="source-code-pro"/>
+            </a:endParaRPr>
+          </a:p>
+          <a:p>
+            <a:pPr marL="0" marR="0" lvl="0" indent="0" algn="l" defTabSz="914400" rtl="0" eaLnBrk="0" fontAlgn="base" latinLnBrk="0" hangingPunct="0">
+              <a:lnSpc>
+                <a:spcPct val="100000"/>
+              </a:lnSpc>
+              <a:spcBef>
+                <a:spcPct val="0"/>
+              </a:spcBef>
+              <a:spcAft>
+                <a:spcPct val="0"/>
+              </a:spcAft>
+              <a:buClrTx/>
+              <a:buSzTx/>
+              <a:buFontTx/>
+              <a:buNone/>
+              <a:tabLst/>
+            </a:pPr>
+            <a:r>
+              <a:rPr kumimoji="0" lang="en-IL" altLang="en-IL" sz="1000" b="0" i="0" u="none" strike="noStrike" cap="none" normalizeH="0" baseline="0" dirty="0">
+                <a:ln>
+                  <a:noFill/>
+                </a:ln>
+                <a:solidFill>
+                  <a:srgbClr val="424242"/>
+                </a:solidFill>
+                <a:effectLst/>
+                <a:latin typeface="Arial Unicode MS"/>
+                <a:ea typeface="source-code-pro"/>
+              </a:rPr>
+              <a:t>├── docker-compose.yml </a:t>
+            </a:r>
+            <a:endParaRPr kumimoji="0" lang="en-US" altLang="en-IL" sz="1000" b="0" i="0" u="none" strike="noStrike" cap="none" normalizeH="0" baseline="0" dirty="0">
+              <a:ln>
+                <a:noFill/>
+              </a:ln>
+              <a:solidFill>
+                <a:srgbClr val="424242"/>
+              </a:solidFill>
+              <a:effectLst/>
+              <a:latin typeface="Arial Unicode MS"/>
+              <a:ea typeface="source-code-pro"/>
+            </a:endParaRPr>
+          </a:p>
+          <a:p>
+            <a:pPr marL="0" marR="0" lvl="0" indent="0" algn="l" defTabSz="914400" rtl="0" eaLnBrk="0" fontAlgn="base" latinLnBrk="0" hangingPunct="0">
+              <a:lnSpc>
+                <a:spcPct val="100000"/>
+              </a:lnSpc>
+              <a:spcBef>
+                <a:spcPct val="0"/>
+              </a:spcBef>
+              <a:spcAft>
+                <a:spcPct val="0"/>
+              </a:spcAft>
+              <a:buClrTx/>
+              <a:buSzTx/>
+              <a:buFontTx/>
+              <a:buNone/>
+              <a:tabLst/>
+            </a:pPr>
+            <a:r>
+              <a:rPr kumimoji="0" lang="en-IL" altLang="en-IL" sz="1000" b="0" i="0" u="none" strike="noStrike" cap="none" normalizeH="0" baseline="0" dirty="0">
+                <a:ln>
+                  <a:noFill/>
+                </a:ln>
+                <a:solidFill>
+                  <a:srgbClr val="424242"/>
+                </a:solidFill>
+                <a:effectLst/>
+                <a:latin typeface="Arial Unicode MS"/>
+                <a:ea typeface="source-code-pro"/>
+              </a:rPr>
+              <a:t>├── docker-compose.override.yml </a:t>
+            </a:r>
+            <a:endParaRPr kumimoji="0" lang="en-US" altLang="en-IL" sz="1000" b="0" i="0" u="none" strike="noStrike" cap="none" normalizeH="0" baseline="0" dirty="0">
+              <a:ln>
+                <a:noFill/>
+              </a:ln>
+              <a:solidFill>
+                <a:srgbClr val="424242"/>
+              </a:solidFill>
+              <a:effectLst/>
+              <a:latin typeface="Arial Unicode MS"/>
+              <a:ea typeface="source-code-pro"/>
+            </a:endParaRPr>
+          </a:p>
+          <a:p>
+            <a:pPr marL="0" marR="0" lvl="0" indent="0" algn="l" defTabSz="914400" rtl="0" eaLnBrk="0" fontAlgn="base" latinLnBrk="0" hangingPunct="0">
+              <a:lnSpc>
+                <a:spcPct val="100000"/>
+              </a:lnSpc>
+              <a:spcBef>
+                <a:spcPct val="0"/>
+              </a:spcBef>
+              <a:spcAft>
+                <a:spcPct val="0"/>
+              </a:spcAft>
+              <a:buClrTx/>
+              <a:buSzTx/>
+              <a:buFontTx/>
+              <a:buNone/>
+              <a:tabLst/>
+            </a:pPr>
+            <a:r>
+              <a:rPr kumimoji="0" lang="en-IL" altLang="en-IL" sz="1000" b="0" i="0" u="none" strike="noStrike" cap="none" normalizeH="0" baseline="0" dirty="0">
+                <a:ln>
+                  <a:noFill/>
+                </a:ln>
+                <a:solidFill>
+                  <a:srgbClr val="424242"/>
+                </a:solidFill>
+                <a:effectLst/>
+                <a:latin typeface="Arial Unicode MS"/>
+                <a:ea typeface="source-code-pro"/>
+              </a:rPr>
+              <a:t>└── A2C.sln </a:t>
+            </a:r>
+            <a:r>
+              <a:rPr kumimoji="0" lang="en-US" altLang="en-IL" sz="1000" b="0" i="0" u="none" strike="noStrike" cap="none" normalizeH="0" baseline="0" dirty="0">
+                <a:ln>
+                  <a:noFill/>
+                </a:ln>
+                <a:solidFill>
+                  <a:srgbClr val="424242"/>
+                </a:solidFill>
+                <a:effectLst/>
+                <a:latin typeface="Arial Unicode MS"/>
+                <a:ea typeface="source-code-pro"/>
+              </a:rPr>
+              <a:t>			</a:t>
+            </a:r>
+            <a:r>
+              <a:rPr kumimoji="0" lang="en-IL" altLang="en-IL" sz="1000" b="0" i="0" u="none" strike="noStrike" cap="none" normalizeH="0" baseline="0" dirty="0">
+                <a:ln>
+                  <a:noFill/>
+                </a:ln>
+                <a:solidFill>
+                  <a:srgbClr val="424242"/>
+                </a:solidFill>
+                <a:effectLst/>
+                <a:latin typeface="Arial Unicode MS"/>
+                <a:ea typeface="source-code-pro"/>
+              </a:rPr>
+              <a:t>← </a:t>
+            </a:r>
+            <a:r>
+              <a:rPr lang="en-US" altLang="en-IL" sz="1000" dirty="0">
+                <a:solidFill>
+                  <a:srgbClr val="424242"/>
+                </a:solidFill>
+                <a:latin typeface="Arial Unicode MS"/>
+                <a:ea typeface="source-code-pro"/>
+                <a:cs typeface="Arial" panose="020B0604020202020204" pitchFamily="34" charset="0"/>
+              </a:rPr>
+              <a:t>Main </a:t>
+            </a:r>
+            <a:r>
+              <a:rPr kumimoji="0" lang="en-IL" altLang="en-IL" sz="1000" b="0" i="0" u="none" strike="noStrike" cap="none" normalizeH="0" baseline="0" dirty="0">
+                <a:ln>
+                  <a:noFill/>
+                </a:ln>
+                <a:solidFill>
+                  <a:srgbClr val="424242"/>
+                </a:solidFill>
+                <a:effectLst/>
+                <a:latin typeface="Arial Unicode MS"/>
+                <a:ea typeface="source-code-pro"/>
+              </a:rPr>
+              <a:t>Solution </a:t>
+            </a:r>
+            <a:r>
+              <a:rPr kumimoji="0" lang="en-US" altLang="en-IL" sz="1000" b="0" i="0" u="none" strike="noStrike" cap="none" normalizeH="0" baseline="0" dirty="0">
+                <a:ln>
+                  <a:noFill/>
+                </a:ln>
+                <a:solidFill>
+                  <a:srgbClr val="424242"/>
+                </a:solidFill>
+                <a:effectLst/>
+                <a:latin typeface="Arial Unicode MS"/>
+                <a:ea typeface="source-code-pro"/>
+                <a:cs typeface="Arial" panose="020B0604020202020204" pitchFamily="34" charset="0"/>
+              </a:rPr>
+              <a:t>file</a:t>
+            </a:r>
+            <a:endParaRPr kumimoji="0" lang="en-IL" altLang="en-IL" sz="1800" b="0" i="0" u="none" strike="noStrike" cap="none" normalizeH="0" baseline="0" dirty="0">
+              <a:ln>
+                <a:noFill/>
+              </a:ln>
+              <a:solidFill>
+                <a:schemeClr val="tx1"/>
+              </a:solidFill>
+              <a:effectLst/>
+              <a:latin typeface="Arial" panose="020B0604020202020204" pitchFamily="34" charset="0"/>
+            </a:endParaRPr>
+          </a:p>
+        </p:txBody>
+      </p:sp>
+      <p:cxnSp>
+        <p:nvCxnSpPr>
+          <p:cNvPr id="5" name="Straight Connector 4">
+            <a:extLst>
+              <a:ext uri="{FF2B5EF4-FFF2-40B4-BE49-F238E27FC236}">
+                <a16:creationId xmlns:a16="http://schemas.microsoft.com/office/drawing/2014/main" id="{2775D967-AD34-DFF9-109B-EBB1CB82D2BA}"/>
+              </a:ext>
+            </a:extLst>
+          </p:cNvPr>
+          <p:cNvCxnSpPr>
+            <a:cxnSpLocks/>
+          </p:cNvCxnSpPr>
+          <p:nvPr/>
+        </p:nvCxnSpPr>
+        <p:spPr>
+          <a:xfrm>
+            <a:off x="2157984" y="1078992"/>
+            <a:ext cx="0" cy="2679192"/>
+          </a:xfrm>
+          <a:prstGeom prst="line">
+            <a:avLst/>
+          </a:prstGeom>
+        </p:spPr>
+        <p:style>
+          <a:lnRef idx="3">
+            <a:schemeClr val="dk1"/>
+          </a:lnRef>
+          <a:fillRef idx="0">
+            <a:schemeClr val="dk1"/>
+          </a:fillRef>
+          <a:effectRef idx="2">
+            <a:schemeClr val="dk1"/>
+          </a:effectRef>
+          <a:fontRef idx="minor">
+            <a:schemeClr val="tx1"/>
+          </a:fontRef>
+        </p:style>
+      </p:cxnSp>
+    </p:spTree>
+    <p:extLst>
+      <p:ext uri="{BB962C8B-B14F-4D97-AF65-F5344CB8AC3E}">
+        <p14:creationId xmlns:p14="http://schemas.microsoft.com/office/powerpoint/2010/main" val="2027742940"/>
+      </p:ext>
+    </p:extLst>
+  </p:cSld>
+  <p:clrMapOvr>
+    <a:masterClrMapping/>
+  </p:clrMapOvr>
+</p:sld>
+</file>
+
+<file path=ppt/slides/slide5.xml><?xml version="1.0" encoding="utf-8"?>
+<p:sld xmlns:a="http://schemas.openxmlformats.org/drawingml/2006/main" xmlns:r="http://schemas.openxmlformats.org/officeDocument/2006/relationships" xmlns:p="http://schemas.openxmlformats.org/presentationml/2006/main">
+  <p:cSld>
+    <p:spTree>
+      <p:nvGrpSpPr>
+        <p:cNvPr id="1" name=""/>
+        <p:cNvGrpSpPr/>
+        <p:nvPr/>
+      </p:nvGrpSpPr>
+      <p:grpSpPr>
+        <a:xfrm>
+          <a:off x="0" y="0"/>
+          <a:ext cx="0" cy="0"/>
+          <a:chOff x="0" y="0"/>
+          <a:chExt cx="0" cy="0"/>
+        </a:xfrm>
+      </p:grpSpPr>
+      <p:pic>
+        <p:nvPicPr>
+          <p:cNvPr id="3" name="Picture 2">
+            <a:extLst>
+              <a:ext uri="{FF2B5EF4-FFF2-40B4-BE49-F238E27FC236}">
+                <a16:creationId xmlns:a16="http://schemas.microsoft.com/office/drawing/2014/main" id="{D7C46D48-8519-3261-C8EE-454CC2EDF1AA}"/>
+              </a:ext>
+            </a:extLst>
+          </p:cNvPr>
+          <p:cNvPicPr>
+            <a:picLocks noChangeAspect="1"/>
+          </p:cNvPicPr>
+          <p:nvPr/>
+        </p:nvPicPr>
+        <p:blipFill>
+          <a:blip r:embed="rId2"/>
+          <a:stretch>
+            <a:fillRect/>
+          </a:stretch>
+        </p:blipFill>
+        <p:spPr>
+          <a:xfrm>
+            <a:off x="4581313" y="380574"/>
+            <a:ext cx="3029373" cy="6096851"/>
+          </a:xfrm>
+          <a:prstGeom prst="rect">
+            <a:avLst/>
+          </a:prstGeom>
+        </p:spPr>
+      </p:pic>
+    </p:spTree>
+    <p:extLst>
+      <p:ext uri="{BB962C8B-B14F-4D97-AF65-F5344CB8AC3E}">
+        <p14:creationId xmlns:p14="http://schemas.microsoft.com/office/powerpoint/2010/main" val="1299460525"/>
+      </p:ext>
+    </p:extLst>
+  </p:cSld>
+  <p:clrMapOvr>
+    <a:masterClrMapping/>
+  </p:clrMapOvr>
+</p:sld>
+</file>
+
+<file path=ppt/slides/slide6.xml><?xml version="1.0" encoding="utf-8"?>
+<p:sld xmlns:a="http://schemas.openxmlformats.org/drawingml/2006/main" xmlns:r="http://schemas.openxmlformats.org/officeDocument/2006/relationships" xmlns:p="http://schemas.openxmlformats.org/presentationml/2006/main">
+  <p:cSld>
+    <p:spTree>
+      <p:nvGrpSpPr>
+        <p:cNvPr id="1" name=""/>
+        <p:cNvGrpSpPr/>
+        <p:nvPr/>
+      </p:nvGrpSpPr>
+      <p:grpSpPr>
+        <a:xfrm>
+          <a:off x="0" y="0"/>
+          <a:ext cx="0" cy="0"/>
+          <a:chOff x="0" y="0"/>
+          <a:chExt cx="0" cy="0"/>
+        </a:xfrm>
+      </p:grpSpPr>
       <p:grpSp>
         <p:nvGrpSpPr>
           <p:cNvPr id="4" name="Group 3">
@@ -11440,7 +13045,7 @@
 </p:sld>
 </file>
 
-<file path=ppt/slides/slide5.xml><?xml version="1.0" encoding="utf-8"?>
+<file path=ppt/slides/slide7.xml><?xml version="1.0" encoding="utf-8"?>
 <p:sld xmlns:a="http://schemas.openxmlformats.org/drawingml/2006/main" xmlns:r="http://schemas.openxmlformats.org/officeDocument/2006/relationships" xmlns:p="http://schemas.openxmlformats.org/presentationml/2006/main">
   <p:cSld>
     <p:spTree>
@@ -12836,7 +14441,7 @@
 </p:sld>
 </file>
 
-<file path=ppt/slides/slide6.xml><?xml version="1.0" encoding="utf-8"?>
+<file path=ppt/slides/slide8.xml><?xml version="1.0" encoding="utf-8"?>
 <p:sld xmlns:a="http://schemas.openxmlformats.org/drawingml/2006/main" xmlns:r="http://schemas.openxmlformats.org/officeDocument/2006/relationships" xmlns:p="http://schemas.openxmlformats.org/presentationml/2006/main">
   <p:cSld>
     <p:spTree>
@@ -12926,7 +14531,7 @@
                 <a:ea typeface="Yu Gothic" panose="020B0400000000000000" pitchFamily="34" charset="-128"/>
                 <a:cs typeface="Arial" panose="020B0604020202020204" pitchFamily="34" charset="0"/>
               </a:rPr>
-              <a:t>A2C (Root)</a:t>
+              <a:t>A2C</a:t>
             </a:r>
             <a:endParaRPr kumimoji="0" lang="en-IL" altLang="en-IL" sz="4000" b="0" i="0" u="none" strike="noStrike" cap="none" normalizeH="0" baseline="0" dirty="0">
               <a:ln>
@@ -13197,7 +14802,7 @@
         </p:nvSpPr>
         <p:spPr bwMode="auto">
           <a:xfrm>
-            <a:off x="1283208" y="5817564"/>
+            <a:off x="1283208" y="6338772"/>
             <a:ext cx="1675482" cy="359441"/>
           </a:xfrm>
           <a:prstGeom prst="roundRect">
@@ -13264,9 +14869,9 @@
           <p:nvPr/>
         </p:nvCxnSpPr>
         <p:spPr>
-          <a:xfrm flipH="1">
-            <a:off x="625882" y="996606"/>
-            <a:ext cx="8184" cy="4979119"/>
+          <a:xfrm>
+            <a:off x="634066" y="996606"/>
+            <a:ext cx="0" cy="5500327"/>
           </a:xfrm>
           <a:prstGeom prst="line">
             <a:avLst/>
@@ -13379,7 +14984,7 @@
         </p:nvCxnSpPr>
         <p:spPr>
           <a:xfrm>
-            <a:off x="624922" y="5975725"/>
+            <a:off x="624922" y="6496933"/>
             <a:ext cx="658286" cy="0"/>
           </a:xfrm>
           <a:prstGeom prst="line">
@@ -14344,6 +15949,282 @@
           </a:fontRef>
         </p:style>
       </p:cxnSp>
+      <p:sp>
+        <p:nvSpPr>
+          <p:cNvPr id="11" name="AutoShape 13">
+            <a:extLst>
+              <a:ext uri="{FF2B5EF4-FFF2-40B4-BE49-F238E27FC236}">
+                <a16:creationId xmlns:a16="http://schemas.microsoft.com/office/drawing/2014/main" id="{F799A10B-14C1-1B55-ACA7-1DABE0E798E4}"/>
+              </a:ext>
+            </a:extLst>
+          </p:cNvPr>
+          <p:cNvSpPr>
+            <a:spLocks noChangeArrowheads="1"/>
+          </p:cNvSpPr>
+          <p:nvPr/>
+        </p:nvSpPr>
+        <p:spPr bwMode="auto">
+          <a:xfrm>
+            <a:off x="1286449" y="5132300"/>
+            <a:ext cx="832104" cy="305112"/>
+          </a:xfrm>
+          <a:prstGeom prst="roundRect">
+            <a:avLst>
+              <a:gd name="adj" fmla="val 16667"/>
+            </a:avLst>
+          </a:prstGeom>
+          <a:solidFill>
+            <a:schemeClr val="bg1"/>
+          </a:solidFill>
+          <a:ln w="12700">
+            <a:solidFill>
+              <a:srgbClr val="09101D"/>
+            </a:solidFill>
+            <a:miter lim="800000"/>
+            <a:headEnd/>
+            <a:tailEnd/>
+          </a:ln>
+        </p:spPr>
+        <p:txBody>
+          <a:bodyPr vert="horz" wrap="square" lIns="91440" tIns="45720" rIns="91440" bIns="45720" numCol="1" anchor="ctr" anchorCtr="0" compatLnSpc="1">
+            <a:prstTxWarp prst="textNoShape">
+              <a:avLst/>
+            </a:prstTxWarp>
+          </a:bodyPr>
+          <a:lstStyle/>
+          <a:p>
+            <a:pPr marL="0" marR="0" lvl="0" indent="0" algn="ctr" defTabSz="914400" rtl="0" eaLnBrk="0" fontAlgn="base" latinLnBrk="0" hangingPunct="0">
+              <a:lnSpc>
+                <a:spcPct val="100000"/>
+              </a:lnSpc>
+              <a:spcBef>
+                <a:spcPct val="0"/>
+              </a:spcBef>
+              <a:spcAft>
+                <a:spcPct val="0"/>
+              </a:spcAft>
+              <a:buClrTx/>
+              <a:buSzTx/>
+              <a:buFontTx/>
+              <a:buNone/>
+              <a:tabLst/>
+            </a:pPr>
+            <a:r>
+              <a:rPr kumimoji="0" lang="en-US" altLang="en-IL" b="0" i="0" u="none" strike="noStrike" cap="none" normalizeH="0" baseline="0" dirty="0">
+                <a:ln>
+                  <a:noFill/>
+                </a:ln>
+                <a:solidFill>
+                  <a:schemeClr val="tx1"/>
+                </a:solidFill>
+                <a:effectLst/>
+                <a:latin typeface="Calibri" panose="020F0502020204030204" pitchFamily="34" charset="0"/>
+                <a:ea typeface="Yu Gothic" panose="020B0400000000000000" pitchFamily="34" charset="-128"/>
+                <a:cs typeface="Arial" panose="020B0604020202020204" pitchFamily="34" charset="0"/>
+              </a:rPr>
+              <a:t>Tests</a:t>
+            </a:r>
+            <a:endParaRPr kumimoji="0" lang="en-IL" altLang="en-IL" sz="4000" b="0" i="0" u="none" strike="noStrike" cap="none" normalizeH="0" baseline="0" dirty="0">
+              <a:ln>
+                <a:noFill/>
+              </a:ln>
+              <a:solidFill>
+                <a:schemeClr val="tx1"/>
+              </a:solidFill>
+              <a:effectLst/>
+              <a:latin typeface="Arial" panose="020B0604020202020204" pitchFamily="34" charset="0"/>
+            </a:endParaRPr>
+          </a:p>
+        </p:txBody>
+      </p:sp>
+      <p:cxnSp>
+        <p:nvCxnSpPr>
+          <p:cNvPr id="12" name="Straight Connector 11">
+            <a:extLst>
+              <a:ext uri="{FF2B5EF4-FFF2-40B4-BE49-F238E27FC236}">
+                <a16:creationId xmlns:a16="http://schemas.microsoft.com/office/drawing/2014/main" id="{5C6BD2AB-A3B0-1F79-EF23-6F6E19FF3C4A}"/>
+              </a:ext>
+            </a:extLst>
+          </p:cNvPr>
+          <p:cNvCxnSpPr>
+            <a:cxnSpLocks/>
+          </p:cNvCxnSpPr>
+          <p:nvPr/>
+        </p:nvCxnSpPr>
+        <p:spPr>
+          <a:xfrm>
+            <a:off x="628163" y="5279671"/>
+            <a:ext cx="658286" cy="0"/>
+          </a:xfrm>
+          <a:prstGeom prst="line">
+            <a:avLst/>
+          </a:prstGeom>
+        </p:spPr>
+        <p:style>
+          <a:lnRef idx="2">
+            <a:schemeClr val="accent1"/>
+          </a:lnRef>
+          <a:fillRef idx="0">
+            <a:schemeClr val="accent1"/>
+          </a:fillRef>
+          <a:effectRef idx="1">
+            <a:schemeClr val="accent1"/>
+          </a:effectRef>
+          <a:fontRef idx="minor">
+            <a:schemeClr val="tx1"/>
+          </a:fontRef>
+        </p:style>
+      </p:cxnSp>
+      <p:sp>
+        <p:nvSpPr>
+          <p:cNvPr id="13" name="AutoShape 13">
+            <a:extLst>
+              <a:ext uri="{FF2B5EF4-FFF2-40B4-BE49-F238E27FC236}">
+                <a16:creationId xmlns:a16="http://schemas.microsoft.com/office/drawing/2014/main" id="{97672CD0-A1CE-374C-68C7-143497BCCE39}"/>
+              </a:ext>
+            </a:extLst>
+          </p:cNvPr>
+          <p:cNvSpPr>
+            <a:spLocks noChangeArrowheads="1"/>
+          </p:cNvSpPr>
+          <p:nvPr/>
+        </p:nvSpPr>
+        <p:spPr bwMode="auto">
+          <a:xfrm>
+            <a:off x="2259974" y="5708372"/>
+            <a:ext cx="2001130" cy="359440"/>
+          </a:xfrm>
+          <a:prstGeom prst="roundRect">
+            <a:avLst>
+              <a:gd name="adj" fmla="val 16667"/>
+            </a:avLst>
+          </a:prstGeom>
+          <a:solidFill>
+            <a:schemeClr val="bg1"/>
+          </a:solidFill>
+          <a:ln w="12700">
+            <a:solidFill>
+              <a:srgbClr val="09101D"/>
+            </a:solidFill>
+            <a:miter lim="800000"/>
+            <a:headEnd/>
+            <a:tailEnd/>
+          </a:ln>
+        </p:spPr>
+        <p:txBody>
+          <a:bodyPr vert="horz" wrap="square" lIns="91440" tIns="45720" rIns="91440" bIns="45720" numCol="1" anchor="ctr" anchorCtr="0" compatLnSpc="1">
+            <a:prstTxWarp prst="textNoShape">
+              <a:avLst/>
+            </a:prstTxWarp>
+          </a:bodyPr>
+          <a:lstStyle/>
+          <a:p>
+            <a:pPr lvl="0" algn="ctr" eaLnBrk="0" fontAlgn="base" hangingPunct="0">
+              <a:spcBef>
+                <a:spcPct val="0"/>
+              </a:spcBef>
+              <a:spcAft>
+                <a:spcPct val="0"/>
+              </a:spcAft>
+            </a:pPr>
+            <a:r>
+              <a:rPr lang="en-US" altLang="en-IL" dirty="0">
+                <a:latin typeface="Calibri" panose="020F0502020204030204" pitchFamily="34" charset="0"/>
+                <a:ea typeface="Yu Gothic" panose="020B0400000000000000" pitchFamily="34" charset="-128"/>
+                <a:cs typeface="Arial" panose="020B0604020202020204" pitchFamily="34" charset="0"/>
+              </a:rPr>
+              <a:t>A2C.CRM.Api.Tests</a:t>
+            </a:r>
+            <a:endParaRPr kumimoji="0" lang="en-IL" altLang="en-IL" sz="4000" b="0" i="0" u="none" strike="noStrike" cap="none" normalizeH="0" baseline="0" dirty="0">
+              <a:ln>
+                <a:noFill/>
+              </a:ln>
+              <a:solidFill>
+                <a:schemeClr val="tx1"/>
+              </a:solidFill>
+              <a:effectLst/>
+              <a:latin typeface="Arial" panose="020B0604020202020204" pitchFamily="34" charset="0"/>
+            </a:endParaRPr>
+          </a:p>
+        </p:txBody>
+      </p:sp>
+      <p:cxnSp>
+        <p:nvCxnSpPr>
+          <p:cNvPr id="14" name="Straight Connector 13">
+            <a:extLst>
+              <a:ext uri="{FF2B5EF4-FFF2-40B4-BE49-F238E27FC236}">
+                <a16:creationId xmlns:a16="http://schemas.microsoft.com/office/drawing/2014/main" id="{F2CC8B0A-5F34-9281-C371-A4FFFC090347}"/>
+              </a:ext>
+            </a:extLst>
+          </p:cNvPr>
+          <p:cNvCxnSpPr>
+            <a:cxnSpLocks/>
+          </p:cNvCxnSpPr>
+          <p:nvPr/>
+        </p:nvCxnSpPr>
+        <p:spPr>
+          <a:xfrm>
+            <a:off x="1718347" y="5446020"/>
+            <a:ext cx="0" cy="442071"/>
+          </a:xfrm>
+          <a:prstGeom prst="line">
+            <a:avLst/>
+          </a:prstGeom>
+        </p:spPr>
+        <p:style>
+          <a:lnRef idx="2">
+            <a:schemeClr val="accent1"/>
+          </a:lnRef>
+          <a:fillRef idx="0">
+            <a:schemeClr val="accent1"/>
+          </a:fillRef>
+          <a:effectRef idx="1">
+            <a:schemeClr val="accent1"/>
+          </a:effectRef>
+          <a:fontRef idx="minor">
+            <a:schemeClr val="tx1"/>
+          </a:fontRef>
+        </p:style>
+      </p:cxnSp>
+      <p:cxnSp>
+        <p:nvCxnSpPr>
+          <p:cNvPr id="16" name="Straight Connector 15">
+            <a:extLst>
+              <a:ext uri="{FF2B5EF4-FFF2-40B4-BE49-F238E27FC236}">
+                <a16:creationId xmlns:a16="http://schemas.microsoft.com/office/drawing/2014/main" id="{DDFF1663-547C-007D-0394-80FCA5C623AA}"/>
+              </a:ext>
+            </a:extLst>
+          </p:cNvPr>
+          <p:cNvCxnSpPr>
+            <a:cxnSpLocks/>
+            <a:endCxn id="13" idx="1"/>
+          </p:cNvCxnSpPr>
+          <p:nvPr/>
+        </p:nvCxnSpPr>
+        <p:spPr>
+          <a:xfrm>
+            <a:off x="1702914" y="5888091"/>
+            <a:ext cx="557060" cy="1"/>
+          </a:xfrm>
+          <a:prstGeom prst="line">
+            <a:avLst/>
+          </a:prstGeom>
+        </p:spPr>
+        <p:style>
+          <a:lnRef idx="2">
+            <a:schemeClr val="accent1"/>
+          </a:lnRef>
+          <a:fillRef idx="0">
+            <a:schemeClr val="accent1"/>
+          </a:fillRef>
+          <a:effectRef idx="1">
+            <a:schemeClr val="accent1"/>
+          </a:effectRef>
+          <a:fontRef idx="minor">
+            <a:schemeClr val="tx1"/>
+          </a:fontRef>
+        </p:style>
+      </p:cxnSp>
     </p:spTree>
     <p:extLst>
       <p:ext uri="{BB962C8B-B14F-4D97-AF65-F5344CB8AC3E}">
@@ -14357,7 +16238,7 @@
 </p:sld>
 </file>
 
-<file path=ppt/slides/slide7.xml><?xml version="1.0" encoding="utf-8"?>
+<file path=ppt/slides/slide9.xml><?xml version="1.0" encoding="utf-8"?>
 <p:sld xmlns:a="http://schemas.openxmlformats.org/drawingml/2006/main" xmlns:r="http://schemas.openxmlformats.org/officeDocument/2006/relationships" xmlns:p="http://schemas.openxmlformats.org/presentationml/2006/main">
   <p:cSld>
     <p:spTree>

</xml_diff>

<commit_message>
move forms to pages folder in client
</commit_message>
<xml_diff>
--- a/Documentations/SysArchitecture.pptx
+++ b/Documentations/SysArchitecture.pptx
@@ -9,8 +9,8 @@
     <p:sldId id="266" r:id="rId3"/>
     <p:sldId id="261" r:id="rId4"/>
     <p:sldId id="268" r:id="rId5"/>
-    <p:sldId id="269" r:id="rId6"/>
-    <p:sldId id="271" r:id="rId7"/>
+    <p:sldId id="271" r:id="rId6"/>
+    <p:sldId id="272" r:id="rId7"/>
     <p:sldId id="270" r:id="rId8"/>
     <p:sldId id="262" r:id="rId9"/>
     <p:sldId id="264" r:id="rId10"/>
@@ -271,7 +271,7 @@
           <a:p>
             <a:fld id="{8377380A-1819-462E-96FD-3D6CBD777CA0}" type="datetimeFigureOut">
               <a:rPr lang="en-IL" smtClean="0"/>
-              <a:t>18/08/2025</a:t>
+              <a:t>19/08/2025</a:t>
             </a:fld>
             <a:endParaRPr lang="en-IL"/>
           </a:p>
@@ -471,7 +471,7 @@
           <a:p>
             <a:fld id="{8377380A-1819-462E-96FD-3D6CBD777CA0}" type="datetimeFigureOut">
               <a:rPr lang="en-IL" smtClean="0"/>
-              <a:t>18/08/2025</a:t>
+              <a:t>19/08/2025</a:t>
             </a:fld>
             <a:endParaRPr lang="en-IL"/>
           </a:p>
@@ -681,7 +681,7 @@
           <a:p>
             <a:fld id="{8377380A-1819-462E-96FD-3D6CBD777CA0}" type="datetimeFigureOut">
               <a:rPr lang="en-IL" smtClean="0"/>
-              <a:t>18/08/2025</a:t>
+              <a:t>19/08/2025</a:t>
             </a:fld>
             <a:endParaRPr lang="en-IL"/>
           </a:p>
@@ -881,7 +881,7 @@
           <a:p>
             <a:fld id="{8377380A-1819-462E-96FD-3D6CBD777CA0}" type="datetimeFigureOut">
               <a:rPr lang="en-IL" smtClean="0"/>
-              <a:t>18/08/2025</a:t>
+              <a:t>19/08/2025</a:t>
             </a:fld>
             <a:endParaRPr lang="en-IL"/>
           </a:p>
@@ -1157,7 +1157,7 @@
           <a:p>
             <a:fld id="{8377380A-1819-462E-96FD-3D6CBD777CA0}" type="datetimeFigureOut">
               <a:rPr lang="en-IL" smtClean="0"/>
-              <a:t>18/08/2025</a:t>
+              <a:t>19/08/2025</a:t>
             </a:fld>
             <a:endParaRPr lang="en-IL"/>
           </a:p>
@@ -1425,7 +1425,7 @@
           <a:p>
             <a:fld id="{8377380A-1819-462E-96FD-3D6CBD777CA0}" type="datetimeFigureOut">
               <a:rPr lang="en-IL" smtClean="0"/>
-              <a:t>18/08/2025</a:t>
+              <a:t>19/08/2025</a:t>
             </a:fld>
             <a:endParaRPr lang="en-IL"/>
           </a:p>
@@ -1840,7 +1840,7 @@
           <a:p>
             <a:fld id="{8377380A-1819-462E-96FD-3D6CBD777CA0}" type="datetimeFigureOut">
               <a:rPr lang="en-IL" smtClean="0"/>
-              <a:t>18/08/2025</a:t>
+              <a:t>19/08/2025</a:t>
             </a:fld>
             <a:endParaRPr lang="en-IL"/>
           </a:p>
@@ -1982,7 +1982,7 @@
           <a:p>
             <a:fld id="{8377380A-1819-462E-96FD-3D6CBD777CA0}" type="datetimeFigureOut">
               <a:rPr lang="en-IL" smtClean="0"/>
-              <a:t>18/08/2025</a:t>
+              <a:t>19/08/2025</a:t>
             </a:fld>
             <a:endParaRPr lang="en-IL"/>
           </a:p>
@@ -2095,7 +2095,7 @@
           <a:p>
             <a:fld id="{8377380A-1819-462E-96FD-3D6CBD777CA0}" type="datetimeFigureOut">
               <a:rPr lang="en-IL" smtClean="0"/>
-              <a:t>18/08/2025</a:t>
+              <a:t>19/08/2025</a:t>
             </a:fld>
             <a:endParaRPr lang="en-IL"/>
           </a:p>
@@ -2408,7 +2408,7 @@
           <a:p>
             <a:fld id="{8377380A-1819-462E-96FD-3D6CBD777CA0}" type="datetimeFigureOut">
               <a:rPr lang="en-IL" smtClean="0"/>
-              <a:t>18/08/2025</a:t>
+              <a:t>19/08/2025</a:t>
             </a:fld>
             <a:endParaRPr lang="en-IL"/>
           </a:p>
@@ -2697,7 +2697,7 @@
           <a:p>
             <a:fld id="{8377380A-1819-462E-96FD-3D6CBD777CA0}" type="datetimeFigureOut">
               <a:rPr lang="en-IL" smtClean="0"/>
-              <a:t>18/08/2025</a:t>
+              <a:t>19/08/2025</a:t>
             </a:fld>
             <a:endParaRPr lang="en-IL"/>
           </a:p>
@@ -2940,7 +2940,7 @@
           <a:p>
             <a:fld id="{8377380A-1819-462E-96FD-3D6CBD777CA0}" type="datetimeFigureOut">
               <a:rPr lang="en-IL" smtClean="0"/>
-              <a:t>18/08/2025</a:t>
+              <a:t>19/08/2025</a:t>
             </a:fld>
             <a:endParaRPr lang="en-IL"/>
           </a:p>
@@ -11195,940 +11195,6 @@
 <file path=ppt/slides/slide5.xml><?xml version="1.0" encoding="utf-8"?>
 <p:sld xmlns:a="http://schemas.openxmlformats.org/drawingml/2006/main" xmlns:r="http://schemas.openxmlformats.org/officeDocument/2006/relationships" xmlns:p="http://schemas.openxmlformats.org/presentationml/2006/main">
   <p:cSld>
-    <p:bg>
-      <p:bgPr>
-        <a:solidFill>
-          <a:schemeClr val="bg1"/>
-        </a:solidFill>
-        <a:effectLst/>
-      </p:bgPr>
-    </p:bg>
-    <p:spTree>
-      <p:nvGrpSpPr>
-        <p:cNvPr id="1" name=""/>
-        <p:cNvGrpSpPr/>
-        <p:nvPr/>
-      </p:nvGrpSpPr>
-      <p:grpSpPr>
-        <a:xfrm>
-          <a:off x="0" y="0"/>
-          <a:ext cx="0" cy="0"/>
-          <a:chOff x="0" y="0"/>
-          <a:chExt cx="0" cy="0"/>
-        </a:xfrm>
-      </p:grpSpPr>
-      <p:sp>
-        <p:nvSpPr>
-          <p:cNvPr id="9" name="Rectangle 8">
-            <a:extLst>
-              <a:ext uri="{FF2B5EF4-FFF2-40B4-BE49-F238E27FC236}">
-                <a16:creationId xmlns:a16="http://schemas.microsoft.com/office/drawing/2014/main" id="{F3060C83-F051-4F0E-ABAD-AA0DFC48B218}"/>
-              </a:ext>
-              <a:ext uri="{C183D7F6-B498-43B3-948B-1728B52AA6E4}">
-                <adec:decorative xmlns:adec="http://schemas.microsoft.com/office/drawing/2017/decorative" val="1"/>
-              </a:ext>
-            </a:extLst>
-          </p:cNvPr>
-          <p:cNvSpPr>
-            <a:spLocks noGrp="1" noRot="1" noChangeAspect="1" noMove="1" noResize="1" noEditPoints="1" noAdjustHandles="1" noChangeArrowheads="1" noChangeShapeType="1" noTextEdit="1"/>
-          </p:cNvSpPr>
-          <p:nvPr>
-            <p:extLst>
-              <p:ext uri="{386F3935-93C4-4BCD-93E2-E3B085C9AB24}">
-                <p16:designElem xmlns:p16="http://schemas.microsoft.com/office/powerpoint/2015/main" val="1"/>
-              </p:ext>
-            </p:extLst>
-          </p:nvPr>
-        </p:nvSpPr>
-        <p:spPr>
-          <a:xfrm>
-            <a:off x="0" y="0"/>
-            <a:ext cx="12192000" cy="6858000"/>
-          </a:xfrm>
-          <a:prstGeom prst="rect">
-            <a:avLst/>
-          </a:prstGeom>
-          <a:solidFill>
-            <a:schemeClr val="bg1"/>
-          </a:solidFill>
-          <a:ln>
-            <a:noFill/>
-          </a:ln>
-        </p:spPr>
-        <p:style>
-          <a:lnRef idx="2">
-            <a:schemeClr val="accent1">
-              <a:shade val="50000"/>
-            </a:schemeClr>
-          </a:lnRef>
-          <a:fillRef idx="1">
-            <a:schemeClr val="accent1"/>
-          </a:fillRef>
-          <a:effectRef idx="0">
-            <a:schemeClr val="accent1"/>
-          </a:effectRef>
-          <a:fontRef idx="minor">
-            <a:schemeClr val="lt1"/>
-          </a:fontRef>
-        </p:style>
-        <p:txBody>
-          <a:bodyPr rtlCol="0" anchor="ctr"/>
-          <a:lstStyle/>
-          <a:p>
-            <a:pPr algn="ctr"/>
-            <a:endParaRPr lang="en-US" dirty="0"/>
-          </a:p>
-        </p:txBody>
-      </p:sp>
-      <p:sp>
-        <p:nvSpPr>
-          <p:cNvPr id="11" name="Freeform: Shape 10">
-            <a:extLst>
-              <a:ext uri="{FF2B5EF4-FFF2-40B4-BE49-F238E27FC236}">
-                <a16:creationId xmlns:a16="http://schemas.microsoft.com/office/drawing/2014/main" id="{83C98ABE-055B-441F-B07E-44F97F083C39}"/>
-              </a:ext>
-              <a:ext uri="{C183D7F6-B498-43B3-948B-1728B52AA6E4}">
-                <adec:decorative xmlns:adec="http://schemas.microsoft.com/office/drawing/2017/decorative" val="1"/>
-              </a:ext>
-            </a:extLst>
-          </p:cNvPr>
-          <p:cNvSpPr>
-            <a:spLocks noGrp="1" noRot="1" noChangeAspect="1" noMove="1" noResize="1" noEditPoints="1" noAdjustHandles="1" noChangeArrowheads="1" noChangeShapeType="1" noTextEdit="1"/>
-          </p:cNvSpPr>
-          <p:nvPr>
-            <p:extLst>
-              <p:ext uri="{386F3935-93C4-4BCD-93E2-E3B085C9AB24}">
-                <p16:designElem xmlns:p16="http://schemas.microsoft.com/office/powerpoint/2015/main" val="1"/>
-              </p:ext>
-            </p:extLst>
-          </p:nvPr>
-        </p:nvSpPr>
-        <p:spPr>
-          <a:xfrm rot="18900000" flipH="1">
-            <a:off x="-376156" y="-253670"/>
-            <a:ext cx="1827638" cy="1376989"/>
-          </a:xfrm>
-          <a:custGeom>
-            <a:avLst/>
-            <a:gdLst>
-              <a:gd name="connsiteX0" fmla="*/ 0 w 1827638"/>
-              <a:gd name="connsiteY0" fmla="*/ 987379 h 1376989"/>
-              <a:gd name="connsiteX1" fmla="*/ 987379 w 1827638"/>
-              <a:gd name="connsiteY1" fmla="*/ 0 h 1376989"/>
-              <a:gd name="connsiteX2" fmla="*/ 1827638 w 1827638"/>
-              <a:gd name="connsiteY2" fmla="*/ 840260 h 1376989"/>
-              <a:gd name="connsiteX3" fmla="*/ 1827638 w 1827638"/>
-              <a:gd name="connsiteY3" fmla="*/ 1376989 h 1376989"/>
-              <a:gd name="connsiteX4" fmla="*/ 0 w 1827638"/>
-              <a:gd name="connsiteY4" fmla="*/ 1376989 h 1376989"/>
-            </a:gdLst>
-            <a:ahLst/>
-            <a:cxnLst>
-              <a:cxn ang="0">
-                <a:pos x="connsiteX0" y="connsiteY0"/>
-              </a:cxn>
-              <a:cxn ang="0">
-                <a:pos x="connsiteX1" y="connsiteY1"/>
-              </a:cxn>
-              <a:cxn ang="0">
-                <a:pos x="connsiteX2" y="connsiteY2"/>
-              </a:cxn>
-              <a:cxn ang="0">
-                <a:pos x="connsiteX3" y="connsiteY3"/>
-              </a:cxn>
-              <a:cxn ang="0">
-                <a:pos x="connsiteX4" y="connsiteY4"/>
-              </a:cxn>
-            </a:cxnLst>
-            <a:rect l="l" t="t" r="r" b="b"/>
-            <a:pathLst>
-              <a:path w="1827638" h="1376989">
-                <a:moveTo>
-                  <a:pt x="0" y="987379"/>
-                </a:moveTo>
-                <a:lnTo>
-                  <a:pt x="987379" y="0"/>
-                </a:lnTo>
-                <a:lnTo>
-                  <a:pt x="1827638" y="840260"/>
-                </a:lnTo>
-                <a:lnTo>
-                  <a:pt x="1827638" y="1376989"/>
-                </a:lnTo>
-                <a:lnTo>
-                  <a:pt x="0" y="1376989"/>
-                </a:lnTo>
-                <a:close/>
-              </a:path>
-            </a:pathLst>
-          </a:custGeom>
-          <a:solidFill>
-            <a:schemeClr val="accent1">
-              <a:alpha val="30000"/>
-            </a:schemeClr>
-          </a:solidFill>
-          <a:ln>
-            <a:noFill/>
-          </a:ln>
-        </p:spPr>
-        <p:style>
-          <a:lnRef idx="2">
-            <a:schemeClr val="accent1">
-              <a:shade val="50000"/>
-            </a:schemeClr>
-          </a:lnRef>
-          <a:fillRef idx="1">
-            <a:schemeClr val="accent1"/>
-          </a:fillRef>
-          <a:effectRef idx="0">
-            <a:schemeClr val="accent1"/>
-          </a:effectRef>
-          <a:fontRef idx="minor">
-            <a:schemeClr val="lt1"/>
-          </a:fontRef>
-        </p:style>
-        <p:txBody>
-          <a:bodyPr rtlCol="0" anchor="ctr"/>
-          <a:lstStyle/>
-          <a:p>
-            <a:pPr algn="ctr"/>
-            <a:endParaRPr lang="en-US" dirty="0"/>
-          </a:p>
-        </p:txBody>
-      </p:sp>
-      <p:sp>
-        <p:nvSpPr>
-          <p:cNvPr id="13" name="Rectangle 12">
-            <a:extLst>
-              <a:ext uri="{FF2B5EF4-FFF2-40B4-BE49-F238E27FC236}">
-                <a16:creationId xmlns:a16="http://schemas.microsoft.com/office/drawing/2014/main" id="{29FDB030-9B49-4CED-8CCD-4D99382388AC}"/>
-              </a:ext>
-              <a:ext uri="{C183D7F6-B498-43B3-948B-1728B52AA6E4}">
-                <adec:decorative xmlns:adec="http://schemas.microsoft.com/office/drawing/2017/decorative" val="1"/>
-              </a:ext>
-            </a:extLst>
-          </p:cNvPr>
-          <p:cNvSpPr>
-            <a:spLocks noGrp="1" noRot="1" noChangeAspect="1" noMove="1" noResize="1" noEditPoints="1" noAdjustHandles="1" noChangeArrowheads="1" noChangeShapeType="1" noTextEdit="1"/>
-          </p:cNvSpPr>
-          <p:nvPr>
-            <p:extLst>
-              <p:ext uri="{386F3935-93C4-4BCD-93E2-E3B085C9AB24}">
-                <p16:designElem xmlns:p16="http://schemas.microsoft.com/office/powerpoint/2015/main" val="1"/>
-              </p:ext>
-            </p:extLst>
-          </p:nvPr>
-        </p:nvSpPr>
-        <p:spPr>
-          <a:xfrm rot="18900000" flipH="1">
-            <a:off x="891641" y="422146"/>
-            <a:ext cx="645368" cy="645368"/>
-          </a:xfrm>
-          <a:prstGeom prst="rect">
-            <a:avLst/>
-          </a:prstGeom>
-          <a:solidFill>
-            <a:schemeClr val="accent1">
-              <a:alpha val="30000"/>
-            </a:schemeClr>
-          </a:solidFill>
-          <a:ln>
-            <a:noFill/>
-          </a:ln>
-        </p:spPr>
-        <p:style>
-          <a:lnRef idx="2">
-            <a:schemeClr val="accent1">
-              <a:shade val="50000"/>
-            </a:schemeClr>
-          </a:lnRef>
-          <a:fillRef idx="1">
-            <a:schemeClr val="accent1"/>
-          </a:fillRef>
-          <a:effectRef idx="0">
-            <a:schemeClr val="accent1"/>
-          </a:effectRef>
-          <a:fontRef idx="minor">
-            <a:schemeClr val="lt1"/>
-          </a:fontRef>
-        </p:style>
-        <p:txBody>
-          <a:bodyPr rtlCol="0" anchor="ctr"/>
-          <a:lstStyle/>
-          <a:p>
-            <a:pPr algn="ctr"/>
-            <a:endParaRPr lang="en-US"/>
-          </a:p>
-        </p:txBody>
-      </p:sp>
-      <p:sp>
-        <p:nvSpPr>
-          <p:cNvPr id="15" name="Rectangle 14">
-            <a:extLst>
-              <a:ext uri="{FF2B5EF4-FFF2-40B4-BE49-F238E27FC236}">
-                <a16:creationId xmlns:a16="http://schemas.microsoft.com/office/drawing/2014/main" id="{3783CA14-24A1-485C-8B30-D6A5D87987AD}"/>
-              </a:ext>
-              <a:ext uri="{C183D7F6-B498-43B3-948B-1728B52AA6E4}">
-                <adec:decorative xmlns:adec="http://schemas.microsoft.com/office/drawing/2017/decorative" val="1"/>
-              </a:ext>
-            </a:extLst>
-          </p:cNvPr>
-          <p:cNvSpPr>
-            <a:spLocks noGrp="1" noRot="1" noChangeAspect="1" noMove="1" noResize="1" noEditPoints="1" noAdjustHandles="1" noChangeArrowheads="1" noChangeShapeType="1" noTextEdit="1"/>
-          </p:cNvSpPr>
-          <p:nvPr>
-            <p:extLst>
-              <p:ext uri="{386F3935-93C4-4BCD-93E2-E3B085C9AB24}">
-                <p16:designElem xmlns:p16="http://schemas.microsoft.com/office/powerpoint/2015/main" val="1"/>
-              </p:ext>
-            </p:extLst>
-          </p:nvPr>
-        </p:nvSpPr>
-        <p:spPr>
-          <a:xfrm rot="18900000" flipH="1">
-            <a:off x="10043482" y="655140"/>
-            <a:ext cx="687472" cy="687472"/>
-          </a:xfrm>
-          <a:prstGeom prst="rect">
-            <a:avLst/>
-          </a:prstGeom>
-          <a:solidFill>
-            <a:schemeClr val="accent4">
-              <a:alpha val="30000"/>
-            </a:schemeClr>
-          </a:solidFill>
-          <a:ln>
-            <a:noFill/>
-          </a:ln>
-        </p:spPr>
-        <p:style>
-          <a:lnRef idx="2">
-            <a:schemeClr val="accent1">
-              <a:shade val="50000"/>
-            </a:schemeClr>
-          </a:lnRef>
-          <a:fillRef idx="1">
-            <a:schemeClr val="accent1"/>
-          </a:fillRef>
-          <a:effectRef idx="0">
-            <a:schemeClr val="accent1"/>
-          </a:effectRef>
-          <a:fontRef idx="minor">
-            <a:schemeClr val="lt1"/>
-          </a:fontRef>
-        </p:style>
-        <p:txBody>
-          <a:bodyPr rtlCol="0" anchor="ctr"/>
-          <a:lstStyle/>
-          <a:p>
-            <a:pPr algn="ctr"/>
-            <a:endParaRPr lang="en-US"/>
-          </a:p>
-        </p:txBody>
-      </p:sp>
-      <p:sp>
-        <p:nvSpPr>
-          <p:cNvPr id="17" name="Freeform: Shape 16">
-            <a:extLst>
-              <a:ext uri="{FF2B5EF4-FFF2-40B4-BE49-F238E27FC236}">
-                <a16:creationId xmlns:a16="http://schemas.microsoft.com/office/drawing/2014/main" id="{9A97C86A-04D6-40F7-AE84-31AB43E6A846}"/>
-              </a:ext>
-              <a:ext uri="{C183D7F6-B498-43B3-948B-1728B52AA6E4}">
-                <adec:decorative xmlns:adec="http://schemas.microsoft.com/office/drawing/2017/decorative" val="1"/>
-              </a:ext>
-            </a:extLst>
-          </p:cNvPr>
-          <p:cNvSpPr>
-            <a:spLocks noGrp="1" noRot="1" noChangeAspect="1" noMove="1" noResize="1" noEditPoints="1" noAdjustHandles="1" noChangeArrowheads="1" noChangeShapeType="1" noTextEdit="1"/>
-          </p:cNvSpPr>
-          <p:nvPr>
-            <p:extLst>
-              <p:ext uri="{386F3935-93C4-4BCD-93E2-E3B085C9AB24}">
-                <p16:designElem xmlns:p16="http://schemas.microsoft.com/office/powerpoint/2015/main" val="1"/>
-              </p:ext>
-            </p:extLst>
-          </p:nvPr>
-        </p:nvSpPr>
-        <p:spPr>
-          <a:xfrm rot="10800000" flipH="1">
-            <a:off x="9356643" y="0"/>
-            <a:ext cx="2835357" cy="1480837"/>
-          </a:xfrm>
-          <a:custGeom>
-            <a:avLst/>
-            <a:gdLst>
-              <a:gd name="connsiteX0" fmla="*/ 2835357 w 2835357"/>
-              <a:gd name="connsiteY0" fmla="*/ 1480837 h 1480837"/>
-              <a:gd name="connsiteX1" fmla="*/ 0 w 2835357"/>
-              <a:gd name="connsiteY1" fmla="*/ 1480837 h 1480837"/>
-              <a:gd name="connsiteX2" fmla="*/ 1552727 w 2835357"/>
-              <a:gd name="connsiteY2" fmla="*/ 0 h 1480837"/>
-              <a:gd name="connsiteX3" fmla="*/ 2835357 w 2835357"/>
-              <a:gd name="connsiteY3" fmla="*/ 1223245 h 1480837"/>
-            </a:gdLst>
-            <a:ahLst/>
-            <a:cxnLst>
-              <a:cxn ang="0">
-                <a:pos x="connsiteX0" y="connsiteY0"/>
-              </a:cxn>
-              <a:cxn ang="0">
-                <a:pos x="connsiteX1" y="connsiteY1"/>
-              </a:cxn>
-              <a:cxn ang="0">
-                <a:pos x="connsiteX2" y="connsiteY2"/>
-              </a:cxn>
-              <a:cxn ang="0">
-                <a:pos x="connsiteX3" y="connsiteY3"/>
-              </a:cxn>
-            </a:cxnLst>
-            <a:rect l="l" t="t" r="r" b="b"/>
-            <a:pathLst>
-              <a:path w="2835357" h="1480837">
-                <a:moveTo>
-                  <a:pt x="2835357" y="1480837"/>
-                </a:moveTo>
-                <a:lnTo>
-                  <a:pt x="0" y="1480837"/>
-                </a:lnTo>
-                <a:lnTo>
-                  <a:pt x="1552727" y="0"/>
-                </a:lnTo>
-                <a:lnTo>
-                  <a:pt x="2835357" y="1223245"/>
-                </a:lnTo>
-                <a:close/>
-              </a:path>
-            </a:pathLst>
-          </a:custGeom>
-          <a:solidFill>
-            <a:schemeClr val="accent4">
-              <a:alpha val="30000"/>
-            </a:schemeClr>
-          </a:solidFill>
-          <a:ln>
-            <a:noFill/>
-          </a:ln>
-        </p:spPr>
-        <p:style>
-          <a:lnRef idx="2">
-            <a:schemeClr val="accent1">
-              <a:shade val="50000"/>
-            </a:schemeClr>
-          </a:lnRef>
-          <a:fillRef idx="1">
-            <a:schemeClr val="accent1"/>
-          </a:fillRef>
-          <a:effectRef idx="0">
-            <a:schemeClr val="accent1"/>
-          </a:effectRef>
-          <a:fontRef idx="minor">
-            <a:schemeClr val="lt1"/>
-          </a:fontRef>
-        </p:style>
-        <p:txBody>
-          <a:bodyPr wrap="square" rtlCol="0" anchor="ctr">
-            <a:noAutofit/>
-          </a:bodyPr>
-          <a:lstStyle/>
-          <a:p>
-            <a:pPr algn="ctr"/>
-            <a:endParaRPr lang="en-US" dirty="0"/>
-          </a:p>
-        </p:txBody>
-      </p:sp>
-      <p:sp>
-        <p:nvSpPr>
-          <p:cNvPr id="19" name="Isosceles Triangle 18">
-            <a:extLst>
-              <a:ext uri="{FF2B5EF4-FFF2-40B4-BE49-F238E27FC236}">
-                <a16:creationId xmlns:a16="http://schemas.microsoft.com/office/drawing/2014/main" id="{FF9F2414-84E8-453E-B1F3-389FDE8192D9}"/>
-              </a:ext>
-              <a:ext uri="{C183D7F6-B498-43B3-948B-1728B52AA6E4}">
-                <adec:decorative xmlns:adec="http://schemas.microsoft.com/office/drawing/2017/decorative" val="1"/>
-              </a:ext>
-            </a:extLst>
-          </p:cNvPr>
-          <p:cNvSpPr>
-            <a:spLocks noGrp="1" noRot="1" noChangeAspect="1" noMove="1" noResize="1" noEditPoints="1" noAdjustHandles="1" noChangeArrowheads="1" noChangeShapeType="1" noTextEdit="1"/>
-          </p:cNvSpPr>
-          <p:nvPr>
-            <p:extLst>
-              <p:ext uri="{386F3935-93C4-4BCD-93E2-E3B085C9AB24}">
-                <p16:designElem xmlns:p16="http://schemas.microsoft.com/office/powerpoint/2015/main" val="1"/>
-              </p:ext>
-            </p:extLst>
-          </p:nvPr>
-        </p:nvSpPr>
-        <p:spPr>
-          <a:xfrm flipH="1">
-            <a:off x="7976344" y="6115501"/>
-            <a:ext cx="1494513" cy="742499"/>
-          </a:xfrm>
-          <a:prstGeom prst="triangle">
-            <a:avLst/>
-          </a:prstGeom>
-          <a:solidFill>
-            <a:schemeClr val="accent1">
-              <a:alpha val="30000"/>
-            </a:schemeClr>
-          </a:solidFill>
-          <a:ln>
-            <a:noFill/>
-          </a:ln>
-        </p:spPr>
-        <p:style>
-          <a:lnRef idx="2">
-            <a:schemeClr val="accent1">
-              <a:shade val="50000"/>
-            </a:schemeClr>
-          </a:lnRef>
-          <a:fillRef idx="1">
-            <a:schemeClr val="accent1"/>
-          </a:fillRef>
-          <a:effectRef idx="0">
-            <a:schemeClr val="accent1"/>
-          </a:effectRef>
-          <a:fontRef idx="minor">
-            <a:schemeClr val="lt1"/>
-          </a:fontRef>
-        </p:style>
-        <p:txBody>
-          <a:bodyPr rtlCol="0" anchor="ctr"/>
-          <a:lstStyle/>
-          <a:p>
-            <a:pPr algn="ctr"/>
-            <a:endParaRPr lang="en-US"/>
-          </a:p>
-        </p:txBody>
-      </p:sp>
-      <p:sp>
-        <p:nvSpPr>
-          <p:cNvPr id="21" name="Isosceles Triangle 20">
-            <a:extLst>
-              <a:ext uri="{FF2B5EF4-FFF2-40B4-BE49-F238E27FC236}">
-                <a16:creationId xmlns:a16="http://schemas.microsoft.com/office/drawing/2014/main" id="{3ECA69A1-7536-43AC-85EF-C7106179F5ED}"/>
-              </a:ext>
-              <a:ext uri="{C183D7F6-B498-43B3-948B-1728B52AA6E4}">
-                <adec:decorative xmlns:adec="http://schemas.microsoft.com/office/drawing/2017/decorative" val="1"/>
-              </a:ext>
-            </a:extLst>
-          </p:cNvPr>
-          <p:cNvSpPr>
-            <a:spLocks noGrp="1" noRot="1" noChangeAspect="1" noMove="1" noResize="1" noEditPoints="1" noAdjustHandles="1" noChangeArrowheads="1" noChangeShapeType="1" noTextEdit="1"/>
-          </p:cNvSpPr>
-          <p:nvPr>
-            <p:extLst>
-              <p:ext uri="{386F3935-93C4-4BCD-93E2-E3B085C9AB24}">
-                <p16:designElem xmlns:p16="http://schemas.microsoft.com/office/powerpoint/2015/main" val="1"/>
-              </p:ext>
-            </p:extLst>
-          </p:nvPr>
-        </p:nvSpPr>
-        <p:spPr>
-          <a:xfrm flipH="1">
-            <a:off x="7604080" y="6453143"/>
-            <a:ext cx="814903" cy="404857"/>
-          </a:xfrm>
-          <a:prstGeom prst="triangle">
-            <a:avLst/>
-          </a:prstGeom>
-          <a:solidFill>
-            <a:schemeClr val="accent1">
-              <a:alpha val="30000"/>
-            </a:schemeClr>
-          </a:solidFill>
-          <a:ln>
-            <a:noFill/>
-          </a:ln>
-        </p:spPr>
-        <p:style>
-          <a:lnRef idx="2">
-            <a:schemeClr val="accent1">
-              <a:shade val="50000"/>
-            </a:schemeClr>
-          </a:lnRef>
-          <a:fillRef idx="1">
-            <a:schemeClr val="accent1"/>
-          </a:fillRef>
-          <a:effectRef idx="0">
-            <a:schemeClr val="accent1"/>
-          </a:effectRef>
-          <a:fontRef idx="minor">
-            <a:schemeClr val="lt1"/>
-          </a:fontRef>
-        </p:style>
-        <p:txBody>
-          <a:bodyPr rtlCol="0" anchor="ctr"/>
-          <a:lstStyle/>
-          <a:p>
-            <a:pPr algn="ctr"/>
-            <a:endParaRPr lang="en-US"/>
-          </a:p>
-        </p:txBody>
-      </p:sp>
-      <p:sp>
-        <p:nvSpPr>
-          <p:cNvPr id="6" name="TextBox 5">
-            <a:extLst>
-              <a:ext uri="{FF2B5EF4-FFF2-40B4-BE49-F238E27FC236}">
-                <a16:creationId xmlns:a16="http://schemas.microsoft.com/office/drawing/2014/main" id="{42F092D9-9422-7B90-2990-F9E8BCF32CF5}"/>
-              </a:ext>
-            </a:extLst>
-          </p:cNvPr>
-          <p:cNvSpPr txBox="1"/>
-          <p:nvPr/>
-        </p:nvSpPr>
-        <p:spPr>
-          <a:xfrm>
-            <a:off x="1320800" y="790533"/>
-            <a:ext cx="9664700" cy="1380506"/>
-          </a:xfrm>
-          <a:prstGeom prst="rect">
-            <a:avLst/>
-          </a:prstGeom>
-          <a:noFill/>
-        </p:spPr>
-        <p:txBody>
-          <a:bodyPr wrap="square">
-            <a:spAutoFit/>
-          </a:bodyPr>
-          <a:lstStyle/>
-          <a:p>
-            <a:pPr algn="ctr">
-              <a:lnSpc>
-                <a:spcPts val="5100"/>
-              </a:lnSpc>
-              <a:buNone/>
-            </a:pPr>
-            <a:r>
-              <a:rPr lang="en-US" sz="4000" b="0" i="0" dirty="0">
-                <a:solidFill>
-                  <a:schemeClr val="accent1"/>
-                </a:solidFill>
-                <a:effectLst/>
-                <a:latin typeface="Noto Sans JP Thin" panose="020B0200000000000000" pitchFamily="34" charset="-128"/>
-                <a:ea typeface="Noto Sans JP Thin" panose="020B0200000000000000" pitchFamily="34" charset="-128"/>
-              </a:rPr>
-              <a:t>A2C - The AI-powered CRM your</a:t>
-            </a:r>
-          </a:p>
-          <a:p>
-            <a:pPr algn="ctr">
-              <a:lnSpc>
-                <a:spcPts val="5100"/>
-              </a:lnSpc>
-              <a:buNone/>
-            </a:pPr>
-            <a:r>
-              <a:rPr lang="en-US" sz="4000" b="0" i="0" dirty="0">
-                <a:solidFill>
-                  <a:schemeClr val="accent1"/>
-                </a:solidFill>
-                <a:effectLst/>
-                <a:latin typeface="Noto Sans JP Thin" panose="020B0200000000000000" pitchFamily="34" charset="-128"/>
-                <a:ea typeface="Noto Sans JP Thin" panose="020B0200000000000000" pitchFamily="34" charset="-128"/>
-              </a:rPr>
-              <a:t>team will love</a:t>
-            </a:r>
-          </a:p>
-        </p:txBody>
-      </p:sp>
-      <p:sp>
-        <p:nvSpPr>
-          <p:cNvPr id="7" name="Rectangle: Rounded Corners 6">
-            <a:extLst>
-              <a:ext uri="{FF2B5EF4-FFF2-40B4-BE49-F238E27FC236}">
-                <a16:creationId xmlns:a16="http://schemas.microsoft.com/office/drawing/2014/main" id="{C767CE8A-427D-4583-6496-B8DEBD8EA1D2}"/>
-              </a:ext>
-            </a:extLst>
-          </p:cNvPr>
-          <p:cNvSpPr/>
-          <p:nvPr/>
-        </p:nvSpPr>
-        <p:spPr>
-          <a:xfrm>
-            <a:off x="2209800" y="3302000"/>
-            <a:ext cx="1765300" cy="1092200"/>
-          </a:xfrm>
-          <a:prstGeom prst="roundRect">
-            <a:avLst/>
-          </a:prstGeom>
-          <a:noFill/>
-          <a:ln w="9525"/>
-        </p:spPr>
-        <p:style>
-          <a:lnRef idx="2">
-            <a:schemeClr val="accent1">
-              <a:shade val="15000"/>
-            </a:schemeClr>
-          </a:lnRef>
-          <a:fillRef idx="1">
-            <a:schemeClr val="accent1"/>
-          </a:fillRef>
-          <a:effectRef idx="0">
-            <a:schemeClr val="accent1"/>
-          </a:effectRef>
-          <a:fontRef idx="minor">
-            <a:schemeClr val="lt1"/>
-          </a:fontRef>
-        </p:style>
-        <p:txBody>
-          <a:bodyPr rtlCol="0" anchor="ctr"/>
-          <a:lstStyle/>
-          <a:p>
-            <a:pPr algn="ctr"/>
-            <a:r>
-              <a:rPr lang="en-US" sz="2400" dirty="0">
-                <a:solidFill>
-                  <a:schemeClr val="tx2">
-                    <a:lumMod val="90000"/>
-                    <a:lumOff val="10000"/>
-                  </a:schemeClr>
-                </a:solidFill>
-                <a:latin typeface="Noto Sans JP Thin" panose="020B0200000000000000" pitchFamily="34" charset="-128"/>
-                <a:ea typeface="Noto Sans JP Thin" panose="020B0200000000000000" pitchFamily="34" charset="-128"/>
-              </a:rPr>
-              <a:t>Users</a:t>
-            </a:r>
-            <a:endParaRPr lang="en-IL" sz="2400" dirty="0">
-              <a:solidFill>
-                <a:schemeClr val="tx2">
-                  <a:lumMod val="90000"/>
-                  <a:lumOff val="10000"/>
-                </a:schemeClr>
-              </a:solidFill>
-              <a:latin typeface="Noto Sans JP Thin" panose="020B0200000000000000" pitchFamily="34" charset="-128"/>
-              <a:ea typeface="Noto Sans JP Thin" panose="020B0200000000000000" pitchFamily="34" charset="-128"/>
-            </a:endParaRPr>
-          </a:p>
-        </p:txBody>
-      </p:sp>
-      <p:sp>
-        <p:nvSpPr>
-          <p:cNvPr id="8" name="Rectangle: Rounded Corners 7">
-            <a:extLst>
-              <a:ext uri="{FF2B5EF4-FFF2-40B4-BE49-F238E27FC236}">
-                <a16:creationId xmlns:a16="http://schemas.microsoft.com/office/drawing/2014/main" id="{D7509843-A905-17A7-655D-9C99B0FA186B}"/>
-              </a:ext>
-            </a:extLst>
-          </p:cNvPr>
-          <p:cNvSpPr/>
-          <p:nvPr/>
-        </p:nvSpPr>
-        <p:spPr>
-          <a:xfrm>
-            <a:off x="4241800" y="3302000"/>
-            <a:ext cx="1765300" cy="1092200"/>
-          </a:xfrm>
-          <a:prstGeom prst="roundRect">
-            <a:avLst/>
-          </a:prstGeom>
-          <a:noFill/>
-          <a:ln w="9525"/>
-        </p:spPr>
-        <p:style>
-          <a:lnRef idx="2">
-            <a:schemeClr val="accent1">
-              <a:shade val="15000"/>
-            </a:schemeClr>
-          </a:lnRef>
-          <a:fillRef idx="1">
-            <a:schemeClr val="accent1"/>
-          </a:fillRef>
-          <a:effectRef idx="0">
-            <a:schemeClr val="accent1"/>
-          </a:effectRef>
-          <a:fontRef idx="minor">
-            <a:schemeClr val="lt1"/>
-          </a:fontRef>
-        </p:style>
-        <p:txBody>
-          <a:bodyPr rtlCol="0" anchor="ctr"/>
-          <a:lstStyle/>
-          <a:p>
-            <a:pPr algn="ctr"/>
-            <a:r>
-              <a:rPr lang="en-US" sz="2400" dirty="0">
-                <a:solidFill>
-                  <a:schemeClr val="tx2">
-                    <a:lumMod val="90000"/>
-                    <a:lumOff val="10000"/>
-                  </a:schemeClr>
-                </a:solidFill>
-                <a:latin typeface="Noto Sans JP Thin" panose="020B0200000000000000" pitchFamily="34" charset="-128"/>
-                <a:ea typeface="Noto Sans JP Thin" panose="020B0200000000000000" pitchFamily="34" charset="-128"/>
-              </a:rPr>
-              <a:t>Customers</a:t>
-            </a:r>
-            <a:endParaRPr lang="en-IL" sz="2400" dirty="0">
-              <a:solidFill>
-                <a:schemeClr val="tx2">
-                  <a:lumMod val="90000"/>
-                  <a:lumOff val="10000"/>
-                </a:schemeClr>
-              </a:solidFill>
-              <a:latin typeface="Noto Sans JP Thin" panose="020B0200000000000000" pitchFamily="34" charset="-128"/>
-              <a:ea typeface="Noto Sans JP Thin" panose="020B0200000000000000" pitchFamily="34" charset="-128"/>
-            </a:endParaRPr>
-          </a:p>
-        </p:txBody>
-      </p:sp>
-      <p:sp>
-        <p:nvSpPr>
-          <p:cNvPr id="10" name="Rectangle: Rounded Corners 9">
-            <a:extLst>
-              <a:ext uri="{FF2B5EF4-FFF2-40B4-BE49-F238E27FC236}">
-                <a16:creationId xmlns:a16="http://schemas.microsoft.com/office/drawing/2014/main" id="{64F46349-61F2-626D-CD12-DE9047C4A70B}"/>
-              </a:ext>
-            </a:extLst>
-          </p:cNvPr>
-          <p:cNvSpPr/>
-          <p:nvPr/>
-        </p:nvSpPr>
-        <p:spPr>
-          <a:xfrm>
-            <a:off x="6273800" y="3302000"/>
-            <a:ext cx="1765300" cy="1092200"/>
-          </a:xfrm>
-          <a:prstGeom prst="roundRect">
-            <a:avLst/>
-          </a:prstGeom>
-          <a:noFill/>
-          <a:ln w="9525"/>
-        </p:spPr>
-        <p:style>
-          <a:lnRef idx="2">
-            <a:schemeClr val="accent1">
-              <a:shade val="15000"/>
-            </a:schemeClr>
-          </a:lnRef>
-          <a:fillRef idx="1">
-            <a:schemeClr val="accent1"/>
-          </a:fillRef>
-          <a:effectRef idx="0">
-            <a:schemeClr val="accent1"/>
-          </a:effectRef>
-          <a:fontRef idx="minor">
-            <a:schemeClr val="lt1"/>
-          </a:fontRef>
-        </p:style>
-        <p:txBody>
-          <a:bodyPr rtlCol="0" anchor="ctr"/>
-          <a:lstStyle/>
-          <a:p>
-            <a:pPr algn="ctr"/>
-            <a:r>
-              <a:rPr lang="en-US" sz="2400" dirty="0">
-                <a:solidFill>
-                  <a:schemeClr val="tx2">
-                    <a:lumMod val="90000"/>
-                    <a:lumOff val="10000"/>
-                  </a:schemeClr>
-                </a:solidFill>
-                <a:latin typeface="Noto Sans JP Thin" panose="020B0200000000000000" pitchFamily="34" charset="-128"/>
-                <a:ea typeface="Noto Sans JP Thin" panose="020B0200000000000000" pitchFamily="34" charset="-128"/>
-              </a:rPr>
-              <a:t>Products</a:t>
-            </a:r>
-            <a:endParaRPr lang="en-IL" sz="2400" dirty="0">
-              <a:solidFill>
-                <a:schemeClr val="tx2">
-                  <a:lumMod val="90000"/>
-                  <a:lumOff val="10000"/>
-                </a:schemeClr>
-              </a:solidFill>
-              <a:latin typeface="Noto Sans JP Thin" panose="020B0200000000000000" pitchFamily="34" charset="-128"/>
-              <a:ea typeface="Noto Sans JP Thin" panose="020B0200000000000000" pitchFamily="34" charset="-128"/>
-            </a:endParaRPr>
-          </a:p>
-        </p:txBody>
-      </p:sp>
-      <p:sp>
-        <p:nvSpPr>
-          <p:cNvPr id="12" name="Rectangle: Rounded Corners 11">
-            <a:extLst>
-              <a:ext uri="{FF2B5EF4-FFF2-40B4-BE49-F238E27FC236}">
-                <a16:creationId xmlns:a16="http://schemas.microsoft.com/office/drawing/2014/main" id="{999A1FC8-BEDD-F84A-0ABA-26C252BCE846}"/>
-              </a:ext>
-            </a:extLst>
-          </p:cNvPr>
-          <p:cNvSpPr/>
-          <p:nvPr/>
-        </p:nvSpPr>
-        <p:spPr>
-          <a:xfrm>
-            <a:off x="8305800" y="3302000"/>
-            <a:ext cx="1765300" cy="1092200"/>
-          </a:xfrm>
-          <a:prstGeom prst="roundRect">
-            <a:avLst/>
-          </a:prstGeom>
-          <a:noFill/>
-          <a:ln w="9525"/>
-        </p:spPr>
-        <p:style>
-          <a:lnRef idx="2">
-            <a:schemeClr val="accent1">
-              <a:shade val="15000"/>
-            </a:schemeClr>
-          </a:lnRef>
-          <a:fillRef idx="1">
-            <a:schemeClr val="accent1"/>
-          </a:fillRef>
-          <a:effectRef idx="0">
-            <a:schemeClr val="accent1"/>
-          </a:effectRef>
-          <a:fontRef idx="minor">
-            <a:schemeClr val="lt1"/>
-          </a:fontRef>
-        </p:style>
-        <p:txBody>
-          <a:bodyPr rtlCol="0" anchor="ctr"/>
-          <a:lstStyle/>
-          <a:p>
-            <a:pPr algn="ctr"/>
-            <a:r>
-              <a:rPr lang="en-US" sz="2400" dirty="0">
-                <a:solidFill>
-                  <a:schemeClr val="tx2">
-                    <a:lumMod val="90000"/>
-                    <a:lumOff val="10000"/>
-                  </a:schemeClr>
-                </a:solidFill>
-                <a:latin typeface="Noto Sans JP Thin" panose="020B0200000000000000" pitchFamily="34" charset="-128"/>
-                <a:ea typeface="Noto Sans JP Thin" panose="020B0200000000000000" pitchFamily="34" charset="-128"/>
-              </a:rPr>
-              <a:t>Orders</a:t>
-            </a:r>
-            <a:endParaRPr lang="en-IL" sz="2400" dirty="0">
-              <a:solidFill>
-                <a:schemeClr val="tx2">
-                  <a:lumMod val="90000"/>
-                  <a:lumOff val="10000"/>
-                </a:schemeClr>
-              </a:solidFill>
-              <a:latin typeface="Noto Sans JP Thin" panose="020B0200000000000000" pitchFamily="34" charset="-128"/>
-              <a:ea typeface="Noto Sans JP Thin" panose="020B0200000000000000" pitchFamily="34" charset="-128"/>
-            </a:endParaRPr>
-          </a:p>
-        </p:txBody>
-      </p:sp>
-    </p:spTree>
-    <p:extLst>
-      <p:ext uri="{BB962C8B-B14F-4D97-AF65-F5344CB8AC3E}">
-        <p14:creationId xmlns:p14="http://schemas.microsoft.com/office/powerpoint/2010/main" val="1299460525"/>
-      </p:ext>
-    </p:extLst>
-  </p:cSld>
-  <p:clrMapOvr>
-    <a:masterClrMapping/>
-  </p:clrMapOvr>
-</p:sld>
-</file>
-
-<file path=ppt/slides/slide6.xml><?xml version="1.0" encoding="utf-8"?>
-<p:sld xmlns:a="http://schemas.openxmlformats.org/drawingml/2006/main" xmlns:r="http://schemas.openxmlformats.org/officeDocument/2006/relationships" xmlns:p="http://schemas.openxmlformats.org/presentationml/2006/main">
-  <p:cSld>
     <p:spTree>
       <p:nvGrpSpPr>
         <p:cNvPr id="1" name=""/>
@@ -12189,6 +11255,72 @@
 </p:sld>
 </file>
 
+<file path=ppt/slides/slide6.xml><?xml version="1.0" encoding="utf-8"?>
+<p:sld xmlns:a="http://schemas.openxmlformats.org/drawingml/2006/main" xmlns:r="http://schemas.openxmlformats.org/officeDocument/2006/relationships" xmlns:p="http://schemas.openxmlformats.org/presentationml/2006/main">
+  <p:cSld>
+    <p:spTree>
+      <p:nvGrpSpPr>
+        <p:cNvPr id="1" name=""/>
+        <p:cNvGrpSpPr/>
+        <p:nvPr/>
+      </p:nvGrpSpPr>
+      <p:grpSpPr>
+        <a:xfrm>
+          <a:off x="0" y="0"/>
+          <a:ext cx="0" cy="0"/>
+          <a:chOff x="0" y="0"/>
+          <a:chExt cx="0" cy="0"/>
+        </a:xfrm>
+      </p:grpSpPr>
+      <p:pic>
+        <p:nvPicPr>
+          <p:cNvPr id="3" name="Picture 2">
+            <a:extLst>
+              <a:ext uri="{FF2B5EF4-FFF2-40B4-BE49-F238E27FC236}">
+                <a16:creationId xmlns:a16="http://schemas.microsoft.com/office/drawing/2014/main" id="{F89B5F49-256A-91EB-7D48-6A8A5D0F64CC}"/>
+              </a:ext>
+            </a:extLst>
+          </p:cNvPr>
+          <p:cNvPicPr>
+            <a:picLocks noChangeAspect="1"/>
+          </p:cNvPicPr>
+          <p:nvPr/>
+        </p:nvPicPr>
+        <p:blipFill>
+          <a:blip r:embed="rId2"/>
+          <a:stretch>
+            <a:fillRect/>
+          </a:stretch>
+        </p:blipFill>
+        <p:spPr>
+          <a:xfrm>
+            <a:off x="1162641" y="595236"/>
+            <a:ext cx="9429160" cy="5667527"/>
+          </a:xfrm>
+          <a:prstGeom prst="rect">
+            <a:avLst/>
+          </a:prstGeom>
+          <a:noFill/>
+          <a:ln>
+            <a:solidFill>
+              <a:schemeClr val="accent1"/>
+            </a:solidFill>
+          </a:ln>
+        </p:spPr>
+      </p:pic>
+    </p:spTree>
+    <p:extLst>
+      <p:ext uri="{BB962C8B-B14F-4D97-AF65-F5344CB8AC3E}">
+        <p14:creationId xmlns:p14="http://schemas.microsoft.com/office/powerpoint/2010/main" val="3443422260"/>
+      </p:ext>
+    </p:extLst>
+  </p:cSld>
+  <p:clrMapOvr>
+    <a:masterClrMapping/>
+  </p:clrMapOvr>
+</p:sld>
+</file>
+
 <file path=ppt/slides/slide7.xml><?xml version="1.0" encoding="utf-8"?>
 <p:sld xmlns:a="http://schemas.openxmlformats.org/drawingml/2006/main" xmlns:r="http://schemas.openxmlformats.org/officeDocument/2006/relationships" xmlns:p="http://schemas.openxmlformats.org/presentationml/2006/main">
   <p:cSld>
@@ -12206,6 +11338,41 @@
           <a:chExt cx="0" cy="0"/>
         </a:xfrm>
       </p:grpSpPr>
+      <p:pic>
+        <p:nvPicPr>
+          <p:cNvPr id="3" name="Picture 2">
+            <a:extLst>
+              <a:ext uri="{FF2B5EF4-FFF2-40B4-BE49-F238E27FC236}">
+                <a16:creationId xmlns:a16="http://schemas.microsoft.com/office/drawing/2014/main" id="{62EF3622-3E09-1582-E7C7-C93D2F126BBE}"/>
+              </a:ext>
+            </a:extLst>
+          </p:cNvPr>
+          <p:cNvPicPr>
+            <a:picLocks noChangeAspect="1"/>
+          </p:cNvPicPr>
+          <p:nvPr/>
+        </p:nvPicPr>
+        <p:blipFill>
+          <a:blip r:embed="rId2"/>
+          <a:stretch>
+            <a:fillRect/>
+          </a:stretch>
+        </p:blipFill>
+        <p:spPr>
+          <a:xfrm>
+            <a:off x="680936" y="1731524"/>
+            <a:ext cx="10542591" cy="2340962"/>
+          </a:xfrm>
+          <a:prstGeom prst="rect">
+            <a:avLst/>
+          </a:prstGeom>
+          <a:ln>
+            <a:solidFill>
+              <a:schemeClr val="accent1"/>
+            </a:solidFill>
+          </a:ln>
+        </p:spPr>
+      </p:pic>
     </p:spTree>
     <p:extLst>
       <p:ext uri="{BB962C8B-B14F-4D97-AF65-F5344CB8AC3E}">

</xml_diff>